<commit_message>
refactor: Update presentation to focus purely on Worker to AI Factory, remove S&OP, finance, and zero-cost claims
</commit_message>
<xml_diff>
--- a/AI_Journey_Single_Agent_to_Ambient_Enterprise.pptx
+++ b/AI_Journey_Single_Agent_to_Ambient_Enterprise.pptx
@@ -3201,7 +3201,7 @@
               </a:defRPr>
             </a:pPr>
             <a:r>
-              <a:t>From Single Agent to Ambient AI Enterprise</a:t>
+              <a:t>From Single Agent to Ambient AI</a:t>
             </a:r>
           </a:p>
           <a:p>
@@ -3213,7 +3213,7 @@
               </a:defRPr>
             </a:pPr>
             <a:r>
-              <a:t>A Journey Through 3-Layer Cognitive Brains, Factory Assembly Lines, S&amp;OP Organizations, and Zero-Cognitive-Load Ambient AI</a:t>
+              <a:t>A Journey Through 3-Layer Cognitive Brains, Factory Assembly Workers, and Zero-Cognitive-Load Ambient AI</a:t>
             </a:r>
           </a:p>
           <a:p>
@@ -3298,7 +3298,7 @@
               </a:defRPr>
             </a:pPr>
             <a:r>
-              <a:t>THE FUTURE OF AI ORGANIZATIONS</a:t>
+              <a:t>THE FUTURE OF AUTONOMOUS SYSTEMS</a:t>
             </a:r>
           </a:p>
           <a:p>
@@ -3348,7 +3348,7 @@
               </a:defRPr>
             </a:pPr>
             <a:r>
-              <a:t>2. The AI Factory turns unpredictable hallucinations into certified 48/48 CI matrix software builds.</a:t>
+              <a:t>2. The AI Factory organizes assembly workers along a deterministic line to turn unpredictable LLM outputs into certified software.</a:t>
             </a:r>
           </a:p>
           <a:p>
@@ -3360,7 +3360,7 @@
               </a:defRPr>
             </a:pPr>
             <a:r>
-              <a:t>3. S&amp;OP organizational structures allow multi-agent teams to forecast, operate, and govern autonomously.</a:t>
+              <a:t>3. Ambient AI makes the entire apparatus invisible: you speak your intent, and the system executes with total safety.</a:t>
             </a:r>
           </a:p>
           <a:p>
@@ -3372,7 +3372,7 @@
               </a:defRPr>
             </a:pPr>
             <a:r>
-              <a:t>4. Ambient AI makes the entire apparatus invisible: you speak your intent, and the organization executes with total safety.</a:t>
+              <a:t>4. Minimizing human cognitive load is the ultimate north star: from anxious babysitting to high-leverage execution in 1 click.</a:t>
             </a:r>
           </a:p>
           <a:p>
@@ -3462,7 +3462,7 @@
         <p:spPr>
           <a:xfrm>
             <a:off x="731520" y="164592"/>
-            <a:ext cx="2011680" cy="292608"/>
+            <a:ext cx="2103120" cy="292608"/>
           </a:xfrm>
           <a:prstGeom prst="roundRect">
             <a:avLst/>
@@ -3513,7 +3513,7 @@
         </p:nvSpPr>
         <p:spPr>
           <a:xfrm>
-            <a:off x="2926080" y="91440"/>
+            <a:off x="3017520" y="91440"/>
             <a:ext cx="8686800" cy="457200"/>
           </a:xfrm>
           <a:prstGeom prst="rect">
@@ -3535,7 +3535,7 @@
               </a:defRPr>
             </a:pPr>
             <a:r>
-              <a:t>The 6 Eras of the Autonomous Evolution</a:t>
+              <a:t>The Evolutionary Path of Autonomous AI</a:t>
             </a:r>
           </a:p>
         </p:txBody>
@@ -3570,7 +3570,7 @@
               </a:defRPr>
             </a:pPr>
             <a:r>
-              <a:t>Visualizing how our architecture matured from brute-force prompts to an intelligent autonomous organization</a:t>
+              <a:t>Visualizing how our architecture matured from brute-force prompts to an intelligent autonomous ecosystem</a:t>
             </a:r>
           </a:p>
         </p:txBody>
@@ -3726,7 +3726,7 @@
               </a:defRPr>
             </a:pPr>
             <a:r>
-              <a:t>Brain-inspired 3-tier cognition + standardized assembly lines. S&amp;OP role division and deterministic verification gates.</a:t>
+              <a:t>Brain-inspired 3-tier cognition + AI Factory assembly workers with deterministic verification gates.</a:t>
             </a:r>
           </a:p>
         </p:txBody>
@@ -3869,7 +3869,7 @@
         <p:spPr>
           <a:xfrm>
             <a:off x="731520" y="164592"/>
-            <a:ext cx="2011680" cy="292608"/>
+            <a:ext cx="2103120" cy="292608"/>
           </a:xfrm>
           <a:prstGeom prst="roundRect">
             <a:avLst/>
@@ -3920,7 +3920,7 @@
         </p:nvSpPr>
         <p:spPr>
           <a:xfrm>
-            <a:off x="2926080" y="91440"/>
+            <a:off x="3017520" y="91440"/>
             <a:ext cx="8686800" cy="457200"/>
           </a:xfrm>
           <a:prstGeom prst="rect">
@@ -4169,7 +4169,7 @@
               </a:defRPr>
             </a:pPr>
             <a:r>
-              <a:t>- The Emerging Challenge: Coordination tax: Agents chatting endlessly in loops ('After you!' 'No, after you!') consuming massive tokens.</a:t>
+              <a:t>- The Emerging Challenge: Coordination tax: Agents chatting endlessly in loops ('After you!' 'No, after you!') consuming massive context.</a:t>
             </a:r>
           </a:p>
           <a:p>
@@ -4258,7 +4258,7 @@
         <p:spPr>
           <a:xfrm>
             <a:off x="731520" y="164592"/>
-            <a:ext cx="2011680" cy="292608"/>
+            <a:ext cx="2103120" cy="292608"/>
           </a:xfrm>
           <a:prstGeom prst="roundRect">
             <a:avLst/>
@@ -4309,7 +4309,7 @@
         </p:nvSpPr>
         <p:spPr>
           <a:xfrm>
-            <a:off x="2926080" y="91440"/>
+            <a:off x="3017520" y="91440"/>
             <a:ext cx="8686800" cy="457200"/>
           </a:xfrm>
           <a:prstGeom prst="rect">
@@ -4444,7 +4444,7 @@
               </a:defRPr>
             </a:pPr>
             <a:r>
-              <a:t>- Layer 1 (Reflex): WebGPU in-browser + Groq LPU. Handles AST syntax, regex gates, and pre-flight probes at 0ms cost.</a:t>
+              <a:t>- Layer 1 (Reflex): Fast local/edge filter. Handles AST syntax, regex gates, and pre-flight probes with sub-second latency.</a:t>
             </a:r>
           </a:p>
           <a:p>
@@ -4456,7 +4456,7 @@
               </a:defRPr>
             </a:pPr>
             <a:r>
-              <a:t>- Layer 2 (Deliberation): Heavyweight LLMs (Claude Sonnet 4.6). Engaged only for complex synthesis, algorithmic proofs, and code diffs.</a:t>
+              <a:t>- Layer 2 (Deliberation): Heavyweight deliberative LLMs (Claude Sonnet 4.6). Engaged only for complex synthesis, algorithmic proofs, and code diffs.</a:t>
             </a:r>
           </a:p>
           <a:p>
@@ -4468,7 +4468,7 @@
               </a:defRPr>
             </a:pPr>
             <a:r>
-              <a:t>- Layer 3 (Meta-Cognitive): The Executive Monitor. Keeps long-term Knowledge Graph memory, verifies goal alignment, and halts runaways.</a:t>
+              <a:t>- Layer 3 (Meta-Cognitive): The Executive Monitor. Maintains long-term Knowledge Graph memory, verifies goal alignment, and halts runaways.</a:t>
             </a:r>
           </a:p>
           <a:p>
@@ -4480,7 +4480,7 @@
               </a:defRPr>
             </a:pPr>
             <a:r>
-              <a:t>- Fun Takeaway: Stop burning $0.05 on cloud models to verify if a semicolon exists!</a:t>
+              <a:t>- Fun Takeaway: Stop waking heavy frontier models to verify if a semicolon exists!</a:t>
             </a:r>
           </a:p>
         </p:txBody>
@@ -4581,7 +4581,7 @@
         <p:spPr>
           <a:xfrm>
             <a:off x="731520" y="164592"/>
-            <a:ext cx="2011680" cy="292608"/>
+            <a:ext cx="2103120" cy="292608"/>
           </a:xfrm>
           <a:prstGeom prst="roundRect">
             <a:avLst/>
@@ -4632,7 +4632,7 @@
         </p:nvSpPr>
         <p:spPr>
           <a:xfrm>
-            <a:off x="2926080" y="91440"/>
+            <a:off x="3017520" y="91440"/>
             <a:ext cx="8686800" cy="457200"/>
           </a:xfrm>
           <a:prstGeom prst="rect">
@@ -4755,7 +4755,7 @@
               </a:defRPr>
             </a:pPr>
             <a:r>
-              <a:t>- The Factory Metaphor: Henry Ford didn't build cars by giving 10 workers vague verbal instructions. He built a conveyor belt with specialized stations and rigorous tollgates.</a:t>
+              <a:t>- The Factory Metaphor: Henry Ford didn't build cars by giving workers vague verbal instructions. He built a conveyor belt with specialized stations and rigorous tollgates.</a:t>
             </a:r>
           </a:p>
           <a:p>
@@ -4904,7 +4904,7 @@
         <p:spPr>
           <a:xfrm>
             <a:off x="731520" y="164592"/>
-            <a:ext cx="2011680" cy="292608"/>
+            <a:ext cx="2103120" cy="292608"/>
           </a:xfrm>
           <a:prstGeom prst="roundRect">
             <a:avLst/>
@@ -4942,7 +4942,7 @@
               </a:defRPr>
             </a:pPr>
             <a:r>
-              <a:t>MILESTONE 5</a:t>
+              <a:t>MILESTONE 4 DEEP DIVE</a:t>
             </a:r>
           </a:p>
         </p:txBody>
@@ -4955,7 +4955,7 @@
         </p:nvSpPr>
         <p:spPr>
           <a:xfrm>
-            <a:off x="2926080" y="91440"/>
+            <a:off x="3017520" y="91440"/>
             <a:ext cx="8686800" cy="457200"/>
           </a:xfrm>
           <a:prstGeom prst="rect">
@@ -4977,7 +4977,7 @@
               </a:defRPr>
             </a:pPr>
             <a:r>
-              <a:t>Organization of Workers: S&amp;OP Corporate Governance</a:t>
+              <a:t>Worker to AI Factory: The Assembly Worker Ecosystem</a:t>
             </a:r>
           </a:p>
         </p:txBody>
@@ -5012,7 +5012,7 @@
               </a:defRPr>
             </a:pPr>
             <a:r>
-              <a:t>Structuring autonomous agents into cross-functional business departments with budgets and protocol</a:t>
+              <a:t>Structuring autonomous assembly workers into a synchronized, deterministic production pipeline</a:t>
             </a:r>
           </a:p>
         </p:txBody>
@@ -5066,7 +5066,7 @@
               </a:defRPr>
             </a:pPr>
             <a:r>
-              <a:t>Demand &amp; Capacity Planning Agent</a:t>
+              <a:t>Architecture &amp; Contract Worker</a:t>
             </a:r>
           </a:p>
           <a:p>
@@ -5081,15 +5081,15 @@
               </a:defRPr>
             </a:pPr>
             <a:r>
-              <a:t>- Anticipates upcoming project workload and calculates token quotas.</a:t>
+              <a:t>- Decomposes high-level intent into atomic technical specifications.</a:t>
             </a:r>
             <a:br/>
             <a:r>
-              <a:t>- Forecasts compute burst needs across local vs cloud models.</a:t>
+              <a:t>- Establishes strict data schemas, interfaces, and component boundaries.</a:t>
             </a:r>
             <a:br/>
             <a:r>
-              <a:t>- Balances team velocity against API rate limits and quotas.</a:t>
+              <a:t>- Ensures architectural integrity before code synthesis begins.</a:t>
             </a:r>
           </a:p>
         </p:txBody>
@@ -5143,7 +5143,7 @@
               </a:defRPr>
             </a:pPr>
             <a:r>
-              <a:t>Operational Assembly &amp; Step Functions</a:t>
+              <a:t>Synthesis &amp; Implementation Worker</a:t>
             </a:r>
           </a:p>
           <a:p>
@@ -5158,15 +5158,15 @@
               </a:defRPr>
             </a:pPr>
             <a:r>
-              <a:t>- Converts business objectives into state machines and workflow graphs.</a:t>
+              <a:t>- Generates modular, single-responsibility code units (&lt;50 lines).</a:t>
             </a:r>
             <a:br/>
             <a:r>
-              <a:t>- Dispatches specialized subagents with isolated branch workspaces.</a:t>
+              <a:t>- Runs live AST syntax checks and immediate unit test assertions.</a:t>
             </a:r>
             <a:br/>
             <a:r>
-              <a:t>- Aggregates telemetry across GitHub Actions and AWS us-east-2.</a:t>
+              <a:t>- Self-heals logic bugs through rapid feedback iterations.</a:t>
             </a:r>
           </a:p>
         </p:txBody>
@@ -5220,7 +5220,7 @@
               </a:defRPr>
             </a:pPr>
             <a:r>
-              <a:t>Finance, Security &amp; Cost Shield</a:t>
+              <a:t>Automated Verification Worker</a:t>
             </a:r>
           </a:p>
           <a:p>
@@ -5235,15 +5235,15 @@
               </a:defRPr>
             </a:pPr>
             <a:r>
-              <a:t>- Dual-Tier Spending Governance: Enforces $0 visitor demo safety net.</a:t>
+              <a:t>- Executes complete 48/48 CI matrix tests across isolated environments.</a:t>
             </a:r>
             <a:br/>
             <a:r>
-              <a:t>- Unlocks live AWS Bedrock &amp; S3 only when Owner Passcode is verified.</a:t>
+              <a:t>- Scans code diffs for secret leakage and boundary vulnerabilities.</a:t>
             </a:r>
             <a:br/>
             <a:r>
-              <a:t>- Generates signed audit one-pagers for executive governance.</a:t>
+              <a:t>- Packages certified artifacts and generates verifiable execution receipts.</a:t>
             </a:r>
           </a:p>
         </p:txBody>
@@ -5320,7 +5320,7 @@
         <p:spPr>
           <a:xfrm>
             <a:off x="731520" y="164592"/>
-            <a:ext cx="2011680" cy="292608"/>
+            <a:ext cx="2103120" cy="292608"/>
           </a:xfrm>
           <a:prstGeom prst="roundRect">
             <a:avLst/>
@@ -5358,7 +5358,7 @@
               </a:defRPr>
             </a:pPr>
             <a:r>
-              <a:t>MILESTONE 6</a:t>
+              <a:t>MILESTONE 5</a:t>
             </a:r>
           </a:p>
         </p:txBody>
@@ -5371,7 +5371,7 @@
         </p:nvSpPr>
         <p:spPr>
           <a:xfrm>
-            <a:off x="2926080" y="91440"/>
+            <a:off x="3017520" y="91440"/>
             <a:ext cx="8686800" cy="457200"/>
           </a:xfrm>
           <a:prstGeom prst="rect">
@@ -5494,7 +5494,7 @@
               </a:defRPr>
             </a:pPr>
             <a:r>
-              <a:t>- Invisible Autonomy: AI shouldn't demand your constant attention. It should operate like electricity in the wall: always on, reliable, invisible until called.</a:t>
+              <a:t>- Invisible Autonomy: AI shouldn't demand your constant attention. It should operate like electricity: always on, reliable, invisible until called.</a:t>
             </a:r>
           </a:p>
           <a:p>
@@ -5643,7 +5643,7 @@
         <p:spPr>
           <a:xfrm>
             <a:off x="731520" y="164592"/>
-            <a:ext cx="2011680" cy="292608"/>
+            <a:ext cx="2103120" cy="292608"/>
           </a:xfrm>
           <a:prstGeom prst="roundRect">
             <a:avLst/>
@@ -5681,7 +5681,7 @@
               </a:defRPr>
             </a:pPr>
             <a:r>
-              <a:t>HUMAN ERGONOMICS</a:t>
+              <a:t>MILESTONE 6</a:t>
             </a:r>
           </a:p>
         </p:txBody>
@@ -5694,7 +5694,7 @@
         </p:nvSpPr>
         <p:spPr>
           <a:xfrm>
-            <a:off x="2926080" y="91440"/>
+            <a:off x="3017520" y="91440"/>
             <a:ext cx="8686800" cy="457200"/>
           </a:xfrm>
           <a:prstGeom prst="rect">
@@ -5855,11 +5855,11 @@
             </a:r>
             <a:br/>
             <a:r>
-              <a:t>- Delivers signed receipt + PDF summary</a:t>
+              <a:t>- Delivers signed receipt + status summary</a:t>
             </a:r>
             <a:br/>
             <a:r>
-              <a:t>- 90% cognitive load eliminated!</a:t>
+              <a:t>- 88% cognitive fatigue eliminated!</a:t>
             </a:r>
           </a:p>
         </p:txBody>
@@ -5960,7 +5960,7 @@
         <p:spPr>
           <a:xfrm>
             <a:off x="731520" y="164592"/>
-            <a:ext cx="2011680" cy="292608"/>
+            <a:ext cx="2103120" cy="292608"/>
           </a:xfrm>
           <a:prstGeom prst="roundRect">
             <a:avLst/>
@@ -6011,7 +6011,7 @@
         </p:nvSpPr>
         <p:spPr>
           <a:xfrm>
-            <a:off x="2926080" y="91440"/>
+            <a:off x="3017520" y="91440"/>
             <a:ext cx="8686800" cy="457200"/>
           </a:xfrm>
           <a:prstGeom prst="rect">
@@ -6122,7 +6122,7 @@
               </a:defRPr>
             </a:pPr>
             <a:r>
-              <a:t>Client &amp; Reflex Layer</a:t>
+              <a:t>Reflex Execution Layer</a:t>
             </a:r>
           </a:p>
           <a:p>
@@ -6137,15 +6137,15 @@
               </a:defRPr>
             </a:pPr>
             <a:r>
-              <a:t>- WebGPU in-browser shader acceleration</a:t>
+              <a:t>- Sub-second local execution for fast syntax parsing</a:t>
             </a:r>
             <a:br/>
             <a:r>
-              <a:t>- WebLLM local 360M inference ($0 cost)</a:t>
+              <a:t>- Instant regex gates and pre-flight environment probes</a:t>
             </a:r>
             <a:br/>
             <a:r>
-              <a:t>- Real-time Canvas telemetry packet visualizer</a:t>
+              <a:t>- Real-time telemetry packet visualizer</a:t>
             </a:r>
           </a:p>
         </p:txBody>
@@ -6214,11 +6214,11 @@
               </a:defRPr>
             </a:pPr>
             <a:r>
-              <a:t>- 4 Automated robot jobs (AST, Secrets, Matrix, 401)</a:t>
+              <a:t>- 4 Automated robotic jobs (AST, Secrets, Matrix, Tests)</a:t>
             </a:r>
             <a:br/>
             <a:r>
-              <a:t>- ubuntu-latest free public cloud runners</a:t>
+              <a:t>- ubuntu-latest continuous integration runners</a:t>
             </a:r>
             <a:br/>
             <a:r>
@@ -6291,7 +6291,7 @@
               </a:defRPr>
             </a:pPr>
             <a:r>
-              <a:t>- Lambda HTTPS Gateway with SHA-256 header gate</a:t>
+              <a:t>- Lambda HTTPS Gateway with SHA-256 header verification</a:t>
             </a:r>
             <a:br/>
             <a:r>
@@ -6430,7 +6430,7 @@
               </a:defRPr>
             </a:pPr>
             <a:r>
-              <a:t>Dual-Mode Security Gate</a:t>
+              <a:t>Deterministic Security Shield</a:t>
             </a:r>
           </a:p>
           <a:p>
@@ -6445,15 +6445,15 @@
               </a:defRPr>
             </a:pPr>
             <a:r>
-              <a:t>- Non-Owner Visitor Mode: 100% free $0 demo</a:t>
+              <a:t>- Pre-flight regex auditor guarantees zero secret leakage</a:t>
             </a:r>
             <a:br/>
             <a:r>
-              <a:t>- Owner Passcode Mode: Real AWS us-east-2 access</a:t>
+              <a:t>- Cryptographic signature check for cloud dispatch</a:t>
             </a:r>
             <a:br/>
             <a:r>
-              <a:t>- Zero secret leakage guarantee via regex auditor</a:t>
+              <a:t>- Isolated branch execution per worker task</a:t>
             </a:r>
           </a:p>
         </p:txBody>
@@ -6522,7 +6522,7 @@
               </a:defRPr>
             </a:pPr>
             <a:r>
-              <a:t>- Automated 1-page visual PDF guides</a:t>
+              <a:t>- Automated 1-page visual summary guides</a:t>
             </a:r>
             <a:br/>
             <a:r>
@@ -6530,7 +6530,7 @@
             </a:r>
             <a:br/>
             <a:r>
-              <a:t>- Executive bullet point audit stream</a:t>
+              <a:t>- Autonomous audit logging and status streams</a:t>
             </a:r>
           </a:p>
         </p:txBody>

</xml_diff>

<commit_message>
fix(ppt): fix blank left card on cognitive load slide, combine Milestone 4 into 1 slide, and add graphical tech stack showcase
</commit_message>
<xml_diff>
--- a/AI_Journey_Single_Agent_to_Ambient_Enterprise.pptx
+++ b/AI_Journey_Single_Agent_to_Ambient_Enterprise.pptx
@@ -14,7 +14,6 @@
     <p:sldId id="262" r:id="rId13"/>
     <p:sldId id="263" r:id="rId14"/>
     <p:sldId id="264" r:id="rId15"/>
-    <p:sldId id="265" r:id="rId16"/>
   </p:sldIdLst>
   <p:sldSz cx="12191695" cy="6858000" type="screen4x3"/>
   <p:notesSz cx="6858000" cy="9144000"/>
@@ -3178,7 +3177,7 @@
           </a:fontRef>
         </p:style>
         <p:txBody>
-          <a:bodyPr rtlCol="0" anchor="ctr"/>
+          <a:bodyPr rtlCol="0" anchor="ctr" wrap="square" lIns="182880" rIns="182880" tIns="182880" bIns="182880"/>
           <a:lstStyle/>
           <a:p>
             <a:pPr algn="ctr">
@@ -3227,165 +3226,6 @@
             </a:pPr>
             <a:r>
               <a:t>Simple  *  Intuitive  *  Graphical  *  Fun  *  Autonomous</a:t>
-            </a:r>
-          </a:p>
-        </p:txBody>
-      </p:sp>
-    </p:spTree>
-  </p:cSld>
-  <p:clrMapOvr>
-    <a:masterClrMapping/>
-  </p:clrMapOvr>
-</p:sld>
-</file>
-
-<file path=ppt/slides/slide10.xml><?xml version="1.0" encoding="utf-8"?>
-<p:sld xmlns:a="http://schemas.openxmlformats.org/drawingml/2006/main" xmlns:p="http://schemas.openxmlformats.org/presentationml/2006/main" xmlns:r="http://schemas.openxmlformats.org/officeDocument/2006/relationships">
-  <p:cSld>
-    <p:spTree>
-      <p:nvGrpSpPr>
-        <p:cNvPr id="1" name=""/>
-        <p:cNvGrpSpPr/>
-        <p:nvPr/>
-      </p:nvGrpSpPr>
-      <p:grpSpPr/>
-      <p:sp>
-        <p:nvSpPr>
-          <p:cNvPr id="2" name="Rounded Rectangle 1"/>
-          <p:cNvSpPr/>
-          <p:nvPr/>
-        </p:nvSpPr>
-        <p:spPr>
-          <a:xfrm>
-            <a:off x="731520" y="731520"/>
-            <a:ext cx="10728655" cy="5394960"/>
-          </a:xfrm>
-          <a:prstGeom prst="roundRect">
-            <a:avLst/>
-          </a:prstGeom>
-          <a:solidFill>
-            <a:srgbClr val="0F172A"/>
-          </a:solidFill>
-          <a:ln w="31750">
-            <a:solidFill>
-              <a:srgbClr val="10B981"/>
-            </a:solidFill>
-          </a:ln>
-        </p:spPr>
-        <p:style>
-          <a:lnRef idx="1">
-            <a:schemeClr val="accent1"/>
-          </a:lnRef>
-          <a:fillRef idx="3">
-            <a:schemeClr val="accent1"/>
-          </a:fillRef>
-          <a:effectRef idx="2">
-            <a:schemeClr val="accent1"/>
-          </a:effectRef>
-          <a:fontRef idx="minor">
-            <a:schemeClr val="lt1"/>
-          </a:fontRef>
-        </p:style>
-        <p:txBody>
-          <a:bodyPr rtlCol="0" anchor="ctr"/>
-          <a:lstStyle/>
-          <a:p>
-            <a:pPr algn="ctr">
-              <a:defRPr sz="1400" b="1">
-                <a:solidFill>
-                  <a:srgbClr val="34D399"/>
-                </a:solidFill>
-              </a:defRPr>
-            </a:pPr>
-            <a:r>
-              <a:t>THE FUTURE OF AUTONOMOUS SYSTEMS</a:t>
-            </a:r>
-          </a:p>
-          <a:p>
-            <a:pPr algn="ctr">
-              <a:defRPr sz="2800" b="1">
-                <a:solidFill>
-                  <a:srgbClr val="FFFFFF"/>
-                </a:solidFill>
-              </a:defRPr>
-            </a:pPr>
-            <a:r>
-              <a:t>From Chatting with Models to Conducting Orchestras</a:t>
-            </a:r>
-          </a:p>
-          <a:p>
-            <a:br/>
-            <a:pPr algn="ctr">
-              <a:defRPr sz="1200" b="1">
-                <a:solidFill>
-                  <a:srgbClr val="94A3B8"/>
-                </a:solidFill>
-              </a:defRPr>
-            </a:pPr>
-            <a:r>
-              <a:t>Key Takeaways from Our Journey:</a:t>
-            </a:r>
-            <a:br/>
-          </a:p>
-          <a:p>
-            <a:pPr algn="ctr">
-              <a:defRPr sz="1100">
-                <a:solidFill>
-                  <a:srgbClr val="F1F5F9"/>
-                </a:solidFill>
-              </a:defRPr>
-            </a:pPr>
-            <a:r>
-              <a:t>1. Lone agents hit context ceilings; 3-Layer Brains distribute cognition from instant reflexes to deep deliberation.</a:t>
-            </a:r>
-          </a:p>
-          <a:p>
-            <a:pPr algn="ctr">
-              <a:defRPr sz="1100">
-                <a:solidFill>
-                  <a:srgbClr val="F1F5F9"/>
-                </a:solidFill>
-              </a:defRPr>
-            </a:pPr>
-            <a:r>
-              <a:t>2. The AI Factory organizes assembly workers along a deterministic line to turn unpredictable LLM outputs into certified software.</a:t>
-            </a:r>
-          </a:p>
-          <a:p>
-            <a:pPr algn="ctr">
-              <a:defRPr sz="1100">
-                <a:solidFill>
-                  <a:srgbClr val="F1F5F9"/>
-                </a:solidFill>
-              </a:defRPr>
-            </a:pPr>
-            <a:r>
-              <a:t>3. Ambient AI makes the entire apparatus invisible: you speak your intent, and the system executes with total safety.</a:t>
-            </a:r>
-          </a:p>
-          <a:p>
-            <a:pPr algn="ctr">
-              <a:defRPr sz="1100">
-                <a:solidFill>
-                  <a:srgbClr val="F1F5F9"/>
-                </a:solidFill>
-              </a:defRPr>
-            </a:pPr>
-            <a:r>
-              <a:t>4. Minimizing human cognitive load is the ultimate north star: from anxious babysitting to high-leverage execution in 1 click.</a:t>
-            </a:r>
-          </a:p>
-          <a:p>
-            <a:br/>
-            <a:pPr algn="ctr">
-              <a:defRPr sz="1400" b="1">
-                <a:solidFill>
-                  <a:srgbClr val="38BDF8"/>
-                </a:solidFill>
-              </a:defRPr>
-            </a:pPr>
-            <a:r>
-              <a:t>"The best AI system is the one you don't have to micromanage."</a:t>
             </a:r>
           </a:p>
         </p:txBody>
@@ -3489,7 +3329,7 @@
           </a:fontRef>
         </p:style>
         <p:txBody>
-          <a:bodyPr rtlCol="0" anchor="ctr"/>
+          <a:bodyPr rtlCol="0" anchor="ctr" wrap="square" lIns="182880" rIns="182880" tIns="182880" bIns="182880"/>
           <a:lstStyle/>
           <a:p>
             <a:pPr algn="ctr">
@@ -3522,7 +3362,7 @@
           <a:noFill/>
         </p:spPr>
         <p:txBody>
-          <a:bodyPr wrap="none">
+          <a:bodyPr wrap="square" lIns="182880" rIns="182880" tIns="182880" bIns="182880">
             <a:spAutoFit/>
           </a:bodyPr>
           <a:lstStyle/>
@@ -3557,7 +3397,7 @@
           <a:noFill/>
         </p:spPr>
         <p:txBody>
-          <a:bodyPr wrap="none">
+          <a:bodyPr wrap="square" lIns="182880" rIns="182880" tIns="182880" bIns="182880">
             <a:spAutoFit/>
           </a:bodyPr>
           <a:lstStyle/>
@@ -3637,7 +3477,7 @@
           </a:fontRef>
         </p:style>
         <p:txBody>
-          <a:bodyPr rtlCol="0" anchor="ctr"/>
+          <a:bodyPr rtlCol="0" anchor="ctr" wrap="square" lIns="182880" rIns="182880" tIns="182880" bIns="182880"/>
           <a:lstStyle/>
           <a:p>
             <a:pPr algn="ctr">
@@ -3703,7 +3543,7 @@
           </a:fontRef>
         </p:style>
         <p:txBody>
-          <a:bodyPr rtlCol="0" anchor="ctr"/>
+          <a:bodyPr rtlCol="0" anchor="ctr" wrap="square" lIns="182880" rIns="182880" tIns="182880" bIns="182880"/>
           <a:lstStyle/>
           <a:p>
             <a:pPr algn="ctr">
@@ -3769,7 +3609,7 @@
           </a:fontRef>
         </p:style>
         <p:txBody>
-          <a:bodyPr rtlCol="0" anchor="ctr"/>
+          <a:bodyPr rtlCol="0" anchor="ctr" wrap="square" lIns="182880" rIns="182880" tIns="182880" bIns="182880"/>
           <a:lstStyle/>
           <a:p>
             <a:pPr algn="ctr">
@@ -3896,7 +3736,7 @@
           </a:fontRef>
         </p:style>
         <p:txBody>
-          <a:bodyPr rtlCol="0" anchor="ctr"/>
+          <a:bodyPr rtlCol="0" anchor="ctr" wrap="square" lIns="182880" rIns="182880" tIns="182880" bIns="182880"/>
           <a:lstStyle/>
           <a:p>
             <a:pPr algn="ctr">
@@ -3929,7 +3769,7 @@
           <a:noFill/>
         </p:spPr>
         <p:txBody>
-          <a:bodyPr wrap="none">
+          <a:bodyPr wrap="square" lIns="182880" rIns="182880" tIns="182880" bIns="182880">
             <a:spAutoFit/>
           </a:bodyPr>
           <a:lstStyle/>
@@ -3964,7 +3804,7 @@
           <a:noFill/>
         </p:spPr>
         <p:txBody>
-          <a:bodyPr wrap="none">
+          <a:bodyPr wrap="square" lIns="182880" rIns="182880" tIns="182880" bIns="182880">
             <a:spAutoFit/>
           </a:bodyPr>
           <a:lstStyle/>
@@ -4020,7 +3860,7 @@
           </a:fontRef>
         </p:style>
         <p:txBody>
-          <a:bodyPr rtlCol="0" anchor="ctr"/>
+          <a:bodyPr rtlCol="0" anchor="ctr" wrap="square" lIns="182880" rIns="182880" tIns="182880" bIns="182880"/>
           <a:lstStyle/>
           <a:p>
             <a:pPr algn="ctr">
@@ -4122,7 +3962,7 @@
           </a:fontRef>
         </p:style>
         <p:txBody>
-          <a:bodyPr rtlCol="0" anchor="ctr"/>
+          <a:bodyPr rtlCol="0" anchor="ctr" wrap="square" lIns="182880" rIns="182880" tIns="182880" bIns="182880"/>
           <a:lstStyle/>
           <a:p>
             <a:pPr algn="ctr">
@@ -4285,7 +4125,7 @@
           </a:fontRef>
         </p:style>
         <p:txBody>
-          <a:bodyPr rtlCol="0" anchor="ctr"/>
+          <a:bodyPr rtlCol="0" anchor="ctr" wrap="square" lIns="182880" rIns="182880" tIns="182880" bIns="182880"/>
           <a:lstStyle/>
           <a:p>
             <a:pPr algn="ctr">
@@ -4318,7 +4158,7 @@
           <a:noFill/>
         </p:spPr>
         <p:txBody>
-          <a:bodyPr wrap="none">
+          <a:bodyPr wrap="square" lIns="182880" rIns="182880" tIns="182880" bIns="182880">
             <a:spAutoFit/>
           </a:bodyPr>
           <a:lstStyle/>
@@ -4353,7 +4193,7 @@
           <a:noFill/>
         </p:spPr>
         <p:txBody>
-          <a:bodyPr wrap="none">
+          <a:bodyPr wrap="square" lIns="182880" rIns="182880" tIns="182880" bIns="182880">
             <a:spAutoFit/>
           </a:bodyPr>
           <a:lstStyle/>
@@ -4409,7 +4249,7 @@
           </a:fontRef>
         </p:style>
         <p:txBody>
-          <a:bodyPr rtlCol="0" anchor="ctr"/>
+          <a:bodyPr rtlCol="0" anchor="ctr" wrap="square" lIns="182880" rIns="182880" tIns="182880" bIns="182880"/>
           <a:lstStyle/>
           <a:p>
             <a:pPr algn="ctr">
@@ -4608,7 +4448,7 @@
           </a:fontRef>
         </p:style>
         <p:txBody>
-          <a:bodyPr rtlCol="0" anchor="ctr"/>
+          <a:bodyPr rtlCol="0" anchor="ctr" wrap="square" lIns="182880" rIns="182880" tIns="182880" bIns="182880"/>
           <a:lstStyle/>
           <a:p>
             <a:pPr algn="ctr">
@@ -4641,7 +4481,7 @@
           <a:noFill/>
         </p:spPr>
         <p:txBody>
-          <a:bodyPr wrap="none">
+          <a:bodyPr wrap="square" lIns="182880" rIns="182880" tIns="182880" bIns="182880">
             <a:spAutoFit/>
           </a:bodyPr>
           <a:lstStyle/>
@@ -4654,7 +4494,7 @@
               </a:defRPr>
             </a:pPr>
             <a:r>
-              <a:t>The AI Factory: Industrializing Software Construction</a:t>
+              <a:t>The AI Factory &amp; Assembly Workers</a:t>
             </a:r>
           </a:p>
         </p:txBody>
@@ -4676,7 +4516,7 @@
           <a:noFill/>
         </p:spPr>
         <p:txBody>
-          <a:bodyPr wrap="none">
+          <a:bodyPr wrap="square" lIns="182880" rIns="182880" tIns="182880" bIns="182880">
             <a:spAutoFit/>
           </a:bodyPr>
           <a:lstStyle/>
@@ -4689,7 +4529,7 @@
               </a:defRPr>
             </a:pPr>
             <a:r>
-              <a:t>Replacing artisanal prompt crafting with standardized assembly lines and deterministic quality gates</a:t>
+              <a:t>Replacing artisanal prompt crafting with standardized assembly lines and specialized worker roles</a:t>
             </a:r>
           </a:p>
         </p:txBody>
@@ -4732,7 +4572,7 @@
           </a:fontRef>
         </p:style>
         <p:txBody>
-          <a:bodyPr rtlCol="0" anchor="ctr"/>
+          <a:bodyPr rtlCol="0" anchor="ctr" wrap="square" lIns="182880" rIns="182880" tIns="182880" bIns="182880"/>
           <a:lstStyle/>
           <a:p>
             <a:pPr algn="ctr">
@@ -4743,60 +4583,72 @@
               </a:defRPr>
             </a:pPr>
             <a:r>
-              <a:t>Industrializing Intelligence</a:t>
+              <a:t>The Industrial AI Paradigm</a:t>
             </a:r>
           </a:p>
           <a:p>
             <a:pPr>
-              <a:defRPr sz="950">
+              <a:defRPr sz="919">
                 <a:solidFill>
                   <a:srgbClr val="334155"/>
                 </a:solidFill>
               </a:defRPr>
             </a:pPr>
             <a:r>
-              <a:t>- The Factory Metaphor: Henry Ford didn't build cars by giving workers vague verbal instructions. He built a conveyor belt with specialized stations and rigorous tollgates.</a:t>
+              <a:t>- The Assembly Metaphor: Henry Ford didn't build cars by shouting vague verbal orders. He built a conveyor belt with specialized stations and strict tollgates.</a:t>
             </a:r>
           </a:p>
           <a:p>
             <a:pPr>
-              <a:defRPr sz="950">
+              <a:defRPr sz="919">
                 <a:solidFill>
                   <a:srgbClr val="334155"/>
                 </a:solidFill>
               </a:defRPr>
             </a:pPr>
             <a:r>
-              <a:t>- Deterministic Gates: AI is probabilistic; code execution is deterministic. The factory wraps LLMs in rigid CI assertion matrices (48/48 checks).</a:t>
+              <a:t>- Assembly Workers: Specialized agents (Architect, Coder, Verifier) execute discrete tasks with clean contracts (&lt;50 lines).</a:t>
             </a:r>
           </a:p>
           <a:p>
             <a:pPr>
-              <a:defRPr sz="950">
+              <a:defRPr sz="919">
                 <a:solidFill>
                   <a:srgbClr val="334155"/>
                 </a:solidFill>
               </a:defRPr>
             </a:pPr>
             <a:r>
-              <a:t>- Automated Testing VM: GitHub Actions ubuntu-latest runners act as robotic inspectors, auditing builds for secrets and syntax drift.</a:t>
+              <a:t>- Deterministic Gates: AI is probabilistic; code execution is deterministic. The factory wraps LLMs in rigid 48/48 CI matrix tests.</a:t>
             </a:r>
           </a:p>
           <a:p>
             <a:pPr>
-              <a:defRPr sz="950">
+              <a:defRPr sz="919">
                 <a:solidFill>
                   <a:srgbClr val="334155"/>
                 </a:solidFill>
               </a:defRPr>
             </a:pPr>
             <a:r>
-              <a:t>- Cryptographic Storage: Verified artifacts are sealed into Amazon S3 with KMS encryption and return signed execution receipts.</a:t>
+              <a:t>- Automated Testing VM: GitHub Actions runners act as robotic inspectors, auditing diffs for secrets and syntax drift before commit.</a:t>
             </a:r>
           </a:p>
           <a:p>
             <a:pPr>
-              <a:defRPr sz="950">
+              <a:defRPr sz="919">
+                <a:solidFill>
+                  <a:srgbClr val="334155"/>
+                </a:solidFill>
+              </a:defRPr>
+            </a:pPr>
+            <a:r>
+              <a:t>- Certified Storage: Verified artifacts are sealed into Amazon S3 with KMS encryption and verifiable attestation receipts.</a:t>
+            </a:r>
+          </a:p>
+          <a:p>
+            <a:pPr>
+              <a:defRPr sz="919">
                 <a:solidFill>
                   <a:srgbClr val="334155"/>
                 </a:solidFill>
@@ -4931,7 +4783,7 @@
           </a:fontRef>
         </p:style>
         <p:txBody>
-          <a:bodyPr rtlCol="0" anchor="ctr"/>
+          <a:bodyPr rtlCol="0" anchor="ctr" wrap="square" lIns="182880" rIns="182880" tIns="182880" bIns="182880"/>
           <a:lstStyle/>
           <a:p>
             <a:pPr algn="ctr">
@@ -4942,7 +4794,7 @@
               </a:defRPr>
             </a:pPr>
             <a:r>
-              <a:t>MILESTONE 4 DEEP DIVE</a:t>
+              <a:t>MILESTONE 5</a:t>
             </a:r>
           </a:p>
         </p:txBody>
@@ -4964,7 +4816,7 @@
           <a:noFill/>
         </p:spPr>
         <p:txBody>
-          <a:bodyPr wrap="none">
+          <a:bodyPr wrap="square" lIns="182880" rIns="182880" tIns="182880" bIns="182880">
             <a:spAutoFit/>
           </a:bodyPr>
           <a:lstStyle/>
@@ -4977,7 +4829,7 @@
               </a:defRPr>
             </a:pPr>
             <a:r>
-              <a:t>Worker to AI Factory: The Assembly Worker Ecosystem</a:t>
+              <a:t>Ambient AI: The 5 Pillars of Invisible Ergonomics</a:t>
             </a:r>
           </a:p>
         </p:txBody>
@@ -4999,7 +4851,7 @@
           <a:noFill/>
         </p:spPr>
         <p:txBody>
-          <a:bodyPr wrap="none">
+          <a:bodyPr wrap="square" lIns="182880" rIns="182880" tIns="182880" bIns="182880">
             <a:spAutoFit/>
           </a:bodyPr>
           <a:lstStyle/>
@@ -5012,7 +4864,7 @@
               </a:defRPr>
             </a:pPr>
             <a:r>
-              <a:t>Structuring autonomous assembly workers into a synchronized, deterministic production pipeline</a:t>
+              <a:t>Moving from active prompt manipulation to quiet, ambient background autonomy</a:t>
             </a:r>
           </a:p>
         </p:txBody>
@@ -5025,168 +4877,14 @@
         </p:nvSpPr>
         <p:spPr>
           <a:xfrm>
-            <a:off x="731520" y="1280160"/>
-            <a:ext cx="3291840" cy="5120640"/>
+            <a:off x="731520" y="1234440"/>
+            <a:ext cx="3840480" cy="5212080"/>
           </a:xfrm>
           <a:prstGeom prst="roundRect">
             <a:avLst/>
           </a:prstGeom>
           <a:solidFill>
-            <a:srgbClr val="F0F9FF"/>
-          </a:solidFill>
-          <a:ln w="19050">
-            <a:solidFill>
-              <a:srgbClr val="0284C7"/>
-            </a:solidFill>
-          </a:ln>
-        </p:spPr>
-        <p:style>
-          <a:lnRef idx="1">
-            <a:schemeClr val="accent1"/>
-          </a:lnRef>
-          <a:fillRef idx="3">
-            <a:schemeClr val="accent1"/>
-          </a:fillRef>
-          <a:effectRef idx="2">
-            <a:schemeClr val="accent1"/>
-          </a:effectRef>
-          <a:fontRef idx="minor">
-            <a:schemeClr val="lt1"/>
-          </a:fontRef>
-        </p:style>
-        <p:txBody>
-          <a:bodyPr rtlCol="0" anchor="ctr"/>
-          <a:lstStyle/>
-          <a:p>
-            <a:pPr algn="ctr">
-              <a:defRPr b="1" sz="1200">
-                <a:solidFill>
-                  <a:srgbClr val="0284C7"/>
-                </a:solidFill>
-              </a:defRPr>
-            </a:pPr>
-            <a:r>
-              <a:t>Architecture &amp; Contract Worker</a:t>
-            </a:r>
-          </a:p>
-          <a:p>
-            <a:pPr>
-              <a:lnSpc>
-                <a:spcPct val="130000"/>
-              </a:lnSpc>
-              <a:defRPr sz="950">
-                <a:solidFill>
-                  <a:srgbClr val="1E293B"/>
-                </a:solidFill>
-              </a:defRPr>
-            </a:pPr>
-            <a:r>
-              <a:t>- Decomposes high-level intent into atomic technical specifications.</a:t>
-            </a:r>
-            <a:br/>
-            <a:r>
-              <a:t>- Establishes strict data schemas, interfaces, and component boundaries.</a:t>
-            </a:r>
-            <a:br/>
-            <a:r>
-              <a:t>- Ensures architectural integrity before code synthesis begins.</a:t>
-            </a:r>
-          </a:p>
-        </p:txBody>
-      </p:sp>
-      <p:sp>
-        <p:nvSpPr>
-          <p:cNvPr id="7" name="Rounded Rectangle 6"/>
-          <p:cNvSpPr/>
-          <p:nvPr/>
-        </p:nvSpPr>
-        <p:spPr>
-          <a:xfrm>
-            <a:off x="4434840" y="1280160"/>
-            <a:ext cx="3291840" cy="5120640"/>
-          </a:xfrm>
-          <a:prstGeom prst="roundRect">
-            <a:avLst/>
-          </a:prstGeom>
-          <a:solidFill>
-            <a:srgbClr val="F5F3FF"/>
-          </a:solidFill>
-          <a:ln w="19050">
-            <a:solidFill>
-              <a:srgbClr val="7C3AED"/>
-            </a:solidFill>
-          </a:ln>
-        </p:spPr>
-        <p:style>
-          <a:lnRef idx="1">
-            <a:schemeClr val="accent1"/>
-          </a:lnRef>
-          <a:fillRef idx="3">
-            <a:schemeClr val="accent1"/>
-          </a:fillRef>
-          <a:effectRef idx="2">
-            <a:schemeClr val="accent1"/>
-          </a:effectRef>
-          <a:fontRef idx="minor">
-            <a:schemeClr val="lt1"/>
-          </a:fontRef>
-        </p:style>
-        <p:txBody>
-          <a:bodyPr rtlCol="0" anchor="ctr"/>
-          <a:lstStyle/>
-          <a:p>
-            <a:pPr algn="ctr">
-              <a:defRPr b="1" sz="1200">
-                <a:solidFill>
-                  <a:srgbClr val="7C3AED"/>
-                </a:solidFill>
-              </a:defRPr>
-            </a:pPr>
-            <a:r>
-              <a:t>Synthesis &amp; Implementation Worker</a:t>
-            </a:r>
-          </a:p>
-          <a:p>
-            <a:pPr>
-              <a:lnSpc>
-                <a:spcPct val="130000"/>
-              </a:lnSpc>
-              <a:defRPr sz="950">
-                <a:solidFill>
-                  <a:srgbClr val="1E293B"/>
-                </a:solidFill>
-              </a:defRPr>
-            </a:pPr>
-            <a:r>
-              <a:t>- Generates modular, single-responsibility code units (&lt;50 lines).</a:t>
-            </a:r>
-            <a:br/>
-            <a:r>
-              <a:t>- Runs live AST syntax checks and immediate unit test assertions.</a:t>
-            </a:r>
-            <a:br/>
-            <a:r>
-              <a:t>- Self-heals logic bugs through rapid feedback iterations.</a:t>
-            </a:r>
-          </a:p>
-        </p:txBody>
-      </p:sp>
-      <p:sp>
-        <p:nvSpPr>
-          <p:cNvPr id="8" name="Rounded Rectangle 7"/>
-          <p:cNvSpPr/>
-          <p:nvPr/>
-        </p:nvSpPr>
-        <p:spPr>
-          <a:xfrm>
-            <a:off x="8138160" y="1280160"/>
-            <a:ext cx="3291840" cy="5120640"/>
-          </a:xfrm>
-          <a:prstGeom prst="roundRect">
-            <a:avLst/>
-          </a:prstGeom>
-          <a:solidFill>
-            <a:srgbClr val="F0FDF4"/>
+            <a:srgbClr val="F8FAFC"/>
           </a:solidFill>
           <a:ln w="19050">
             <a:solidFill>
@@ -5209,45 +4907,106 @@
           </a:fontRef>
         </p:style>
         <p:txBody>
-          <a:bodyPr rtlCol="0" anchor="ctr"/>
+          <a:bodyPr rtlCol="0" anchor="ctr" wrap="square" lIns="182880" rIns="182880" tIns="182880" bIns="182880"/>
           <a:lstStyle/>
           <a:p>
             <a:pPr algn="ctr">
-              <a:defRPr b="1" sz="1200">
-                <a:solidFill>
-                  <a:srgbClr val="059669"/>
-                </a:solidFill>
-              </a:defRPr>
-            </a:pPr>
-            <a:r>
-              <a:t>Automated Verification Worker</a:t>
+              <a:defRPr b="1" sz="1300">
+                <a:solidFill>
+                  <a:srgbClr val="047857"/>
+                </a:solidFill>
+              </a:defRPr>
+            </a:pPr>
+            <a:r>
+              <a:t>What is Ambient AI?</a:t>
             </a:r>
           </a:p>
           <a:p>
             <a:pPr>
-              <a:lnSpc>
-                <a:spcPct val="130000"/>
-              </a:lnSpc>
               <a:defRPr sz="950">
                 <a:solidFill>
-                  <a:srgbClr val="1E293B"/>
-                </a:solidFill>
-              </a:defRPr>
-            </a:pPr>
-            <a:r>
-              <a:t>- Executes complete 48/48 CI matrix tests across isolated environments.</a:t>
-            </a:r>
-            <a:br/>
-            <a:r>
-              <a:t>- Scans code diffs for secret leakage and boundary vulnerabilities.</a:t>
-            </a:r>
-            <a:br/>
-            <a:r>
-              <a:t>- Packages certified artifacts and generates verifiable execution receipts.</a:t>
-            </a:r>
-          </a:p>
-        </p:txBody>
-      </p:sp>
+                  <a:srgbClr val="334155"/>
+                </a:solidFill>
+              </a:defRPr>
+            </a:pPr>
+            <a:r>
+              <a:t>- Invisible Autonomy: AI shouldn't demand your constant attention. It should operate like electricity: always on, reliable, invisible until called.</a:t>
+            </a:r>
+          </a:p>
+          <a:p>
+            <a:pPr>
+              <a:defRPr sz="950">
+                <a:solidFill>
+                  <a:srgbClr val="334155"/>
+                </a:solidFill>
+              </a:defRPr>
+            </a:pPr>
+            <a:r>
+              <a:t>- Zero Context Bloat: Instead of dumping 100,000 tokens into every turn, context is managed as an active Directed Acyclic Graph (DAG).</a:t>
+            </a:r>
+          </a:p>
+          <a:p>
+            <a:pPr>
+              <a:defRPr sz="950">
+                <a:solidFill>
+                  <a:srgbClr val="334155"/>
+                </a:solidFill>
+              </a:defRPr>
+            </a:pPr>
+            <a:r>
+              <a:t>- Evolution to Skills: When an agent discovers a reliable workflow, it packages it into a permanent SKILL.md so it never has to re-learn it.</a:t>
+            </a:r>
+          </a:p>
+          <a:p>
+            <a:pPr>
+              <a:defRPr sz="950">
+                <a:solidFill>
+                  <a:srgbClr val="334155"/>
+                </a:solidFill>
+              </a:defRPr>
+            </a:pPr>
+            <a:r>
+              <a:t>- Reversible Safety: Total psychological safety: any change can be rolled back in one click via atomic Git branches.</a:t>
+            </a:r>
+          </a:p>
+          <a:p>
+            <a:pPr>
+              <a:defRPr sz="950">
+                <a:solidFill>
+                  <a:srgbClr val="334155"/>
+                </a:solidFill>
+              </a:defRPr>
+            </a:pPr>
+            <a:r>
+              <a:t>- Fun Takeaway: The ultimate luxury in AI is not a chatbox - it's not having to chat at all!</a:t>
+            </a:r>
+          </a:p>
+        </p:txBody>
+      </p:sp>
+      <p:pic>
+        <p:nvPicPr>
+          <p:cNvPr id="7" name="Picture 6" descr="diag_ambient_pillars.png"/>
+          <p:cNvPicPr>
+            <a:picLocks noChangeAspect="1"/>
+          </p:cNvPicPr>
+          <p:nvPr/>
+        </p:nvPicPr>
+        <p:blipFill>
+          <a:blip r:embed="rId2"/>
+          <a:stretch>
+            <a:fillRect/>
+          </a:stretch>
+        </p:blipFill>
+        <p:spPr>
+          <a:xfrm>
+            <a:off x="4754880" y="1234440"/>
+            <a:ext cx="6705295" cy="4084835"/>
+          </a:xfrm>
+          <a:prstGeom prst="rect">
+            <a:avLst/>
+          </a:prstGeom>
+        </p:spPr>
+      </p:pic>
     </p:spTree>
   </p:cSld>
   <p:clrMapOvr>
@@ -5347,7 +5106,7 @@
           </a:fontRef>
         </p:style>
         <p:txBody>
-          <a:bodyPr rtlCol="0" anchor="ctr"/>
+          <a:bodyPr rtlCol="0" anchor="ctr" wrap="square" lIns="182880" rIns="182880" tIns="182880" bIns="182880"/>
           <a:lstStyle/>
           <a:p>
             <a:pPr algn="ctr">
@@ -5358,7 +5117,7 @@
               </a:defRPr>
             </a:pPr>
             <a:r>
-              <a:t>MILESTONE 5</a:t>
+              <a:t>MILESTONE 6</a:t>
             </a:r>
           </a:p>
         </p:txBody>
@@ -5380,7 +5139,7 @@
           <a:noFill/>
         </p:spPr>
         <p:txBody>
-          <a:bodyPr wrap="none">
+          <a:bodyPr wrap="square" lIns="182880" rIns="182880" tIns="182880" bIns="182880">
             <a:spAutoFit/>
           </a:bodyPr>
           <a:lstStyle/>
@@ -5393,7 +5152,7 @@
               </a:defRPr>
             </a:pPr>
             <a:r>
-              <a:t>Ambient AI: The 5 Pillars of Invisible Ergonomics</a:t>
+              <a:t>The North Star: Minimizing Human Cognitive Load</a:t>
             </a:r>
           </a:p>
         </p:txBody>
@@ -5415,7 +5174,7 @@
           <a:noFill/>
         </p:spPr>
         <p:txBody>
-          <a:bodyPr wrap="none">
+          <a:bodyPr wrap="square" lIns="182880" rIns="182880" tIns="182880" bIns="182880">
             <a:spAutoFit/>
           </a:bodyPr>
           <a:lstStyle/>
@@ -5428,7 +5187,7 @@
               </a:defRPr>
             </a:pPr>
             <a:r>
-              <a:t>Moving from active prompt manipulation to quiet, ambient background autonomy</a:t>
+              <a:t>Transforming human operators from stressed micromanagers into confident directors</a:t>
             </a:r>
           </a:p>
         </p:txBody>
@@ -5442,17 +5201,17 @@
         <p:spPr>
           <a:xfrm>
             <a:off x="731520" y="1234440"/>
-            <a:ext cx="3840480" cy="5212080"/>
+            <a:ext cx="3840480" cy="2514600"/>
           </a:xfrm>
           <a:prstGeom prst="roundRect">
             <a:avLst/>
           </a:prstGeom>
           <a:solidFill>
-            <a:srgbClr val="F8FAFC"/>
+            <a:srgbClr val="FEF2F2"/>
           </a:solidFill>
           <a:ln w="19050">
             <a:solidFill>
-              <a:srgbClr val="059669"/>
+              <a:srgbClr val="EF4444"/>
             </a:solidFill>
           </a:ln>
         </p:spPr>
@@ -5471,85 +5230,163 @@
           </a:fontRef>
         </p:style>
         <p:txBody>
-          <a:bodyPr rtlCol="0" anchor="ctr"/>
+          <a:bodyPr rtlCol="0" anchor="ctr" wrap="square" lIns="182880" rIns="182880" tIns="182880" bIns="182880"/>
           <a:lstStyle/>
           <a:p>
             <a:pPr algn="ctr">
-              <a:defRPr b="1" sz="1300">
-                <a:solidFill>
-                  <a:srgbClr val="047857"/>
-                </a:solidFill>
-              </a:defRPr>
-            </a:pPr>
-            <a:r>
-              <a:t>What is Ambient AI?</a:t>
+              <a:defRPr b="1" sz="1150">
+                <a:solidFill>
+                  <a:srgbClr val="DC2626"/>
+                </a:solidFill>
+              </a:defRPr>
+            </a:pPr>
+            <a:r>
+              <a:t>OLD WAY: The Babysitting Trap</a:t>
             </a:r>
           </a:p>
           <a:p>
             <a:pPr>
-              <a:defRPr sz="950">
-                <a:solidFill>
-                  <a:srgbClr val="334155"/>
-                </a:solidFill>
-              </a:defRPr>
-            </a:pPr>
-            <a:r>
-              <a:t>- Invisible Autonomy: AI shouldn't demand your constant attention. It should operate like electricity: always on, reliable, invisible until called.</a:t>
+              <a:defRPr sz="919">
+                <a:solidFill>
+                  <a:srgbClr val="991B1B"/>
+                </a:solidFill>
+              </a:defRPr>
+            </a:pPr>
+            <a:r>
+              <a:t>- Context Exhaustion: Paste stack traces, re-read code diffs, re-prompt.</a:t>
             </a:r>
           </a:p>
           <a:p>
             <a:pPr>
-              <a:defRPr sz="950">
-                <a:solidFill>
-                  <a:srgbClr val="334155"/>
-                </a:solidFill>
-              </a:defRPr>
-            </a:pPr>
-            <a:r>
-              <a:t>- Zero Context Bloat: Instead of dumping 100,000 tokens into every turn, context is managed as an active Directed Acyclic Graph (DAG).</a:t>
+              <a:defRPr sz="919">
+                <a:solidFill>
+                  <a:srgbClr val="991B1B"/>
+                </a:solidFill>
+              </a:defRPr>
+            </a:pPr>
+            <a:r>
+              <a:t>- Manual Babysitting: Anxiously inspect every single line &amp; syntax output.</a:t>
             </a:r>
           </a:p>
           <a:p>
             <a:pPr>
-              <a:defRPr sz="950">
-                <a:solidFill>
-                  <a:srgbClr val="334155"/>
-                </a:solidFill>
-              </a:defRPr>
-            </a:pPr>
-            <a:r>
-              <a:t>- Evolution to Skills: When an agent discovers a reliable workflow, it packages it into a permanent SKILL.md so it never has to re-learn it.</a:t>
+              <a:defRPr sz="919">
+                <a:solidFill>
+                  <a:srgbClr val="991B1B"/>
+                </a:solidFill>
+              </a:defRPr>
+            </a:pPr>
+            <a:r>
+              <a:t>- Mental Burnout: 40+ context switches/hour causing extreme fatigue.</a:t>
+            </a:r>
+          </a:p>
+        </p:txBody>
+      </p:sp>
+      <p:sp>
+        <p:nvSpPr>
+          <p:cNvPr id="7" name="Rounded Rectangle 6"/>
+          <p:cNvSpPr/>
+          <p:nvPr/>
+        </p:nvSpPr>
+        <p:spPr>
+          <a:xfrm>
+            <a:off x="731520" y="3886200"/>
+            <a:ext cx="3840480" cy="2560320"/>
+          </a:xfrm>
+          <a:prstGeom prst="roundRect">
+            <a:avLst/>
+          </a:prstGeom>
+          <a:solidFill>
+            <a:srgbClr val="F0FDF4"/>
+          </a:solidFill>
+          <a:ln w="19050">
+            <a:solidFill>
+              <a:srgbClr val="10B981"/>
+            </a:solidFill>
+          </a:ln>
+        </p:spPr>
+        <p:style>
+          <a:lnRef idx="1">
+            <a:schemeClr val="accent1"/>
+          </a:lnRef>
+          <a:fillRef idx="3">
+            <a:schemeClr val="accent1"/>
+          </a:fillRef>
+          <a:effectRef idx="2">
+            <a:schemeClr val="accent1"/>
+          </a:effectRef>
+          <a:fontRef idx="minor">
+            <a:schemeClr val="lt1"/>
+          </a:fontRef>
+        </p:style>
+        <p:txBody>
+          <a:bodyPr rtlCol="0" anchor="ctr" wrap="square" lIns="182880" rIns="182880" tIns="182880" bIns="182880"/>
+          <a:lstStyle/>
+          <a:p>
+            <a:pPr algn="ctr">
+              <a:defRPr b="1" sz="1150">
+                <a:solidFill>
+                  <a:srgbClr val="059669"/>
+                </a:solidFill>
+              </a:defRPr>
+            </a:pPr>
+            <a:r>
+              <a:t>NEW WAY: Ambient Autonomy</a:t>
             </a:r>
           </a:p>
           <a:p>
             <a:pPr>
-              <a:defRPr sz="950">
-                <a:solidFill>
-                  <a:srgbClr val="334155"/>
-                </a:solidFill>
-              </a:defRPr>
-            </a:pPr>
-            <a:r>
-              <a:t>- Reversible Safety: Total psychological safety: any change can be rolled back in one click via atomic Git branches.</a:t>
+              <a:defRPr sz="919">
+                <a:solidFill>
+                  <a:srgbClr val="065F46"/>
+                </a:solidFill>
+              </a:defRPr>
+            </a:pPr>
+            <a:r>
+              <a:t>- Executive Intent: Human gives high-level directive: 'Ship it' or 'Proceed'.</a:t>
             </a:r>
           </a:p>
           <a:p>
             <a:pPr>
-              <a:defRPr sz="950">
-                <a:solidFill>
-                  <a:srgbClr val="334155"/>
-                </a:solidFill>
-              </a:defRPr>
-            </a:pPr>
-            <a:r>
-              <a:t>- Fun Takeaway: The ultimate luxury in AI is not a chatbox - it's not having to chat at all!</a:t>
+              <a:defRPr sz="919">
+                <a:solidFill>
+                  <a:srgbClr val="065F46"/>
+                </a:solidFill>
+              </a:defRPr>
+            </a:pPr>
+            <a:r>
+              <a:t>- Autonomous Execution: Context DAG routes state, executes 48/48 CI matrix.</a:t>
+            </a:r>
+          </a:p>
+          <a:p>
+            <a:pPr>
+              <a:defRPr sz="919">
+                <a:solidFill>
+                  <a:srgbClr val="065F46"/>
+                </a:solidFill>
+              </a:defRPr>
+            </a:pPr>
+            <a:r>
+              <a:t>- Reversible Safety: One-button rollback safety net + signed receipts.</a:t>
+            </a:r>
+          </a:p>
+          <a:p>
+            <a:pPr>
+              <a:defRPr sz="919">
+                <a:solidFill>
+                  <a:srgbClr val="065F46"/>
+                </a:solidFill>
+              </a:defRPr>
+            </a:pPr>
+            <a:r>
+              <a:t>- Proven Result: -88% cognitive mental fatigue eliminated!</a:t>
             </a:r>
           </a:p>
         </p:txBody>
       </p:sp>
       <p:pic>
         <p:nvPicPr>
-          <p:cNvPr id="7" name="Picture 6" descr="diag_ambient_pillars.png"/>
+          <p:cNvPr id="8" name="Picture 7" descr="diag_cognitive_load.png"/>
           <p:cNvPicPr>
             <a:picLocks noChangeAspect="1"/>
           </p:cNvPicPr>
@@ -5564,7 +5401,7 @@
         <p:spPr>
           <a:xfrm>
             <a:off x="4754880" y="1234440"/>
-            <a:ext cx="6705295" cy="4084835"/>
+            <a:ext cx="6705295" cy="3930690"/>
           </a:xfrm>
           <a:prstGeom prst="rect">
             <a:avLst/>
@@ -5670,7 +5507,7 @@
           </a:fontRef>
         </p:style>
         <p:txBody>
-          <a:bodyPr rtlCol="0" anchor="ctr"/>
+          <a:bodyPr rtlCol="0" anchor="ctr" wrap="square" lIns="182880" rIns="182880" tIns="182880" bIns="182880"/>
           <a:lstStyle/>
           <a:p>
             <a:pPr algn="ctr">
@@ -5681,7 +5518,7 @@
               </a:defRPr>
             </a:pPr>
             <a:r>
-              <a:t>MILESTONE 6</a:t>
+              <a:t>TECH SHOWCASE</a:t>
             </a:r>
           </a:p>
         </p:txBody>
@@ -5703,7 +5540,7 @@
           <a:noFill/>
         </p:spPr>
         <p:txBody>
-          <a:bodyPr wrap="none">
+          <a:bodyPr wrap="square" lIns="182880" rIns="182880" tIns="182880" bIns="182880">
             <a:spAutoFit/>
           </a:bodyPr>
           <a:lstStyle/>
@@ -5716,7 +5553,7 @@
               </a:defRPr>
             </a:pPr>
             <a:r>
-              <a:t>The North Star: Minimizing Human Cognitive Load</a:t>
+              <a:t>Production Tech Stack &amp; Cloud Architecture</a:t>
             </a:r>
           </a:p>
         </p:txBody>
@@ -5738,7 +5575,7 @@
           <a:noFill/>
         </p:spPr>
         <p:txBody>
-          <a:bodyPr wrap="none">
+          <a:bodyPr wrap="square" lIns="182880" rIns="182880" tIns="182880" bIns="182880">
             <a:spAutoFit/>
           </a:bodyPr>
           <a:lstStyle/>
@@ -5751,122 +5588,14 @@
               </a:defRPr>
             </a:pPr>
             <a:r>
-              <a:t>Transforming human operators from stressed micromanagers into confident directors</a:t>
-            </a:r>
-          </a:p>
-        </p:txBody>
-      </p:sp>
-      <p:sp>
-        <p:nvSpPr>
-          <p:cNvPr id="6" name="Rounded Rectangle 5"/>
-          <p:cNvSpPr/>
-          <p:nvPr/>
-        </p:nvSpPr>
-        <p:spPr>
-          <a:xfrm>
-            <a:off x="731520" y="1234440"/>
-            <a:ext cx="3840480" cy="5212080"/>
-          </a:xfrm>
-          <a:prstGeom prst="roundRect">
-            <a:avLst/>
-          </a:prstGeom>
-          <a:solidFill>
-            <a:srgbClr val="FFFFFF"/>
-          </a:solidFill>
-          <a:ln w="19050">
-            <a:solidFill>
-              <a:srgbClr val="DC2626"/>
-            </a:solidFill>
-          </a:ln>
-        </p:spPr>
-        <p:style>
-          <a:lnRef idx="1">
-            <a:schemeClr val="accent1"/>
-          </a:lnRef>
-          <a:fillRef idx="3">
-            <a:schemeClr val="accent1"/>
-          </a:fillRef>
-          <a:effectRef idx="2">
-            <a:schemeClr val="accent1"/>
-          </a:effectRef>
-          <a:fontRef idx="minor">
-            <a:schemeClr val="lt1"/>
-          </a:fontRef>
-        </p:style>
-        <p:txBody>
-          <a:bodyPr rtlCol="0" anchor="ctr"/>
-          <a:lstStyle/>
-          <a:p>
-            <a:pPr algn="ctr">
-              <a:defRPr b="1" sz="1100">
-                <a:solidFill>
-                  <a:srgbClr val="DC2626"/>
-                </a:solidFill>
-              </a:defRPr>
-            </a:pPr>
-            <a:r>
-              <a:t>The Babysitting Trap vs. Ambient Ease</a:t>
-            </a:r>
-          </a:p>
-          <a:p>
-            <a:br/>
-            <a:pPr>
-              <a:defRPr sz="900">
-                <a:solidFill>
-                  <a:srgbClr val="991B1B"/>
-                </a:solidFill>
-              </a:defRPr>
-            </a:pPr>
-            <a:r>
-              <a:t>OLD WAY: Human Micromanager</a:t>
-            </a:r>
-            <a:br/>
-            <a:r>
-              <a:t>- Paste stack trace -&gt; read code -&gt; ask model</a:t>
-            </a:r>
-            <a:br/>
-            <a:r>
-              <a:t>- Copy snippet -&gt; test manually -&gt; hit syntax bug</a:t>
-            </a:r>
-            <a:br/>
-            <a:r>
-              <a:t>- Repeat 40 times per hour -&gt; Extreme mental fatigue</a:t>
-            </a:r>
-          </a:p>
-          <a:p>
-            <a:br/>
-            <a:pPr>
-              <a:defRPr sz="900">
-                <a:solidFill>
-                  <a:srgbClr val="065F46"/>
-                </a:solidFill>
-              </a:defRPr>
-            </a:pPr>
-            <a:r>
-              <a:t>AMBIENT WAY: Executive Director</a:t>
-            </a:r>
-            <a:br/>
-            <a:r>
-              <a:t>- Human says: 'Proceed' or 'Ship it'</a:t>
-            </a:r>
-            <a:br/>
-            <a:r>
-              <a:t>- AI team evaluates DAG, runs CI matrix, pushes commit</a:t>
-            </a:r>
-            <a:br/>
-            <a:r>
-              <a:t>- Delivers signed receipt + status summary</a:t>
-            </a:r>
-            <a:br/>
-            <a:r>
-              <a:t>- 88% cognitive fatigue eliminated!</a:t>
+              <a:t>Real-world infrastructure connecting client reflex, CI/CD factory, and AWS us-east-2 (966273137102)</a:t>
             </a:r>
           </a:p>
         </p:txBody>
       </p:sp>
       <p:pic>
         <p:nvPicPr>
-          <p:cNvPr id="7" name="Picture 6" descr="diag_cognitive_load.png"/>
+          <p:cNvPr id="6" name="Picture 5" descr="diag_tech_stack.png"/>
           <p:cNvPicPr>
             <a:picLocks noChangeAspect="1"/>
           </p:cNvPicPr>
@@ -5880,14 +5609,168 @@
         </p:blipFill>
         <p:spPr>
           <a:xfrm>
-            <a:off x="4754880" y="1234440"/>
-            <a:ext cx="6705295" cy="3773334"/>
+            <a:off x="731520" y="1234440"/>
+            <a:ext cx="7498079" cy="3854153"/>
           </a:xfrm>
           <a:prstGeom prst="rect">
             <a:avLst/>
           </a:prstGeom>
         </p:spPr>
       </p:pic>
+      <p:sp>
+        <p:nvSpPr>
+          <p:cNvPr id="7" name="Rounded Rectangle 6"/>
+          <p:cNvSpPr/>
+          <p:nvPr/>
+        </p:nvSpPr>
+        <p:spPr>
+          <a:xfrm>
+            <a:off x="8412480" y="1234440"/>
+            <a:ext cx="3047695" cy="5212080"/>
+          </a:xfrm>
+          <a:prstGeom prst="roundRect">
+            <a:avLst/>
+          </a:prstGeom>
+          <a:solidFill>
+            <a:srgbClr val="F8FAFC"/>
+          </a:solidFill>
+          <a:ln w="19050">
+            <a:solidFill>
+              <a:srgbClr val="0284C7"/>
+            </a:solidFill>
+          </a:ln>
+        </p:spPr>
+        <p:style>
+          <a:lnRef idx="1">
+            <a:schemeClr val="accent1"/>
+          </a:lnRef>
+          <a:fillRef idx="3">
+            <a:schemeClr val="accent1"/>
+          </a:fillRef>
+          <a:effectRef idx="2">
+            <a:schemeClr val="accent1"/>
+          </a:effectRef>
+          <a:fontRef idx="minor">
+            <a:schemeClr val="lt1"/>
+          </a:fontRef>
+        </p:style>
+        <p:txBody>
+          <a:bodyPr rtlCol="0" anchor="ctr" wrap="square" lIns="182880" rIns="182880" tIns="182880" bIns="182880"/>
+          <a:lstStyle/>
+          <a:p>
+            <a:pPr algn="ctr">
+              <a:defRPr b="1" sz="1200">
+                <a:solidFill>
+                  <a:srgbClr val="0369A1"/>
+                </a:solidFill>
+              </a:defRPr>
+            </a:pPr>
+            <a:r>
+              <a:t>Architectural Guarantees</a:t>
+            </a:r>
+          </a:p>
+          <a:p>
+            <a:br/>
+            <a:pPr>
+              <a:defRPr b="1" sz="950">
+                <a:solidFill>
+                  <a:srgbClr val="0284C7"/>
+                </a:solidFill>
+              </a:defRPr>
+            </a:pPr>
+            <a:r>
+              <a:t>Tier 1: Sub-Second Reflex</a:t>
+            </a:r>
+          </a:p>
+          <a:p>
+            <a:pPr>
+              <a:defRPr sz="850">
+                <a:solidFill>
+                  <a:srgbClr val="334155"/>
+                </a:solidFill>
+              </a:defRPr>
+            </a:pPr>
+            <a:r>
+              <a:t>Local AST parsing &amp; regex filters absorb routine syntax probes before cloud API invocation.</a:t>
+            </a:r>
+          </a:p>
+          <a:p>
+            <a:br/>
+            <a:pPr>
+              <a:defRPr b="1" sz="950">
+                <a:solidFill>
+                  <a:srgbClr val="7C3AED"/>
+                </a:solidFill>
+              </a:defRPr>
+            </a:pPr>
+            <a:r>
+              <a:t>Tier 2: Deterministic CI</a:t>
+            </a:r>
+          </a:p>
+          <a:p>
+            <a:pPr>
+              <a:defRPr sz="850">
+                <a:solidFill>
+                  <a:srgbClr val="334155"/>
+                </a:solidFill>
+              </a:defRPr>
+            </a:pPr>
+            <a:r>
+              <a:t>48/48 automated assertions on clean-room virtual runners before merge.</a:t>
+            </a:r>
+          </a:p>
+          <a:p>
+            <a:br/>
+            <a:pPr>
+              <a:defRPr b="1" sz="950">
+                <a:solidFill>
+                  <a:srgbClr val="D97706"/>
+                </a:solidFill>
+              </a:defRPr>
+            </a:pPr>
+            <a:r>
+              <a:t>Tier 3: AWS us-east-2</a:t>
+            </a:r>
+          </a:p>
+          <a:p>
+            <a:pPr>
+              <a:defRPr sz="850">
+                <a:solidFill>
+                  <a:srgbClr val="334155"/>
+                </a:solidFill>
+              </a:defRPr>
+            </a:pPr>
+            <a:r>
+              <a:t>Lambda HTTPS gateway, Step Functions state machine, Bedrock Claude Sonnet, and KMS S3.</a:t>
+            </a:r>
+          </a:p>
+          <a:p>
+            <a:br/>
+            <a:pPr>
+              <a:defRPr b="1" sz="950">
+                <a:solidFill>
+                  <a:srgbClr val="059669"/>
+                </a:solidFill>
+              </a:defRPr>
+            </a:pPr>
+            <a:r>
+              <a:t>Tier 4: Cognitive Memory</a:t>
+            </a:r>
+          </a:p>
+          <a:p>
+            <a:pPr>
+              <a:defRPr sz="850">
+                <a:solidFill>
+                  <a:srgbClr val="334155"/>
+                </a:solidFill>
+              </a:defRPr>
+            </a:pPr>
+            <a:r>
+              <a:t>Vector DB cosine embeddings + Knowledge Graph Cypher multi-hop traversal.</a:t>
+            </a:r>
+          </a:p>
+        </p:txBody>
+      </p:sp>
     </p:spTree>
   </p:cSld>
   <p:clrMapOvr>
@@ -5908,24 +5791,24 @@
       <p:grpSpPr/>
       <p:sp>
         <p:nvSpPr>
-          <p:cNvPr id="2" name="Rectangle 1"/>
+          <p:cNvPr id="2" name="Rounded Rectangle 1"/>
           <p:cNvSpPr/>
           <p:nvPr/>
         </p:nvSpPr>
         <p:spPr>
           <a:xfrm>
-            <a:off x="0" y="0"/>
-            <a:ext cx="12191695" cy="1051560"/>
-          </a:xfrm>
-          <a:prstGeom prst="rect">
+            <a:off x="731520" y="731520"/>
+            <a:ext cx="10728655" cy="5394960"/>
+          </a:xfrm>
+          <a:prstGeom prst="roundRect">
             <a:avLst/>
           </a:prstGeom>
           <a:solidFill>
-            <a:srgbClr val="FFFFFF"/>
+            <a:srgbClr val="0F172A"/>
           </a:solidFill>
-          <a:ln w="12700">
+          <a:ln w="31750">
             <a:solidFill>
-              <a:srgbClr val="E2E8F0"/>
+              <a:srgbClr val="10B981"/>
             </a:solidFill>
           </a:ln>
         </p:spPr>
@@ -5944,593 +5827,105 @@
           </a:fontRef>
         </p:style>
         <p:txBody>
-          <a:bodyPr rtlCol="0" anchor="ctr"/>
-          <a:lstStyle/>
-          <a:p>
-            <a:pPr algn="ctr"/>
-          </a:p>
-        </p:txBody>
-      </p:sp>
-      <p:sp>
-        <p:nvSpPr>
-          <p:cNvPr id="3" name="Rounded Rectangle 2"/>
-          <p:cNvSpPr/>
-          <p:nvPr/>
-        </p:nvSpPr>
-        <p:spPr>
-          <a:xfrm>
-            <a:off x="731520" y="164592"/>
-            <a:ext cx="2103120" cy="292608"/>
-          </a:xfrm>
-          <a:prstGeom prst="roundRect">
-            <a:avLst/>
-          </a:prstGeom>
-          <a:solidFill>
-            <a:srgbClr val="0284C7"/>
-          </a:solidFill>
-          <a:ln>
-            <a:noFill/>
-          </a:ln>
-        </p:spPr>
-        <p:style>
-          <a:lnRef idx="1">
-            <a:schemeClr val="accent1"/>
-          </a:lnRef>
-          <a:fillRef idx="3">
-            <a:schemeClr val="accent1"/>
-          </a:fillRef>
-          <a:effectRef idx="2">
-            <a:schemeClr val="accent1"/>
-          </a:effectRef>
-          <a:fontRef idx="minor">
-            <a:schemeClr val="lt1"/>
-          </a:fontRef>
-        </p:style>
-        <p:txBody>
-          <a:bodyPr rtlCol="0" anchor="ctr"/>
+          <a:bodyPr rtlCol="0" anchor="ctr" wrap="square" lIns="182880" rIns="182880" tIns="182880" bIns="182880"/>
           <a:lstStyle/>
           <a:p>
             <a:pPr algn="ctr">
-              <a:defRPr sz="950" b="1">
+              <a:defRPr sz="1400" b="1">
+                <a:solidFill>
+                  <a:srgbClr val="34D399"/>
+                </a:solidFill>
+              </a:defRPr>
+            </a:pPr>
+            <a:r>
+              <a:t>THE FUTURE OF AUTONOMOUS SYSTEMS</a:t>
+            </a:r>
+          </a:p>
+          <a:p>
+            <a:pPr algn="ctr">
+              <a:defRPr sz="2800" b="1">
                 <a:solidFill>
                   <a:srgbClr val="FFFFFF"/>
                 </a:solidFill>
               </a:defRPr>
             </a:pPr>
             <a:r>
-              <a:t>TECH SHOWCASE</a:t>
-            </a:r>
-          </a:p>
-        </p:txBody>
-      </p:sp>
-      <p:sp>
-        <p:nvSpPr>
-          <p:cNvPr id="4" name="TextBox 3"/>
-          <p:cNvSpPr txBox="1"/>
-          <p:nvPr/>
-        </p:nvSpPr>
-        <p:spPr>
-          <a:xfrm>
-            <a:off x="3017520" y="91440"/>
-            <a:ext cx="8686800" cy="457200"/>
-          </a:xfrm>
-          <a:prstGeom prst="rect">
-            <a:avLst/>
-          </a:prstGeom>
-          <a:noFill/>
-        </p:spPr>
-        <p:txBody>
-          <a:bodyPr wrap="none">
-            <a:spAutoFit/>
-          </a:bodyPr>
-          <a:lstStyle/>
-          <a:p>
-            <a:pPr>
-              <a:defRPr sz="2000" b="1">
-                <a:solidFill>
-                  <a:srgbClr val="0F172A"/>
-                </a:solidFill>
-              </a:defRPr>
-            </a:pPr>
-            <a:r>
-              <a:t>Production Tech Stack &amp; Live Cloud Bridge</a:t>
-            </a:r>
-          </a:p>
-        </p:txBody>
-      </p:sp>
-      <p:sp>
-        <p:nvSpPr>
-          <p:cNvPr id="5" name="TextBox 4"/>
-          <p:cNvSpPr txBox="1"/>
-          <p:nvPr/>
-        </p:nvSpPr>
-        <p:spPr>
-          <a:xfrm>
-            <a:off x="731520" y="530352"/>
-            <a:ext cx="10789920" cy="411480"/>
-          </a:xfrm>
-          <a:prstGeom prst="rect">
-            <a:avLst/>
-          </a:prstGeom>
-          <a:noFill/>
-        </p:spPr>
-        <p:txBody>
-          <a:bodyPr wrap="none">
-            <a:spAutoFit/>
-          </a:bodyPr>
-          <a:lstStyle/>
-          <a:p>
-            <a:pPr>
+              <a:t>From Chatting with Models to Conducting Orchestras</a:t>
+            </a:r>
+          </a:p>
+          <a:p>
+            <a:br/>
+            <a:pPr algn="ctr">
+              <a:defRPr sz="1200" b="1">
+                <a:solidFill>
+                  <a:srgbClr val="94A3B8"/>
+                </a:solidFill>
+              </a:defRPr>
+            </a:pPr>
+            <a:r>
+              <a:t>Key Takeaways from Our Journey:</a:t>
+            </a:r>
+            <a:br/>
+          </a:p>
+          <a:p>
+            <a:pPr algn="ctr">
               <a:defRPr sz="1100">
                 <a:solidFill>
-                  <a:srgbClr val="64748B"/>
-                </a:solidFill>
-              </a:defRPr>
-            </a:pPr>
-            <a:r>
-              <a:t>Real-world infrastructure proven across GitHub Actions and AWS Project us-east-2 (966273137102)</a:t>
-            </a:r>
-          </a:p>
-        </p:txBody>
-      </p:sp>
-      <p:sp>
-        <p:nvSpPr>
-          <p:cNvPr id="6" name="Rounded Rectangle 5"/>
-          <p:cNvSpPr/>
-          <p:nvPr/>
-        </p:nvSpPr>
-        <p:spPr>
-          <a:xfrm>
-            <a:off x="731520" y="1280160"/>
-            <a:ext cx="3291840" cy="2423160"/>
-          </a:xfrm>
-          <a:prstGeom prst="roundRect">
-            <a:avLst/>
-          </a:prstGeom>
-          <a:solidFill>
-            <a:srgbClr val="FFFFFF"/>
-          </a:solidFill>
-          <a:ln w="19050">
-            <a:solidFill>
-              <a:srgbClr val="0284C7"/>
-            </a:solidFill>
-          </a:ln>
-        </p:spPr>
-        <p:style>
-          <a:lnRef idx="1">
-            <a:schemeClr val="accent1"/>
-          </a:lnRef>
-          <a:fillRef idx="3">
-            <a:schemeClr val="accent1"/>
-          </a:fillRef>
-          <a:effectRef idx="2">
-            <a:schemeClr val="accent1"/>
-          </a:effectRef>
-          <a:fontRef idx="minor">
-            <a:schemeClr val="lt1"/>
-          </a:fontRef>
-        </p:style>
-        <p:txBody>
-          <a:bodyPr rtlCol="0" anchor="ctr"/>
-          <a:lstStyle/>
+                  <a:srgbClr val="F1F5F9"/>
+                </a:solidFill>
+              </a:defRPr>
+            </a:pPr>
+            <a:r>
+              <a:t>1. Lone agents hit context ceilings; 3-Layer Brains distribute cognition from instant reflexes to deep deliberation.</a:t>
+            </a:r>
+          </a:p>
           <a:p>
             <a:pPr algn="ctr">
-              <a:defRPr b="1" sz="1100">
-                <a:solidFill>
-                  <a:srgbClr val="0284C7"/>
-                </a:solidFill>
-              </a:defRPr>
-            </a:pPr>
-            <a:r>
-              <a:t>Reflex Execution Layer</a:t>
-            </a:r>
-          </a:p>
-          <a:p>
-            <a:pPr>
-              <a:lnSpc>
-                <a:spcPct val="125000"/>
-              </a:lnSpc>
-              <a:defRPr sz="880">
-                <a:solidFill>
-                  <a:srgbClr val="334155"/>
-                </a:solidFill>
-              </a:defRPr>
-            </a:pPr>
-            <a:r>
-              <a:t>- Sub-second local execution for fast syntax parsing</a:t>
-            </a:r>
+              <a:defRPr sz="1100">
+                <a:solidFill>
+                  <a:srgbClr val="F1F5F9"/>
+                </a:solidFill>
+              </a:defRPr>
+            </a:pPr>
+            <a:r>
+              <a:t>2. The AI Factory organizes assembly workers along a deterministic line to turn unpredictable LLM outputs into certified software.</a:t>
+            </a:r>
+          </a:p>
+          <a:p>
+            <a:pPr algn="ctr">
+              <a:defRPr sz="1100">
+                <a:solidFill>
+                  <a:srgbClr val="F1F5F9"/>
+                </a:solidFill>
+              </a:defRPr>
+            </a:pPr>
+            <a:r>
+              <a:t>3. Ambient AI makes the entire apparatus invisible: you speak your intent, and the system executes with total safety.</a:t>
+            </a:r>
+          </a:p>
+          <a:p>
+            <a:pPr algn="ctr">
+              <a:defRPr sz="1100">
+                <a:solidFill>
+                  <a:srgbClr val="F1F5F9"/>
+                </a:solidFill>
+              </a:defRPr>
+            </a:pPr>
+            <a:r>
+              <a:t>4. Minimizing human cognitive load is the ultimate north star: from anxious babysitting to high-leverage execution in 1 click.</a:t>
+            </a:r>
+          </a:p>
+          <a:p>
             <a:br/>
-            <a:r>
-              <a:t>- Instant regex gates and pre-flight environment probes</a:t>
-            </a:r>
-            <a:br/>
-            <a:r>
-              <a:t>- Real-time telemetry packet visualizer</a:t>
-            </a:r>
-          </a:p>
-        </p:txBody>
-      </p:sp>
-      <p:sp>
-        <p:nvSpPr>
-          <p:cNvPr id="7" name="Rounded Rectangle 6"/>
-          <p:cNvSpPr/>
-          <p:nvPr/>
-        </p:nvSpPr>
-        <p:spPr>
-          <a:xfrm>
-            <a:off x="4434840" y="1280160"/>
-            <a:ext cx="3291840" cy="2423160"/>
-          </a:xfrm>
-          <a:prstGeom prst="roundRect">
-            <a:avLst/>
-          </a:prstGeom>
-          <a:solidFill>
-            <a:srgbClr val="FFFFFF"/>
-          </a:solidFill>
-          <a:ln w="19050">
-            <a:solidFill>
-              <a:srgbClr val="7C3AED"/>
-            </a:solidFill>
-          </a:ln>
-        </p:spPr>
-        <p:style>
-          <a:lnRef idx="1">
-            <a:schemeClr val="accent1"/>
-          </a:lnRef>
-          <a:fillRef idx="3">
-            <a:schemeClr val="accent1"/>
-          </a:fillRef>
-          <a:effectRef idx="2">
-            <a:schemeClr val="accent1"/>
-          </a:effectRef>
-          <a:fontRef idx="minor">
-            <a:schemeClr val="lt1"/>
-          </a:fontRef>
-        </p:style>
-        <p:txBody>
-          <a:bodyPr rtlCol="0" anchor="ctr"/>
-          <a:lstStyle/>
-          <a:p>
             <a:pPr algn="ctr">
-              <a:defRPr b="1" sz="1100">
-                <a:solidFill>
-                  <a:srgbClr val="7C3AED"/>
-                </a:solidFill>
-              </a:defRPr>
-            </a:pPr>
-            <a:r>
-              <a:t>GitHub CI/CD Automation</a:t>
-            </a:r>
-          </a:p>
-          <a:p>
-            <a:pPr>
-              <a:lnSpc>
-                <a:spcPct val="125000"/>
-              </a:lnSpc>
-              <a:defRPr sz="880">
-                <a:solidFill>
-                  <a:srgbClr val="334155"/>
-                </a:solidFill>
-              </a:defRPr>
-            </a:pPr>
-            <a:r>
-              <a:t>- 4 Automated robotic jobs (AST, Secrets, Matrix, Tests)</a:t>
-            </a:r>
-            <a:br/>
-            <a:r>
-              <a:t>- ubuntu-latest continuous integration runners</a:t>
-            </a:r>
-            <a:br/>
-            <a:r>
-              <a:t>- Ed25519 SSH key signing for live Git pushes</a:t>
-            </a:r>
-          </a:p>
-        </p:txBody>
-      </p:sp>
-      <p:sp>
-        <p:nvSpPr>
-          <p:cNvPr id="8" name="Rounded Rectangle 7"/>
-          <p:cNvSpPr/>
-          <p:nvPr/>
-        </p:nvSpPr>
-        <p:spPr>
-          <a:xfrm>
-            <a:off x="8138160" y="1280160"/>
-            <a:ext cx="3291840" cy="2423160"/>
-          </a:xfrm>
-          <a:prstGeom prst="roundRect">
-            <a:avLst/>
-          </a:prstGeom>
-          <a:solidFill>
-            <a:srgbClr val="FFFFFF"/>
-          </a:solidFill>
-          <a:ln w="19050">
-            <a:solidFill>
-              <a:srgbClr val="D97706"/>
-            </a:solidFill>
-          </a:ln>
-        </p:spPr>
-        <p:style>
-          <a:lnRef idx="1">
-            <a:schemeClr val="accent1"/>
-          </a:lnRef>
-          <a:fillRef idx="3">
-            <a:schemeClr val="accent1"/>
-          </a:fillRef>
-          <a:effectRef idx="2">
-            <a:schemeClr val="accent1"/>
-          </a:effectRef>
-          <a:fontRef idx="minor">
-            <a:schemeClr val="lt1"/>
-          </a:fontRef>
-        </p:style>
-        <p:txBody>
-          <a:bodyPr rtlCol="0" anchor="ctr"/>
-          <a:lstStyle/>
-          <a:p>
-            <a:pPr algn="ctr">
-              <a:defRPr b="1" sz="1100">
-                <a:solidFill>
-                  <a:srgbClr val="D97706"/>
-                </a:solidFill>
-              </a:defRPr>
-            </a:pPr>
-            <a:r>
-              <a:t>AWS Cloud Core (us-east-2)</a:t>
-            </a:r>
-          </a:p>
-          <a:p>
-            <a:pPr>
-              <a:lnSpc>
-                <a:spcPct val="125000"/>
-              </a:lnSpc>
-              <a:defRPr sz="880">
-                <a:solidFill>
-                  <a:srgbClr val="334155"/>
-                </a:solidFill>
-              </a:defRPr>
-            </a:pPr>
-            <a:r>
-              <a:t>- Lambda HTTPS Gateway with SHA-256 header verification</a:t>
-            </a:r>
-            <a:br/>
-            <a:r>
-              <a:t>- Bedrock Claude Sonnet 4.6 Mantle Converse API</a:t>
-            </a:r>
-            <a:br/>
-            <a:r>
-              <a:t>- Step Functions state machines &amp; KMS S3 bucket</a:t>
-            </a:r>
-          </a:p>
-        </p:txBody>
-      </p:sp>
-      <p:sp>
-        <p:nvSpPr>
-          <p:cNvPr id="9" name="Rounded Rectangle 8"/>
-          <p:cNvSpPr/>
-          <p:nvPr/>
-        </p:nvSpPr>
-        <p:spPr>
-          <a:xfrm>
-            <a:off x="731520" y="3931920"/>
-            <a:ext cx="3291840" cy="2423160"/>
-          </a:xfrm>
-          <a:prstGeom prst="roundRect">
-            <a:avLst/>
-          </a:prstGeom>
-          <a:solidFill>
-            <a:srgbClr val="FFFFFF"/>
-          </a:solidFill>
-          <a:ln w="19050">
-            <a:solidFill>
-              <a:srgbClr val="059669"/>
-            </a:solidFill>
-          </a:ln>
-        </p:spPr>
-        <p:style>
-          <a:lnRef idx="1">
-            <a:schemeClr val="accent1"/>
-          </a:lnRef>
-          <a:fillRef idx="3">
-            <a:schemeClr val="accent1"/>
-          </a:fillRef>
-          <a:effectRef idx="2">
-            <a:schemeClr val="accent1"/>
-          </a:effectRef>
-          <a:fontRef idx="minor">
-            <a:schemeClr val="lt1"/>
-          </a:fontRef>
-        </p:style>
-        <p:txBody>
-          <a:bodyPr rtlCol="0" anchor="ctr"/>
-          <a:lstStyle/>
-          <a:p>
-            <a:pPr algn="ctr">
-              <a:defRPr b="1" sz="1100">
-                <a:solidFill>
-                  <a:srgbClr val="059669"/>
-                </a:solidFill>
-              </a:defRPr>
-            </a:pPr>
-            <a:r>
-              <a:t>AI Knowledge &amp; Database</a:t>
-            </a:r>
-          </a:p>
-          <a:p>
-            <a:pPr>
-              <a:lnSpc>
-                <a:spcPct val="125000"/>
-              </a:lnSpc>
-              <a:defRPr sz="880">
-                <a:solidFill>
-                  <a:srgbClr val="334155"/>
-                </a:solidFill>
-              </a:defRPr>
-            </a:pPr>
-            <a:r>
-              <a:t>- Vector Database with cosine similarity search</a:t>
-            </a:r>
-            <a:br/>
-            <a:r>
-              <a:t>- Knowledge Graph with Cypher multi-hop traversals</a:t>
-            </a:r>
-            <a:br/>
-            <a:r>
-              <a:t>- Context DAG memory indexing &amp; skill registry</a:t>
-            </a:r>
-          </a:p>
-        </p:txBody>
-      </p:sp>
-      <p:sp>
-        <p:nvSpPr>
-          <p:cNvPr id="10" name="Rounded Rectangle 9"/>
-          <p:cNvSpPr/>
-          <p:nvPr/>
-        </p:nvSpPr>
-        <p:spPr>
-          <a:xfrm>
-            <a:off x="4434840" y="3931920"/>
-            <a:ext cx="3291840" cy="2423160"/>
-          </a:xfrm>
-          <a:prstGeom prst="roundRect">
-            <a:avLst/>
-          </a:prstGeom>
-          <a:solidFill>
-            <a:srgbClr val="FFFFFF"/>
-          </a:solidFill>
-          <a:ln w="19050">
-            <a:solidFill>
-              <a:srgbClr val="DC2626"/>
-            </a:solidFill>
-          </a:ln>
-        </p:spPr>
-        <p:style>
-          <a:lnRef idx="1">
-            <a:schemeClr val="accent1"/>
-          </a:lnRef>
-          <a:fillRef idx="3">
-            <a:schemeClr val="accent1"/>
-          </a:fillRef>
-          <a:effectRef idx="2">
-            <a:schemeClr val="accent1"/>
-          </a:effectRef>
-          <a:fontRef idx="minor">
-            <a:schemeClr val="lt1"/>
-          </a:fontRef>
-        </p:style>
-        <p:txBody>
-          <a:bodyPr rtlCol="0" anchor="ctr"/>
-          <a:lstStyle/>
-          <a:p>
-            <a:pPr algn="ctr">
-              <a:defRPr b="1" sz="1100">
-                <a:solidFill>
-                  <a:srgbClr val="DC2626"/>
-                </a:solidFill>
-              </a:defRPr>
-            </a:pPr>
-            <a:r>
-              <a:t>Deterministic Security Shield</a:t>
-            </a:r>
-          </a:p>
-          <a:p>
-            <a:pPr>
-              <a:lnSpc>
-                <a:spcPct val="125000"/>
-              </a:lnSpc>
-              <a:defRPr sz="880">
-                <a:solidFill>
-                  <a:srgbClr val="334155"/>
-                </a:solidFill>
-              </a:defRPr>
-            </a:pPr>
-            <a:r>
-              <a:t>- Pre-flight regex auditor guarantees zero secret leakage</a:t>
-            </a:r>
-            <a:br/>
-            <a:r>
-              <a:t>- Cryptographic signature check for cloud dispatch</a:t>
-            </a:r>
-            <a:br/>
-            <a:r>
-              <a:t>- Isolated branch execution per worker task</a:t>
-            </a:r>
-          </a:p>
-        </p:txBody>
-      </p:sp>
-      <p:sp>
-        <p:nvSpPr>
-          <p:cNvPr id="11" name="Rounded Rectangle 10"/>
-          <p:cNvSpPr/>
-          <p:nvPr/>
-        </p:nvSpPr>
-        <p:spPr>
-          <a:xfrm>
-            <a:off x="8138160" y="3931920"/>
-            <a:ext cx="3291840" cy="2423160"/>
-          </a:xfrm>
-          <a:prstGeom prst="roundRect">
-            <a:avLst/>
-          </a:prstGeom>
-          <a:solidFill>
-            <a:srgbClr val="FFFFFF"/>
-          </a:solidFill>
-          <a:ln w="19050">
-            <a:solidFill>
-              <a:srgbClr val="475569"/>
-            </a:solidFill>
-          </a:ln>
-        </p:spPr>
-        <p:style>
-          <a:lnRef idx="1">
-            <a:schemeClr val="accent1"/>
-          </a:lnRef>
-          <a:fillRef idx="3">
-            <a:schemeClr val="accent1"/>
-          </a:fillRef>
-          <a:effectRef idx="2">
-            <a:schemeClr val="accent1"/>
-          </a:effectRef>
-          <a:fontRef idx="minor">
-            <a:schemeClr val="lt1"/>
-          </a:fontRef>
-        </p:style>
-        <p:txBody>
-          <a:bodyPr rtlCol="0" anchor="ctr"/>
-          <a:lstStyle/>
-          <a:p>
-            <a:pPr algn="ctr">
-              <a:defRPr b="1" sz="1100">
-                <a:solidFill>
-                  <a:srgbClr val="475569"/>
-                </a:solidFill>
-              </a:defRPr>
-            </a:pPr>
-            <a:r>
-              <a:t>Executive Synthesis</a:t>
-            </a:r>
-          </a:p>
-          <a:p>
-            <a:pPr>
-              <a:lnSpc>
-                <a:spcPct val="125000"/>
-              </a:lnSpc>
-              <a:defRPr sz="880">
-                <a:solidFill>
-                  <a:srgbClr val="334155"/>
-                </a:solidFill>
-              </a:defRPr>
-            </a:pPr>
-            <a:r>
-              <a:t>- Automated 1-page visual summary guides</a:t>
-            </a:r>
-            <a:br/>
-            <a:r>
-              <a:t>- Cryptographic telemetry receipts</a:t>
-            </a:r>
-            <a:br/>
-            <a:r>
-              <a:t>- Autonomous audit logging and status streams</a:t>
+              <a:defRPr sz="1400" b="1">
+                <a:solidFill>
+                  <a:srgbClr val="38BDF8"/>
+                </a:solidFill>
+              </a:defRPr>
+            </a:pPr>
+            <a:r>
+              <a:t>"The best AI system is the one you don't have to micromanage."</a:t>
             </a:r>
           </a:p>
         </p:txBody>

</xml_diff>

<commit_message>
style: remove 'simple, intuitive, graphical, fun, autonomous' tagline from cover subtitle
</commit_message>
<xml_diff>
--- a/AI_Journey_Single_Agent_to_Ambient_Enterprise.pptx
+++ b/AI_Journey_Single_Agent_to_Ambient_Enterprise.pptx
@@ -3215,19 +3215,6 @@
               <a:t>A Journey Through 3-Layer Cognitive Brains, Factory Assembly Workers, and Zero-Cognitive-Load Ambient AI</a:t>
             </a:r>
           </a:p>
-          <a:p>
-            <a:br/>
-            <a:pPr algn="ctr">
-              <a:defRPr sz="1300" b="1">
-                <a:solidFill>
-                  <a:srgbClr val="34D399"/>
-                </a:solidFill>
-              </a:defRPr>
-            </a:pPr>
-            <a:r>
-              <a:t>Simple  *  Intuitive  *  Graphical  *  Fun  *  Autonomous</a:t>
-            </a:r>
-          </a:p>
         </p:txBody>
       </p:sp>
     </p:spTree>
@@ -3919,7 +3906,7 @@
               </a:defRPr>
             </a:pPr>
             <a:r>
-              <a:t>- Fun Analogy: Asking a single intern to build a skyscraper, draft legal contracts, and inspect plumbing alone.</a:t>
+              <a:t>- Key Analogy: Asking a single intern to build a skyscraper, draft legal contracts, and inspect plumbing alone.</a:t>
             </a:r>
           </a:p>
         </p:txBody>
@@ -4320,7 +4307,7 @@
               </a:defRPr>
             </a:pPr>
             <a:r>
-              <a:t>- Fun Takeaway: Stop waking heavy frontier models to verify if a semicolon exists!</a:t>
+              <a:t>- Core Takeaway: Stop waking heavy frontier models to verify if a semicolon exists!</a:t>
             </a:r>
           </a:p>
         </p:txBody>
@@ -4655,7 +4642,7 @@
               </a:defRPr>
             </a:pPr>
             <a:r>
-              <a:t>- Fun Takeaway: Treat prompts like machine tooling, not creative writing!</a:t>
+              <a:t>- Core Takeaway: Treat prompts like machine tooling, not creative writing!</a:t>
             </a:r>
           </a:p>
         </p:txBody>
@@ -4978,7 +4965,7 @@
               </a:defRPr>
             </a:pPr>
             <a:r>
-              <a:t>- Fun Takeaway: The ultimate luxury in AI is not a chatbox - it's not having to chat at all!</a:t>
+              <a:t>- Core Takeaway: The ultimate luxury in AI is not a chatbox - it's not having to chat at all!</a:t>
             </a:r>
           </a:p>
         </p:txBody>

</xml_diff>

<commit_message>
docs: Rewrite AI Journey PPT to reflect combination of AI Factory and Ambient CI/CD
</commit_message>
<xml_diff>
--- a/AI_Journey_Single_Agent_to_Ambient_Enterprise.pptx
+++ b/AI_Journey_Single_Agent_to_Ambient_Enterprise.pptx
@@ -3181,38 +3181,51 @@
           <a:lstStyle/>
           <a:p>
             <a:pPr algn="ctr">
-              <a:defRPr sz="1400" b="1">
+              <a:defRPr sz="1500" b="1">
                 <a:solidFill>
                   <a:srgbClr val="38BDF8"/>
                 </a:solidFill>
               </a:defRPr>
             </a:pPr>
             <a:r>
-              <a:t>THE AUTONOMOUS ODYSSEY</a:t>
+              <a:t>MY AI JOURNEY</a:t>
             </a:r>
           </a:p>
           <a:p>
             <a:pPr algn="ctr">
-              <a:defRPr sz="3200" b="1">
+              <a:defRPr sz="3000" b="1">
                 <a:solidFill>
                   <a:srgbClr val="FFFFFF"/>
                 </a:solidFill>
               </a:defRPr>
             </a:pPr>
             <a:r>
-              <a:t>From Single Agent to Ambient AI</a:t>
+              <a:t>Combining AI Factory &amp; Ambient CI/CD</a:t>
             </a:r>
           </a:p>
           <a:p>
             <a:pPr algn="ctr">
-              <a:defRPr sz="1300">
+              <a:defRPr sz="1200">
                 <a:solidFill>
                   <a:srgbClr val="94A3B8"/>
                 </a:solidFill>
               </a:defRPr>
             </a:pPr>
             <a:r>
-              <a:t>A Journey Through 3-Layer Cognitive Brains, Factory Assembly Workers, and Zero-Cognitive-Load Ambient AI</a:t>
+              <a:t>From Single Agent to 3-Tier Cognitive Pyramid, Assembly Line Factory, and Multi-Time Scale Continuous Deployment with Zero Cognitive Load</a:t>
+            </a:r>
+          </a:p>
+          <a:p>
+            <a:br/>
+            <a:pPr algn="ctr">
+              <a:defRPr sz="1100" b="1">
+                <a:solidFill>
+                  <a:srgbClr val="10B981"/>
+                </a:solidFill>
+              </a:defRPr>
+            </a:pPr>
+            <a:r>
+              <a:t>Project: For Each and Every  •  AWS us-east-2  •  Live in Production</a:t>
             </a:r>
           </a:p>
         </p:txBody>
@@ -3250,12 +3263,10 @@
             <a:avLst/>
           </a:prstGeom>
           <a:solidFill>
-            <a:srgbClr val="FFFFFF"/>
+            <a:srgbClr val="0F172A"/>
           </a:solidFill>
-          <a:ln w="12700">
-            <a:solidFill>
-              <a:srgbClr val="E2E8F0"/>
-            </a:solidFill>
+          <a:ln>
+            <a:noFill/>
           </a:ln>
         </p:spPr>
         <p:style>
@@ -3288,8 +3299,8 @@
         </p:nvSpPr>
         <p:spPr>
           <a:xfrm>
-            <a:off x="731520" y="164592"/>
-            <a:ext cx="2103120" cy="292608"/>
+            <a:off x="731520" y="201168"/>
+            <a:ext cx="1645920" cy="292608"/>
           </a:xfrm>
           <a:prstGeom prst="roundRect">
             <a:avLst/>
@@ -3320,7 +3331,7 @@
           <a:lstStyle/>
           <a:p>
             <a:pPr algn="ctr">
-              <a:defRPr sz="950" b="1">
+              <a:defRPr sz="850" b="1">
                 <a:solidFill>
                   <a:srgbClr val="FFFFFF"/>
                 </a:solidFill>
@@ -3340,8 +3351,8 @@
         </p:nvSpPr>
         <p:spPr>
           <a:xfrm>
-            <a:off x="3017520" y="91440"/>
-            <a:ext cx="8686800" cy="457200"/>
+            <a:off x="2514600" y="109728"/>
+            <a:ext cx="8961120" cy="868680"/>
           </a:xfrm>
           <a:prstGeom prst="rect">
             <a:avLst/>
@@ -3349,62 +3360,39 @@
           <a:noFill/>
         </p:spPr>
         <p:txBody>
-          <a:bodyPr wrap="square" lIns="182880" rIns="182880" tIns="182880" bIns="182880">
+          <a:bodyPr wrap="square" lIns="182880" rIns="182880" bIns="182880">
             <a:spAutoFit/>
           </a:bodyPr>
           <a:lstStyle/>
           <a:p>
             <a:pPr>
-              <a:defRPr sz="2000" b="1">
-                <a:solidFill>
-                  <a:srgbClr val="0F172A"/>
-                </a:solidFill>
-              </a:defRPr>
-            </a:pPr>
-            <a:r>
-              <a:t>The Evolutionary Path of Autonomous AI</a:t>
-            </a:r>
-          </a:p>
-        </p:txBody>
-      </p:sp>
-      <p:sp>
-        <p:nvSpPr>
-          <p:cNvPr id="5" name="TextBox 4"/>
-          <p:cNvSpPr txBox="1"/>
-          <p:nvPr/>
-        </p:nvSpPr>
-        <p:spPr>
-          <a:xfrm>
-            <a:off x="731520" y="530352"/>
-            <a:ext cx="10789920" cy="411480"/>
-          </a:xfrm>
-          <a:prstGeom prst="rect">
-            <a:avLst/>
-          </a:prstGeom>
-          <a:noFill/>
-        </p:spPr>
-        <p:txBody>
-          <a:bodyPr wrap="square" lIns="182880" rIns="182880" tIns="182880" bIns="182880">
-            <a:spAutoFit/>
-          </a:bodyPr>
-          <a:lstStyle/>
+              <a:defRPr sz="1700" b="1">
+                <a:solidFill>
+                  <a:srgbClr val="FFFFFF"/>
+                </a:solidFill>
+              </a:defRPr>
+            </a:pPr>
+            <a:r>
+              <a:t>The Evolutionary Journey of My AI Architecture</a:t>
+            </a:r>
+          </a:p>
           <a:p>
             <a:pPr>
-              <a:defRPr sz="1100">
-                <a:solidFill>
-                  <a:srgbClr val="64748B"/>
-                </a:solidFill>
-              </a:defRPr>
-            </a:pPr>
-            <a:r>
-              <a:t>Visualizing how our architecture matured from brute-force prompts to an intelligent autonomous ecosystem</a:t>
+              <a:defRPr sz="950">
+                <a:solidFill>
+                  <a:srgbClr val="94A3B8"/>
+                </a:solidFill>
+              </a:defRPr>
+            </a:pPr>
+            <a:r>
+              <a:t>Visualizing the maturation from brute-force prompts to an industrial AI Factory and ambient CI/CD</a:t>
             </a:r>
           </a:p>
         </p:txBody>
       </p:sp>
       <p:pic>
         <p:nvPicPr>
-          <p:cNvPr id="6" name="Picture 5" descr="diag_roadmap.png"/>
+          <p:cNvPr id="5" name="Picture 4" descr="diag_roadmap.png"/>
           <p:cNvPicPr>
             <a:picLocks noChangeAspect="1"/>
           </p:cNvPicPr>
@@ -3428,7 +3416,7 @@
       </p:pic>
       <p:sp>
         <p:nvSpPr>
-          <p:cNvPr id="7" name="Rounded Rectangle 6"/>
+          <p:cNvPr id="6" name="Rounded Rectangle 5"/>
           <p:cNvSpPr/>
           <p:nvPr/>
         </p:nvSpPr>
@@ -3475,7 +3463,7 @@
               </a:defRPr>
             </a:pPr>
             <a:r>
-              <a:t>Phase 1: Tool Execution</a:t>
+              <a:t>Phase 1: Artisanal Prompting</a:t>
             </a:r>
           </a:p>
           <a:p>
@@ -3487,14 +3475,14 @@
               </a:defRPr>
             </a:pPr>
             <a:r>
-              <a:t>Early single/multi-agent scripts acting as simple task runners. Required high human babysitting and constant prompt tweaking.</a:t>
-            </a:r>
-          </a:p>
-        </p:txBody>
-      </p:sp>
-      <p:sp>
-        <p:nvSpPr>
-          <p:cNvPr id="8" name="Rounded Rectangle 7"/>
+              <a:t>Early single/multi-agent trial-and-error. Heavy mental babysitting, context rot over 50 turns, and fragile unverified outputs.</a:t>
+            </a:r>
+          </a:p>
+        </p:txBody>
+      </p:sp>
+      <p:sp>
+        <p:nvSpPr>
+          <p:cNvPr id="7" name="Rounded Rectangle 6"/>
           <p:cNvSpPr/>
           <p:nvPr/>
         </p:nvSpPr>
@@ -3541,7 +3529,7 @@
               </a:defRPr>
             </a:pPr>
             <a:r>
-              <a:t>Phase 2: Cognitive Factories</a:t>
+              <a:t>Phase 2: Cognitive AI Factory</a:t>
             </a:r>
           </a:p>
           <a:p>
@@ -3553,14 +3541,14 @@
               </a:defRPr>
             </a:pPr>
             <a:r>
-              <a:t>Brain-inspired 3-tier cognition + AI Factory assembly workers with deterministic verification gates.</a:t>
-            </a:r>
-          </a:p>
-        </p:txBody>
-      </p:sp>
-      <p:sp>
-        <p:nvSpPr>
-          <p:cNvPr id="9" name="Rounded Rectangle 8"/>
+              <a:t>The 3-Tier Cognitive Pyramid (Foundations, Executive Mind, Networked Brain) + assembly line with deterministic 48/48 CI matrix tests.</a:t>
+            </a:r>
+          </a:p>
+        </p:txBody>
+      </p:sp>
+      <p:sp>
+        <p:nvSpPr>
+          <p:cNvPr id="8" name="Rounded Rectangle 7"/>
           <p:cNvSpPr/>
           <p:nvPr/>
         </p:nvSpPr>
@@ -3607,7 +3595,7 @@
               </a:defRPr>
             </a:pPr>
             <a:r>
-              <a:t>Phase 3: Ambient Intelligence</a:t>
+              <a:t>Phase 3: Ambient Production</a:t>
             </a:r>
           </a:p>
           <a:p>
@@ -3619,7 +3607,7 @@
               </a:defRPr>
             </a:pPr>
             <a:r>
-              <a:t>Context DAGs, self-healing skills, one-button rollbacks. AI runs quietly in the ambient background with near-zero human fatigue.</a:t>
+              <a:t>Multi-time scale CI/CD unifying Design and Operations continuously. Context DAGs, one-button rollbacks, and -88% human fatigue in AWS us-east-2.</a:t>
             </a:r>
           </a:p>
         </p:txBody>
@@ -3657,12 +3645,10 @@
             <a:avLst/>
           </a:prstGeom>
           <a:solidFill>
-            <a:srgbClr val="FFFFFF"/>
+            <a:srgbClr val="0F172A"/>
           </a:solidFill>
-          <a:ln w="12700">
-            <a:solidFill>
-              <a:srgbClr val="E2E8F0"/>
-            </a:solidFill>
+          <a:ln>
+            <a:noFill/>
           </a:ln>
         </p:spPr>
         <p:style>
@@ -3695,8 +3681,8 @@
         </p:nvSpPr>
         <p:spPr>
           <a:xfrm>
-            <a:off x="731520" y="164592"/>
-            <a:ext cx="2103120" cy="292608"/>
+            <a:off x="731520" y="201168"/>
+            <a:ext cx="1645920" cy="292608"/>
           </a:xfrm>
           <a:prstGeom prst="roundRect">
             <a:avLst/>
@@ -3727,7 +3713,7 @@
           <a:lstStyle/>
           <a:p>
             <a:pPr algn="ctr">
-              <a:defRPr sz="950" b="1">
+              <a:defRPr sz="850" b="1">
                 <a:solidFill>
                   <a:srgbClr val="FFFFFF"/>
                 </a:solidFill>
@@ -3747,8 +3733,8 @@
         </p:nvSpPr>
         <p:spPr>
           <a:xfrm>
-            <a:off x="3017520" y="91440"/>
-            <a:ext cx="8686800" cy="457200"/>
+            <a:off x="2514600" y="109728"/>
+            <a:ext cx="8961120" cy="868680"/>
           </a:xfrm>
           <a:prstGeom prst="rect">
             <a:avLst/>
@@ -3756,15 +3742,15 @@
           <a:noFill/>
         </p:spPr>
         <p:txBody>
-          <a:bodyPr wrap="square" lIns="182880" rIns="182880" tIns="182880" bIns="182880">
+          <a:bodyPr wrap="square" lIns="182880" rIns="182880" bIns="182880">
             <a:spAutoFit/>
           </a:bodyPr>
           <a:lstStyle/>
           <a:p>
             <a:pPr>
-              <a:defRPr sz="2000" b="1">
-                <a:solidFill>
-                  <a:srgbClr val="0F172A"/>
+              <a:defRPr sz="1700" b="1">
+                <a:solidFill>
+                  <a:srgbClr val="FFFFFF"/>
                 </a:solidFill>
               </a:defRPr>
             </a:pPr>
@@ -3772,46 +3758,23 @@
               <a:t>From Lone Wolf to the Specialized Squad</a:t>
             </a:r>
           </a:p>
-        </p:txBody>
-      </p:sp>
-      <p:sp>
-        <p:nvSpPr>
-          <p:cNvPr id="5" name="TextBox 4"/>
-          <p:cNvSpPr txBox="1"/>
-          <p:nvPr/>
-        </p:nvSpPr>
-        <p:spPr>
-          <a:xfrm>
-            <a:off x="731520" y="530352"/>
-            <a:ext cx="10789920" cy="411480"/>
-          </a:xfrm>
-          <a:prstGeom prst="rect">
-            <a:avLst/>
-          </a:prstGeom>
-          <a:noFill/>
-        </p:spPr>
-        <p:txBody>
-          <a:bodyPr wrap="square" lIns="182880" rIns="182880" tIns="182880" bIns="182880">
-            <a:spAutoFit/>
-          </a:bodyPr>
-          <a:lstStyle/>
           <a:p>
             <a:pPr>
-              <a:defRPr sz="1100">
-                <a:solidFill>
-                  <a:srgbClr val="64748B"/>
-                </a:solidFill>
-              </a:defRPr>
-            </a:pPr>
-            <a:r>
-              <a:t>Breaking out of the single-prompt trap by assembling cooperative specialized agents</a:t>
-            </a:r>
-          </a:p>
-        </p:txBody>
-      </p:sp>
-      <p:sp>
-        <p:nvSpPr>
-          <p:cNvPr id="6" name="Rounded Rectangle 5"/>
+              <a:defRPr sz="950">
+                <a:solidFill>
+                  <a:srgbClr val="94A3B8"/>
+                </a:solidFill>
+              </a:defRPr>
+            </a:pPr>
+            <a:r>
+              <a:t>Breaking out of the monolithic prompt trap by assembling cooperative specialized agents</a:t>
+            </a:r>
+          </a:p>
+        </p:txBody>
+      </p:sp>
+      <p:sp>
+        <p:nvSpPr>
+          <p:cNvPr id="5" name="Rounded Rectangle 4"/>
           <p:cNvSpPr/>
           <p:nvPr/>
         </p:nvSpPr>
@@ -3863,7 +3826,7 @@
           </a:p>
           <a:p>
             <a:pPr>
-              <a:defRPr sz="1000">
+              <a:defRPr sz="950">
                 <a:solidFill>
                   <a:srgbClr val="334155"/>
                 </a:solidFill>
@@ -3875,7 +3838,7 @@
           </a:p>
           <a:p>
             <a:pPr>
-              <a:defRPr sz="1000">
+              <a:defRPr sz="950">
                 <a:solidFill>
                   <a:srgbClr val="334155"/>
                 </a:solidFill>
@@ -3887,7 +3850,7 @@
           </a:p>
           <a:p>
             <a:pPr>
-              <a:defRPr sz="1000">
+              <a:defRPr sz="950">
                 <a:solidFill>
                   <a:srgbClr val="334155"/>
                 </a:solidFill>
@@ -3899,21 +3862,21 @@
           </a:p>
           <a:p>
             <a:pPr>
-              <a:defRPr sz="1000">
+              <a:defRPr sz="950">
                 <a:solidFill>
                   <a:srgbClr val="334155"/>
                 </a:solidFill>
               </a:defRPr>
             </a:pPr>
             <a:r>
-              <a:t>- Key Analogy: Asking a single intern to build a skyscraper, draft legal contracts, and inspect plumbing alone.</a:t>
-            </a:r>
-          </a:p>
-        </p:txBody>
-      </p:sp>
-      <p:sp>
-        <p:nvSpPr>
-          <p:cNvPr id="7" name="Rounded Rectangle 6"/>
+              <a:t>- Analogy: Asking a single intern to design a skyscraper, draft legal contracts, and inspect plumbing alone.</a:t>
+            </a:r>
+          </a:p>
+        </p:txBody>
+      </p:sp>
+      <p:sp>
+        <p:nvSpPr>
+          <p:cNvPr id="6" name="Rounded Rectangle 5"/>
           <p:cNvSpPr/>
           <p:nvPr/>
         </p:nvSpPr>
@@ -3965,50 +3928,50 @@
           </a:p>
           <a:p>
             <a:pPr>
-              <a:defRPr sz="1000">
+              <a:defRPr sz="950">
                 <a:solidFill>
                   <a:srgbClr val="334155"/>
                 </a:solidFill>
               </a:defRPr>
             </a:pPr>
             <a:r>
-              <a:t>- Concept: Role specialization: Researcher, Architect, Coder, and QA Critic working in tandem.</a:t>
+              <a:t>- Concept: Role specialization: Software Architect, Coder, and Test Engineer working in tandem.</a:t>
             </a:r>
           </a:p>
           <a:p>
             <a:pPr>
-              <a:defRPr sz="1000">
+              <a:defRPr sz="950">
                 <a:solidFill>
                   <a:srgbClr val="334155"/>
                 </a:solidFill>
               </a:defRPr>
             </a:pPr>
             <a:r>
-              <a:t>- The Breakthrough: Cross-verification: The Coder cannot push until the QA Critic asserts exit code 0.</a:t>
+              <a:t>- The Breakthrough: Cross-verification: The Coder cannot push until the Test Engineer asserts exit code 0.</a:t>
             </a:r>
           </a:p>
           <a:p>
             <a:pPr>
-              <a:defRPr sz="1000">
+              <a:defRPr sz="950">
                 <a:solidFill>
                   <a:srgbClr val="334155"/>
                 </a:solidFill>
               </a:defRPr>
             </a:pPr>
             <a:r>
-              <a:t>- The Emerging Challenge: Coordination tax: Agents chatting endlessly in loops ('After you!' 'No, after you!') consuming massive context.</a:t>
+              <a:t>- The Emerging Challenge: Coordination tax: Agents chatting endlessly in loops ('After you!' 'No, after you!') consuming massive tokens.</a:t>
             </a:r>
           </a:p>
           <a:p>
             <a:pPr>
-              <a:defRPr sz="1000">
+              <a:defRPr sz="950">
                 <a:solidFill>
                   <a:srgbClr val="334155"/>
                 </a:solidFill>
               </a:defRPr>
             </a:pPr>
             <a:r>
-              <a:t>- Key Lesson: Specialization is essential, but without hierarchical cognitive control, multi-agent teams drift into chaos.</a:t>
+              <a:t>- Key Discovery: Role division alone is not enough; agents require formal cognitive stratification and invariant governance.</a:t>
             </a:r>
           </a:p>
         </p:txBody>
@@ -4046,12 +4009,10 @@
             <a:avLst/>
           </a:prstGeom>
           <a:solidFill>
-            <a:srgbClr val="FFFFFF"/>
+            <a:srgbClr val="0F172A"/>
           </a:solidFill>
-          <a:ln w="12700">
-            <a:solidFill>
-              <a:srgbClr val="E2E8F0"/>
-            </a:solidFill>
+          <a:ln>
+            <a:noFill/>
           </a:ln>
         </p:spPr>
         <p:style>
@@ -4084,8 +4045,8 @@
         </p:nvSpPr>
         <p:spPr>
           <a:xfrm>
-            <a:off x="731520" y="164592"/>
-            <a:ext cx="2103120" cy="292608"/>
+            <a:off x="731520" y="201168"/>
+            <a:ext cx="1645920" cy="292608"/>
           </a:xfrm>
           <a:prstGeom prst="roundRect">
             <a:avLst/>
@@ -4116,7 +4077,7 @@
           <a:lstStyle/>
           <a:p>
             <a:pPr algn="ctr">
-              <a:defRPr sz="950" b="1">
+              <a:defRPr sz="850" b="1">
                 <a:solidFill>
                   <a:srgbClr val="FFFFFF"/>
                 </a:solidFill>
@@ -4136,8 +4097,8 @@
         </p:nvSpPr>
         <p:spPr>
           <a:xfrm>
-            <a:off x="3017520" y="91440"/>
-            <a:ext cx="8686800" cy="457200"/>
+            <a:off x="2514600" y="109728"/>
+            <a:ext cx="8961120" cy="868680"/>
           </a:xfrm>
           <a:prstGeom prst="rect">
             <a:avLst/>
@@ -4145,62 +4106,39 @@
           <a:noFill/>
         </p:spPr>
         <p:txBody>
-          <a:bodyPr wrap="square" lIns="182880" rIns="182880" tIns="182880" bIns="182880">
+          <a:bodyPr wrap="square" lIns="182880" rIns="182880" bIns="182880">
             <a:spAutoFit/>
           </a:bodyPr>
           <a:lstStyle/>
           <a:p>
             <a:pPr>
-              <a:defRPr sz="2000" b="1">
-                <a:solidFill>
-                  <a:srgbClr val="0F172A"/>
-                </a:solidFill>
-              </a:defRPr>
-            </a:pPr>
-            <a:r>
-              <a:t>Brain-Inspired Cognitive Architecture (3 Layers)</a:t>
-            </a:r>
-          </a:p>
-        </p:txBody>
-      </p:sp>
-      <p:sp>
-        <p:nvSpPr>
-          <p:cNvPr id="5" name="TextBox 4"/>
-          <p:cNvSpPr txBox="1"/>
-          <p:nvPr/>
-        </p:nvSpPr>
-        <p:spPr>
-          <a:xfrm>
-            <a:off x="731520" y="530352"/>
-            <a:ext cx="10789920" cy="411480"/>
-          </a:xfrm>
-          <a:prstGeom prst="rect">
-            <a:avLst/>
-          </a:prstGeom>
-          <a:noFill/>
-        </p:spPr>
-        <p:txBody>
-          <a:bodyPr wrap="square" lIns="182880" rIns="182880" tIns="182880" bIns="182880">
-            <a:spAutoFit/>
-          </a:bodyPr>
-          <a:lstStyle/>
+              <a:defRPr sz="1700" b="1">
+                <a:solidFill>
+                  <a:srgbClr val="FFFFFF"/>
+                </a:solidFill>
+              </a:defRPr>
+            </a:pPr>
+            <a:r>
+              <a:t>The Tiered Cognitive Pyramid (3 Tiers)</a:t>
+            </a:r>
+          </a:p>
           <a:p>
             <a:pPr>
-              <a:defRPr sz="1100">
-                <a:solidFill>
-                  <a:srgbClr val="64748B"/>
-                </a:solidFill>
-              </a:defRPr>
-            </a:pPr>
-            <a:r>
-              <a:t>Mimicking biological cognitive hierarchy to balance instant reflexes with deep deliberative reason</a:t>
-            </a:r>
-          </a:p>
-        </p:txBody>
-      </p:sp>
-      <p:sp>
-        <p:nvSpPr>
-          <p:cNvPr id="6" name="Rounded Rectangle 5"/>
+              <a:defRPr sz="950">
+                <a:solidFill>
+                  <a:srgbClr val="94A3B8"/>
+                </a:solidFill>
+              </a:defRPr>
+            </a:pPr>
+            <a:r>
+              <a:t>Stratifying intelligence into Foundations, Executive Mind, and Networked Brain</a:t>
+            </a:r>
+          </a:p>
+        </p:txBody>
+      </p:sp>
+      <p:sp>
+        <p:nvSpPr>
+          <p:cNvPr id="5" name="Rounded Rectangle 4"/>
           <p:cNvSpPr/>
           <p:nvPr/>
         </p:nvSpPr>
@@ -4247,74 +4185,74 @@
               </a:defRPr>
             </a:pPr>
             <a:r>
-              <a:t>Biological Cognition in AI</a:t>
+              <a:t>The Cognitive Pyramid Principle</a:t>
             </a:r>
           </a:p>
           <a:p>
             <a:pPr>
-              <a:defRPr sz="950">
+              <a:defRPr sz="900">
                 <a:solidFill>
                   <a:srgbClr val="334155"/>
                 </a:solidFill>
               </a:defRPr>
             </a:pPr>
             <a:r>
-              <a:t>- Why 3 Layers?: The human brain doesn't fire millions of neurons to blink an eyelid. Fast tasks stay in the spinal cord; only novel dilemmas wake the prefrontal cortex.</a:t>
+              <a:t>- Why Stratify?: Biological brains don't fire millions of cortical neurons to blink an eye. Fast tasks stay in the spinal reflex; only novel dilemmas wake the prefrontal cortex.</a:t>
             </a:r>
           </a:p>
           <a:p>
             <a:pPr>
-              <a:defRPr sz="950">
+              <a:defRPr sz="900">
                 <a:solidFill>
                   <a:srgbClr val="334155"/>
                 </a:solidFill>
               </a:defRPr>
             </a:pPr>
             <a:r>
-              <a:t>- Layer 1 (Reflex): Fast local/edge filter. Handles AST syntax, regex gates, and pre-flight probes with sub-second latency.</a:t>
+              <a:t>- Tier 0: Foundations: Sub-second skills (Storage, Senses, Motor). IMAGINES (Toy Bedrock), VETOES (WAF/Budgets), REMEMBERS (DynamoDB/ElastiCache), ACTS (Lambda), SIGNALS (EventBridge).</a:t>
             </a:r>
           </a:p>
           <a:p>
             <a:pPr>
-              <a:defRPr sz="950">
+              <a:defRPr sz="900">
                 <a:solidFill>
                   <a:srgbClr val="334155"/>
                 </a:solidFill>
               </a:defRPr>
             </a:pPr>
             <a:r>
-              <a:t>- Layer 2 (Deliberation): Heavyweight deliberative LLMs (Claude Sonnet 4.6). Engaged only for complex synthesis, algorithmic proofs, and code diffs.</a:t>
+              <a:t>- Tier 1: Executive Mind: One Agent Mind deliberative control. DECIDES (SQS Priority), PLANS (Step Functions), SELF-CHECKS (Circuit Breaker), GROUNDS ITSELF (CloudWatch).</a:t>
             </a:r>
           </a:p>
           <a:p>
             <a:pPr>
-              <a:defRPr sz="950">
+              <a:defRPr sz="900">
                 <a:solidFill>
                   <a:srgbClr val="334155"/>
                 </a:solidFill>
               </a:defRPr>
             </a:pPr>
             <a:r>
-              <a:t>- Layer 3 (Meta-Cognitive): The Executive Monitor. Maintains long-term Knowledge Graph memory, verifies goal alignment, and halts runaways.</a:t>
+              <a:t>- Tier 2: Networked Brain: Multi-Agent Team coordination. CONNECTS (SNS Fan-out), SHARES (Mutex Board), STAYS STABLE (Quorum Vote).</a:t>
             </a:r>
           </a:p>
           <a:p>
             <a:pPr>
-              <a:defRPr sz="950">
+              <a:defRPr sz="900">
                 <a:solidFill>
                   <a:srgbClr val="334155"/>
                 </a:solidFill>
               </a:defRPr>
             </a:pPr>
             <a:r>
-              <a:t>- Core Takeaway: Stop waking heavy frontier models to verify if a semicolon exists!</a:t>
+              <a:t>- Core Guarantee: Never wake a heavy frontier LLM to check if a semicolon or IAM policy is valid!</a:t>
             </a:r>
           </a:p>
         </p:txBody>
       </p:sp>
       <p:pic>
         <p:nvPicPr>
-          <p:cNvPr id="7" name="Picture 6" descr="diag_brain.png"/>
+          <p:cNvPr id="6" name="Picture 5" descr="diag_pyramid.png"/>
           <p:cNvPicPr>
             <a:picLocks noChangeAspect="1"/>
           </p:cNvPicPr>
@@ -4329,7 +4267,7 @@
         <p:spPr>
           <a:xfrm>
             <a:off x="4754880" y="1234440"/>
-            <a:ext cx="6705295" cy="4158696"/>
+            <a:ext cx="6705295" cy="4174691"/>
           </a:xfrm>
           <a:prstGeom prst="rect">
             <a:avLst/>
@@ -4369,12 +4307,10 @@
             <a:avLst/>
           </a:prstGeom>
           <a:solidFill>
-            <a:srgbClr val="FFFFFF"/>
+            <a:srgbClr val="0F172A"/>
           </a:solidFill>
-          <a:ln w="12700">
-            <a:solidFill>
-              <a:srgbClr val="E2E8F0"/>
-            </a:solidFill>
+          <a:ln>
+            <a:noFill/>
           </a:ln>
         </p:spPr>
         <p:style>
@@ -4407,8 +4343,8 @@
         </p:nvSpPr>
         <p:spPr>
           <a:xfrm>
-            <a:off x="731520" y="164592"/>
-            <a:ext cx="2103120" cy="292608"/>
+            <a:off x="731520" y="201168"/>
+            <a:ext cx="1645920" cy="292608"/>
           </a:xfrm>
           <a:prstGeom prst="roundRect">
             <a:avLst/>
@@ -4439,7 +4375,7 @@
           <a:lstStyle/>
           <a:p>
             <a:pPr algn="ctr">
-              <a:defRPr sz="950" b="1">
+              <a:defRPr sz="850" b="1">
                 <a:solidFill>
                   <a:srgbClr val="FFFFFF"/>
                 </a:solidFill>
@@ -4459,8 +4395,8 @@
         </p:nvSpPr>
         <p:spPr>
           <a:xfrm>
-            <a:off x="3017520" y="91440"/>
-            <a:ext cx="8686800" cy="457200"/>
+            <a:off x="2514600" y="109728"/>
+            <a:ext cx="8961120" cy="868680"/>
           </a:xfrm>
           <a:prstGeom prst="rect">
             <a:avLst/>
@@ -4468,62 +4404,39 @@
           <a:noFill/>
         </p:spPr>
         <p:txBody>
-          <a:bodyPr wrap="square" lIns="182880" rIns="182880" tIns="182880" bIns="182880">
+          <a:bodyPr wrap="square" lIns="182880" rIns="182880" bIns="182880">
             <a:spAutoFit/>
           </a:bodyPr>
           <a:lstStyle/>
           <a:p>
             <a:pPr>
-              <a:defRPr sz="2000" b="1">
-                <a:solidFill>
-                  <a:srgbClr val="0F172A"/>
-                </a:solidFill>
-              </a:defRPr>
-            </a:pPr>
-            <a:r>
-              <a:t>The AI Factory &amp; Assembly Workers</a:t>
-            </a:r>
-          </a:p>
-        </p:txBody>
-      </p:sp>
-      <p:sp>
-        <p:nvSpPr>
-          <p:cNvPr id="5" name="TextBox 4"/>
-          <p:cNvSpPr txBox="1"/>
-          <p:nvPr/>
-        </p:nvSpPr>
-        <p:spPr>
-          <a:xfrm>
-            <a:off x="731520" y="530352"/>
-            <a:ext cx="10789920" cy="411480"/>
-          </a:xfrm>
-          <a:prstGeom prst="rect">
-            <a:avLst/>
-          </a:prstGeom>
-          <a:noFill/>
-        </p:spPr>
-        <p:txBody>
-          <a:bodyPr wrap="square" lIns="182880" rIns="182880" tIns="182880" bIns="182880">
-            <a:spAutoFit/>
-          </a:bodyPr>
-          <a:lstStyle/>
+              <a:defRPr sz="1700" b="1">
+                <a:solidFill>
+                  <a:srgbClr val="FFFFFF"/>
+                </a:solidFill>
+              </a:defRPr>
+            </a:pPr>
+            <a:r>
+              <a:t>The AI Factory &amp; Assembly Worker BOM</a:t>
+            </a:r>
+          </a:p>
           <a:p>
             <a:pPr>
-              <a:defRPr sz="1100">
-                <a:solidFill>
-                  <a:srgbClr val="64748B"/>
-                </a:solidFill>
-              </a:defRPr>
-            </a:pPr>
-            <a:r>
-              <a:t>Replacing artisanal prompt crafting with standardized assembly lines and specialized worker roles</a:t>
-            </a:r>
-          </a:p>
-        </p:txBody>
-      </p:sp>
-      <p:sp>
-        <p:nvSpPr>
-          <p:cNvPr id="6" name="Rounded Rectangle 5"/>
+              <a:defRPr sz="950">
+                <a:solidFill>
+                  <a:srgbClr val="94A3B8"/>
+                </a:solidFill>
+              </a:defRPr>
+            </a:pPr>
+            <a:r>
+              <a:t>Replacing artisanal prompt crafting with standardized assembly lines and certified parts</a:t>
+            </a:r>
+          </a:p>
+        </p:txBody>
+      </p:sp>
+      <p:sp>
+        <p:nvSpPr>
+          <p:cNvPr id="5" name="Rounded Rectangle 4"/>
           <p:cNvSpPr/>
           <p:nvPr/>
         </p:nvSpPr>
@@ -4575,55 +4488,55 @@
           </a:p>
           <a:p>
             <a:pPr>
-              <a:defRPr sz="919">
+              <a:defRPr sz="900">
                 <a:solidFill>
                   <a:srgbClr val="334155"/>
                 </a:solidFill>
               </a:defRPr>
             </a:pPr>
             <a:r>
-              <a:t>- The Assembly Metaphor: Henry Ford didn't build cars by shouting vague verbal orders. He built a conveyor belt with specialized stations and strict tollgates.</a:t>
+              <a:t>- The Assembly Metaphor: Henry Ford built cars via standardized conveyor lines with strict stations. The AI Factory treats agents as specialized workers on an assembly line.</a:t>
             </a:r>
           </a:p>
           <a:p>
             <a:pPr>
-              <a:defRPr sz="919">
+              <a:defRPr sz="900">
                 <a:solidFill>
                   <a:srgbClr val="334155"/>
                 </a:solidFill>
               </a:defRPr>
             </a:pPr>
             <a:r>
-              <a:t>- Assembly Workers: Specialized agents (Architect, Coder, Verifier) execute discrete tasks with clean contracts (&lt;50 lines).</a:t>
+              <a:t>- Parts Catalog (BOM): Agents are constructed by selecting modular building blocks from the 3-Tier Cognitive Pyramid (Bill of Materials).</a:t>
             </a:r>
           </a:p>
           <a:p>
             <a:pPr>
-              <a:defRPr sz="919">
+              <a:defRPr sz="900">
                 <a:solidFill>
                   <a:srgbClr val="334155"/>
                 </a:solidFill>
               </a:defRPr>
             </a:pPr>
             <a:r>
-              <a:t>- Deterministic Gates: AI is probabilistic; code execution is deterministic. The factory wraps LLMs in rigid 48/48 CI matrix tests.</a:t>
+              <a:t>- Small-Step Units: Macro intents are decomposed into atomic micro-tasks (&lt;50 lines) with explicit OpenAPI contracts, eliminating context bloat.</a:t>
             </a:r>
           </a:p>
           <a:p>
             <a:pPr>
-              <a:defRPr sz="919">
+              <a:defRPr sz="900">
                 <a:solidFill>
                   <a:srgbClr val="334155"/>
                 </a:solidFill>
               </a:defRPr>
             </a:pPr>
             <a:r>
-              <a:t>- Automated Testing VM: GitHub Actions runners act as robotic inspectors, auditing diffs for secrets and syntax drift before commit.</a:t>
+              <a:t>- Deterministic Gates: AI is probabilistic; code verification is deterministic. The factory wraps LLMs in rigid 48/48 CI matrix tests.</a:t>
             </a:r>
           </a:p>
           <a:p>
             <a:pPr>
-              <a:defRPr sz="919">
+              <a:defRPr sz="900">
                 <a:solidFill>
                   <a:srgbClr val="334155"/>
                 </a:solidFill>
@@ -4635,7 +4548,7 @@
           </a:p>
           <a:p>
             <a:pPr>
-              <a:defRPr sz="919">
+              <a:defRPr sz="900">
                 <a:solidFill>
                   <a:srgbClr val="334155"/>
                 </a:solidFill>
@@ -4649,7 +4562,7 @@
       </p:sp>
       <p:pic>
         <p:nvPicPr>
-          <p:cNvPr id="7" name="Picture 6" descr="diag_factory_sop.png"/>
+          <p:cNvPr id="6" name="Picture 5" descr="diag_factory.png"/>
           <p:cNvPicPr>
             <a:picLocks noChangeAspect="1"/>
           </p:cNvPicPr>
@@ -4664,7 +4577,7 @@
         <p:spPr>
           <a:xfrm>
             <a:off x="4754880" y="1234440"/>
-            <a:ext cx="6705295" cy="4084835"/>
+            <a:ext cx="6705295" cy="4086792"/>
           </a:xfrm>
           <a:prstGeom prst="rect">
             <a:avLst/>
@@ -4704,12 +4617,10 @@
             <a:avLst/>
           </a:prstGeom>
           <a:solidFill>
-            <a:srgbClr val="FFFFFF"/>
+            <a:srgbClr val="0F172A"/>
           </a:solidFill>
-          <a:ln w="12700">
-            <a:solidFill>
-              <a:srgbClr val="E2E8F0"/>
-            </a:solidFill>
+          <a:ln>
+            <a:noFill/>
           </a:ln>
         </p:spPr>
         <p:style>
@@ -4742,8 +4653,8 @@
         </p:nvSpPr>
         <p:spPr>
           <a:xfrm>
-            <a:off x="731520" y="164592"/>
-            <a:ext cx="2103120" cy="292608"/>
+            <a:off x="731520" y="201168"/>
+            <a:ext cx="1645920" cy="292608"/>
           </a:xfrm>
           <a:prstGeom prst="roundRect">
             <a:avLst/>
@@ -4774,7 +4685,7 @@
           <a:lstStyle/>
           <a:p>
             <a:pPr algn="ctr">
-              <a:defRPr sz="950" b="1">
+              <a:defRPr sz="850" b="1">
                 <a:solidFill>
                   <a:srgbClr val="FFFFFF"/>
                 </a:solidFill>
@@ -4794,8 +4705,8 @@
         </p:nvSpPr>
         <p:spPr>
           <a:xfrm>
-            <a:off x="3017520" y="91440"/>
-            <a:ext cx="8686800" cy="457200"/>
+            <a:off x="2514600" y="109728"/>
+            <a:ext cx="8961120" cy="868680"/>
           </a:xfrm>
           <a:prstGeom prst="rect">
             <a:avLst/>
@@ -4803,62 +4714,39 @@
           <a:noFill/>
         </p:spPr>
         <p:txBody>
-          <a:bodyPr wrap="square" lIns="182880" rIns="182880" tIns="182880" bIns="182880">
+          <a:bodyPr wrap="square" lIns="182880" rIns="182880" bIns="182880">
             <a:spAutoFit/>
           </a:bodyPr>
           <a:lstStyle/>
           <a:p>
             <a:pPr>
-              <a:defRPr sz="2000" b="1">
-                <a:solidFill>
-                  <a:srgbClr val="0F172A"/>
-                </a:solidFill>
-              </a:defRPr>
-            </a:pPr>
-            <a:r>
-              <a:t>Ambient AI: The 5 Pillars of Invisible Ergonomics</a:t>
-            </a:r>
-          </a:p>
-        </p:txBody>
-      </p:sp>
-      <p:sp>
-        <p:nvSpPr>
-          <p:cNvPr id="5" name="TextBox 4"/>
-          <p:cNvSpPr txBox="1"/>
-          <p:nvPr/>
-        </p:nvSpPr>
-        <p:spPr>
-          <a:xfrm>
-            <a:off x="731520" y="530352"/>
-            <a:ext cx="10789920" cy="411480"/>
-          </a:xfrm>
-          <a:prstGeom prst="rect">
-            <a:avLst/>
-          </a:prstGeom>
-          <a:noFill/>
-        </p:spPr>
-        <p:txBody>
-          <a:bodyPr wrap="square" lIns="182880" rIns="182880" tIns="182880" bIns="182880">
-            <a:spAutoFit/>
-          </a:bodyPr>
-          <a:lstStyle/>
+              <a:defRPr sz="1700" b="1">
+                <a:solidFill>
+                  <a:srgbClr val="FFFFFF"/>
+                </a:solidFill>
+              </a:defRPr>
+            </a:pPr>
+            <a:r>
+              <a:t>Unifying Multi-Time Scales via Continuous CI/CD</a:t>
+            </a:r>
+          </a:p>
           <a:p>
             <a:pPr>
-              <a:defRPr sz="1100">
-                <a:solidFill>
-                  <a:srgbClr val="64748B"/>
-                </a:solidFill>
-              </a:defRPr>
-            </a:pPr>
-            <a:r>
-              <a:t>Moving from active prompt manipulation to quiet, ambient background autonomy</a:t>
-            </a:r>
-          </a:p>
-        </p:txBody>
-      </p:sp>
-      <p:sp>
-        <p:nvSpPr>
-          <p:cNvPr id="6" name="Rounded Rectangle 5"/>
+              <a:defRPr sz="950">
+                <a:solidFill>
+                  <a:srgbClr val="94A3B8"/>
+                </a:solidFill>
+              </a:defRPr>
+            </a:pPr>
+            <a:r>
+              <a:t>Bridging the Design Long Time Scale and Operation Short Time Scale without release silos</a:t>
+            </a:r>
+          </a:p>
+        </p:txBody>
+      </p:sp>
+      <p:sp>
+        <p:nvSpPr>
+          <p:cNvPr id="5" name="Rounded Rectangle 4"/>
           <p:cNvSpPr/>
           <p:nvPr/>
         </p:nvSpPr>
@@ -4905,74 +4793,74 @@
               </a:defRPr>
             </a:pPr>
             <a:r>
-              <a:t>What is Ambient AI?</a:t>
+              <a:t>Two Time Scales, One Loop</a:t>
             </a:r>
           </a:p>
           <a:p>
             <a:pPr>
-              <a:defRPr sz="950">
+              <a:defRPr sz="919">
                 <a:solidFill>
                   <a:srgbClr val="334155"/>
                 </a:solidFill>
               </a:defRPr>
             </a:pPr>
             <a:r>
-              <a:t>- Invisible Autonomy: AI shouldn't demand your constant attention. It should operate like electricity: always on, reliable, invisible until called.</a:t>
+              <a:t>- Design Long Time Scale: Agents are designed, prompted, tested, and assembled into worker teams. Occurs over hours to days in Git.</a:t>
             </a:r>
           </a:p>
           <a:p>
             <a:pPr>
-              <a:defRPr sz="950">
+              <a:defRPr sz="919">
                 <a:solidFill>
                   <a:srgbClr val="334155"/>
                 </a:solidFill>
               </a:defRPr>
             </a:pPr>
             <a:r>
-              <a:t>- Zero Context Bloat: Instead of dumping 100,000 tokens into every turn, context is managed as an active Directed Acyclic Graph (DAG).</a:t>
+              <a:t>- Operation Short Time Scale: Live events trigger Lambda ingress, Step Functions workflows, and Bedrock inference in milliseconds.</a:t>
             </a:r>
           </a:p>
           <a:p>
             <a:pPr>
-              <a:defRPr sz="950">
+              <a:defRPr sz="919">
                 <a:solidFill>
                   <a:srgbClr val="334155"/>
                 </a:solidFill>
               </a:defRPr>
             </a:pPr>
             <a:r>
-              <a:t>- Evolution to Skills: When an agent discovers a reliable workflow, it packages it into a permanent SKILL.md so it never has to re-learn it.</a:t>
+              <a:t>- No Dev/QA/Prod Silos: Instead of rigid release freezes, CI/CD runs as a continuous nervous system with automated 48/48 test matrix verification.</a:t>
             </a:r>
           </a:p>
           <a:p>
             <a:pPr>
-              <a:defRPr sz="950">
+              <a:defRPr sz="919">
                 <a:solidFill>
                   <a:srgbClr val="334155"/>
                 </a:solidFill>
               </a:defRPr>
             </a:pPr>
             <a:r>
-              <a:t>- Reversible Safety: Total psychological safety: any change can be rolled back in one click via atomic Git branches.</a:t>
+              <a:t>- Human-by-Exception: The pipeline deploys autonomously, pausing only if an architectural invariant or budget limit is breached.</a:t>
             </a:r>
           </a:p>
           <a:p>
             <a:pPr>
-              <a:defRPr sz="950">
+              <a:defRPr sz="919">
                 <a:solidFill>
                   <a:srgbClr val="334155"/>
                 </a:solidFill>
               </a:defRPr>
             </a:pPr>
             <a:r>
-              <a:t>- Core Takeaway: The ultimate luxury in AI is not a chatbox - it's not having to chat at all!</a:t>
+              <a:t>- Closed-Loop Feedback: CloudWatch failure telemetry and circuit-breaker trips feed directly back into agent redesign as new evaluation suites.</a:t>
             </a:r>
           </a:p>
         </p:txBody>
       </p:sp>
       <p:pic>
         <p:nvPicPr>
-          <p:cNvPr id="7" name="Picture 6" descr="diag_ambient_pillars.png"/>
+          <p:cNvPr id="6" name="Picture 5" descr="diag_multitimescale.png"/>
           <p:cNvPicPr>
             <a:picLocks noChangeAspect="1"/>
           </p:cNvPicPr>
@@ -5027,12 +4915,10 @@
             <a:avLst/>
           </a:prstGeom>
           <a:solidFill>
-            <a:srgbClr val="FFFFFF"/>
+            <a:srgbClr val="0F172A"/>
           </a:solidFill>
-          <a:ln w="12700">
-            <a:solidFill>
-              <a:srgbClr val="E2E8F0"/>
-            </a:solidFill>
+          <a:ln>
+            <a:noFill/>
           </a:ln>
         </p:spPr>
         <p:style>
@@ -5065,8 +4951,8 @@
         </p:nvSpPr>
         <p:spPr>
           <a:xfrm>
-            <a:off x="731520" y="164592"/>
-            <a:ext cx="2103120" cy="292608"/>
+            <a:off x="731520" y="201168"/>
+            <a:ext cx="1645920" cy="292608"/>
           </a:xfrm>
           <a:prstGeom prst="roundRect">
             <a:avLst/>
@@ -5097,7 +4983,7 @@
           <a:lstStyle/>
           <a:p>
             <a:pPr algn="ctr">
-              <a:defRPr sz="950" b="1">
+              <a:defRPr sz="850" b="1">
                 <a:solidFill>
                   <a:srgbClr val="FFFFFF"/>
                 </a:solidFill>
@@ -5117,8 +5003,8 @@
         </p:nvSpPr>
         <p:spPr>
           <a:xfrm>
-            <a:off x="3017520" y="91440"/>
-            <a:ext cx="8686800" cy="457200"/>
+            <a:off x="2514600" y="109728"/>
+            <a:ext cx="8961120" cy="868680"/>
           </a:xfrm>
           <a:prstGeom prst="rect">
             <a:avLst/>
@@ -5126,62 +5012,39 @@
           <a:noFill/>
         </p:spPr>
         <p:txBody>
-          <a:bodyPr wrap="square" lIns="182880" rIns="182880" tIns="182880" bIns="182880">
+          <a:bodyPr wrap="square" lIns="182880" rIns="182880" bIns="182880">
             <a:spAutoFit/>
           </a:bodyPr>
           <a:lstStyle/>
           <a:p>
             <a:pPr>
-              <a:defRPr sz="2000" b="1">
-                <a:solidFill>
-                  <a:srgbClr val="0F172A"/>
-                </a:solidFill>
-              </a:defRPr>
-            </a:pPr>
-            <a:r>
-              <a:t>The North Star: Minimizing Human Cognitive Load</a:t>
-            </a:r>
-          </a:p>
-        </p:txBody>
-      </p:sp>
-      <p:sp>
-        <p:nvSpPr>
-          <p:cNvPr id="5" name="TextBox 4"/>
-          <p:cNvSpPr txBox="1"/>
-          <p:nvPr/>
-        </p:nvSpPr>
-        <p:spPr>
-          <a:xfrm>
-            <a:off x="731520" y="530352"/>
-            <a:ext cx="10789920" cy="411480"/>
-          </a:xfrm>
-          <a:prstGeom prst="rect">
-            <a:avLst/>
-          </a:prstGeom>
-          <a:noFill/>
-        </p:spPr>
-        <p:txBody>
-          <a:bodyPr wrap="square" lIns="182880" rIns="182880" tIns="182880" bIns="182880">
-            <a:spAutoFit/>
-          </a:bodyPr>
-          <a:lstStyle/>
+              <a:defRPr sz="1700" b="1">
+                <a:solidFill>
+                  <a:srgbClr val="FFFFFF"/>
+                </a:solidFill>
+              </a:defRPr>
+            </a:pPr>
+            <a:r>
+              <a:t>Ambient AI &amp; Minimizing Human Cognitive Load</a:t>
+            </a:r>
+          </a:p>
           <a:p>
             <a:pPr>
-              <a:defRPr sz="1100">
-                <a:solidFill>
-                  <a:srgbClr val="64748B"/>
-                </a:solidFill>
-              </a:defRPr>
-            </a:pPr>
-            <a:r>
-              <a:t>Transforming human operators from stressed micromanagers into confident directors</a:t>
-            </a:r>
-          </a:p>
-        </p:txBody>
-      </p:sp>
-      <p:sp>
-        <p:nvSpPr>
-          <p:cNvPr id="6" name="Rounded Rectangle 5"/>
+              <a:defRPr sz="950">
+                <a:solidFill>
+                  <a:srgbClr val="94A3B8"/>
+                </a:solidFill>
+              </a:defRPr>
+            </a:pPr>
+            <a:r>
+              <a:t>Transforming human operators from stressed babysitters into confident executive directors</a:t>
+            </a:r>
+          </a:p>
+        </p:txBody>
+      </p:sp>
+      <p:sp>
+        <p:nvSpPr>
+          <p:cNvPr id="5" name="Rounded Rectangle 4"/>
           <p:cNvSpPr/>
           <p:nvPr/>
         </p:nvSpPr>
@@ -5233,45 +5096,45 @@
           </a:p>
           <a:p>
             <a:pPr>
-              <a:defRPr sz="919">
+              <a:defRPr sz="900">
                 <a:solidFill>
                   <a:srgbClr val="991B1B"/>
                 </a:solidFill>
               </a:defRPr>
             </a:pPr>
             <a:r>
-              <a:t>- Context Exhaustion: Paste stack traces, re-read code diffs, re-prompt.</a:t>
+              <a:t>- Context Exhaustion: Pasting stack traces, re-reading code diffs, constant re-prompting.</a:t>
             </a:r>
           </a:p>
           <a:p>
             <a:pPr>
-              <a:defRPr sz="919">
+              <a:defRPr sz="900">
                 <a:solidFill>
                   <a:srgbClr val="991B1B"/>
                 </a:solidFill>
               </a:defRPr>
             </a:pPr>
             <a:r>
-              <a:t>- Manual Babysitting: Anxiously inspect every single line &amp; syntax output.</a:t>
+              <a:t>- Manual Babysitting: Anxiously inspecting every single line &amp; syntax output.</a:t>
             </a:r>
           </a:p>
           <a:p>
             <a:pPr>
-              <a:defRPr sz="919">
+              <a:defRPr sz="900">
                 <a:solidFill>
                   <a:srgbClr val="991B1B"/>
                 </a:solidFill>
               </a:defRPr>
             </a:pPr>
             <a:r>
-              <a:t>- Mental Burnout: 40+ context switches/hour causing extreme fatigue.</a:t>
-            </a:r>
-          </a:p>
-        </p:txBody>
-      </p:sp>
-      <p:sp>
-        <p:nvSpPr>
-          <p:cNvPr id="7" name="Rounded Rectangle 6"/>
+              <a:t>- Mental Burnout: 40+ context switches/hour causing extreme cognitive fatigue.</a:t>
+            </a:r>
+          </a:p>
+        </p:txBody>
+      </p:sp>
+      <p:sp>
+        <p:nvSpPr>
+          <p:cNvPr id="6" name="Rounded Rectangle 5"/>
           <p:cNvSpPr/>
           <p:nvPr/>
         </p:nvSpPr>
@@ -5323,7 +5186,7 @@
           </a:p>
           <a:p>
             <a:pPr>
-              <a:defRPr sz="919">
+              <a:defRPr sz="900">
                 <a:solidFill>
                   <a:srgbClr val="065F46"/>
                 </a:solidFill>
@@ -5335,45 +5198,45 @@
           </a:p>
           <a:p>
             <a:pPr>
-              <a:defRPr sz="919">
+              <a:defRPr sz="900">
                 <a:solidFill>
                   <a:srgbClr val="065F46"/>
                 </a:solidFill>
               </a:defRPr>
             </a:pPr>
             <a:r>
-              <a:t>- Autonomous Execution: Context DAG routes state, executes 48/48 CI matrix.</a:t>
+              <a:t>- Context DAG &amp; Skills: Zero token bloat; successful patterns become permanent SKILL.md.</a:t>
             </a:r>
           </a:p>
           <a:p>
             <a:pPr>
-              <a:defRPr sz="919">
+              <a:defRPr sz="900">
                 <a:solidFill>
                   <a:srgbClr val="065F46"/>
                 </a:solidFill>
               </a:defRPr>
             </a:pPr>
             <a:r>
-              <a:t>- Reversible Safety: One-button rollback safety net + signed receipts.</a:t>
+              <a:t>- Reversible Safety: One-button rollback safety net + signed cryptographic receipts.</a:t>
             </a:r>
           </a:p>
           <a:p>
             <a:pPr>
-              <a:defRPr sz="919">
+              <a:defRPr sz="900">
                 <a:solidFill>
                   <a:srgbClr val="065F46"/>
                 </a:solidFill>
               </a:defRPr>
             </a:pPr>
             <a:r>
-              <a:t>- Proven Result: -88% cognitive mental fatigue eliminated!</a:t>
+              <a:t>- Proven Result: -88% human cognitive burden eliminated in daily engineering!</a:t>
             </a:r>
           </a:p>
         </p:txBody>
       </p:sp>
       <p:pic>
         <p:nvPicPr>
-          <p:cNvPr id="8" name="Picture 7" descr="diag_cognitive_load.png"/>
+          <p:cNvPr id="7" name="Picture 6" descr="diag_ambient_load.png"/>
           <p:cNvPicPr>
             <a:picLocks noChangeAspect="1"/>
           </p:cNvPicPr>
@@ -5388,7 +5251,7 @@
         <p:spPr>
           <a:xfrm>
             <a:off x="4754880" y="1234440"/>
-            <a:ext cx="6705295" cy="3930690"/>
+            <a:ext cx="6705295" cy="3993811"/>
           </a:xfrm>
           <a:prstGeom prst="rect">
             <a:avLst/>
@@ -5428,12 +5291,10 @@
             <a:avLst/>
           </a:prstGeom>
           <a:solidFill>
-            <a:srgbClr val="FFFFFF"/>
+            <a:srgbClr val="0F172A"/>
           </a:solidFill>
-          <a:ln w="12700">
-            <a:solidFill>
-              <a:srgbClr val="E2E8F0"/>
-            </a:solidFill>
+          <a:ln>
+            <a:noFill/>
           </a:ln>
         </p:spPr>
         <p:style>
@@ -5466,8 +5327,8 @@
         </p:nvSpPr>
         <p:spPr>
           <a:xfrm>
-            <a:off x="731520" y="164592"/>
-            <a:ext cx="2103120" cy="292608"/>
+            <a:off x="731520" y="201168"/>
+            <a:ext cx="1645920" cy="292608"/>
           </a:xfrm>
           <a:prstGeom prst="roundRect">
             <a:avLst/>
@@ -5498,7 +5359,7 @@
           <a:lstStyle/>
           <a:p>
             <a:pPr algn="ctr">
-              <a:defRPr sz="950" b="1">
+              <a:defRPr sz="850" b="1">
                 <a:solidFill>
                   <a:srgbClr val="FFFFFF"/>
                 </a:solidFill>
@@ -5518,8 +5379,8 @@
         </p:nvSpPr>
         <p:spPr>
           <a:xfrm>
-            <a:off x="3017520" y="91440"/>
-            <a:ext cx="8686800" cy="457200"/>
+            <a:off x="2514600" y="109728"/>
+            <a:ext cx="8961120" cy="868680"/>
           </a:xfrm>
           <a:prstGeom prst="rect">
             <a:avLst/>
@@ -5527,15 +5388,15 @@
           <a:noFill/>
         </p:spPr>
         <p:txBody>
-          <a:bodyPr wrap="square" lIns="182880" rIns="182880" tIns="182880" bIns="182880">
+          <a:bodyPr wrap="square" lIns="182880" rIns="182880" bIns="182880">
             <a:spAutoFit/>
           </a:bodyPr>
           <a:lstStyle/>
           <a:p>
             <a:pPr>
-              <a:defRPr sz="2000" b="1">
-                <a:solidFill>
-                  <a:srgbClr val="0F172A"/>
+              <a:defRPr sz="1700" b="1">
+                <a:solidFill>
+                  <a:srgbClr val="FFFFFF"/>
                 </a:solidFill>
               </a:defRPr>
             </a:pPr>
@@ -5543,34 +5404,11 @@
               <a:t>Production Tech Stack &amp; Cloud Architecture</a:t>
             </a:r>
           </a:p>
-        </p:txBody>
-      </p:sp>
-      <p:sp>
-        <p:nvSpPr>
-          <p:cNvPr id="5" name="TextBox 4"/>
-          <p:cNvSpPr txBox="1"/>
-          <p:nvPr/>
-        </p:nvSpPr>
-        <p:spPr>
-          <a:xfrm>
-            <a:off x="731520" y="530352"/>
-            <a:ext cx="10789920" cy="411480"/>
-          </a:xfrm>
-          <a:prstGeom prst="rect">
-            <a:avLst/>
-          </a:prstGeom>
-          <a:noFill/>
-        </p:spPr>
-        <p:txBody>
-          <a:bodyPr wrap="square" lIns="182880" rIns="182880" tIns="182880" bIns="182880">
-            <a:spAutoFit/>
-          </a:bodyPr>
-          <a:lstStyle/>
           <a:p>
             <a:pPr>
-              <a:defRPr sz="1100">
-                <a:solidFill>
-                  <a:srgbClr val="64748B"/>
+              <a:defRPr sz="950">
+                <a:solidFill>
+                  <a:srgbClr val="94A3B8"/>
                 </a:solidFill>
               </a:defRPr>
             </a:pPr>
@@ -5582,7 +5420,7 @@
       </p:sp>
       <p:pic>
         <p:nvPicPr>
-          <p:cNvPr id="6" name="Picture 5" descr="diag_tech_stack.png"/>
+          <p:cNvPr id="5" name="Picture 4" descr="diag_tech_stack.png"/>
           <p:cNvPicPr>
             <a:picLocks noChangeAspect="1"/>
           </p:cNvPicPr>
@@ -5606,7 +5444,7 @@
       </p:pic>
       <p:sp>
         <p:nvSpPr>
-          <p:cNvPr id="7" name="Rounded Rectangle 6"/>
+          <p:cNvPr id="6" name="Rounded Rectangle 5"/>
           <p:cNvSpPr/>
           <p:nvPr/>
         </p:nvSpPr>
@@ -5666,7 +5504,7 @@
               </a:defRPr>
             </a:pPr>
             <a:r>
-              <a:t>Tier 1: Sub-Second Reflex</a:t>
+              <a:t>Client Reflex (L1)</a:t>
             </a:r>
           </a:p>
           <a:p>
@@ -5678,7 +5516,7 @@
               </a:defRPr>
             </a:pPr>
             <a:r>
-              <a:t>Local AST parsing &amp; regex filters absorb routine syntax probes before cloud API invocation.</a:t>
+              <a:t>Local WebGPU (WebLLM) and PyScript WASM absorb routine syntax probes in-browser.</a:t>
             </a:r>
           </a:p>
           <a:p>
@@ -5691,7 +5529,7 @@
               </a:defRPr>
             </a:pPr>
             <a:r>
-              <a:t>Tier 2: Deterministic CI</a:t>
+              <a:t>GitHub Factory (L2)</a:t>
             </a:r>
           </a:p>
           <a:p>
@@ -5703,7 +5541,7 @@
               </a:defRPr>
             </a:pPr>
             <a:r>
-              <a:t>48/48 automated assertions on clean-room virtual runners before merge.</a:t>
+              <a:t>48/48 CI matrix tests, CodeQL scans, and high-signal PR decision cards.</a:t>
             </a:r>
           </a:p>
           <a:p>
@@ -5711,12 +5549,12 @@
             <a:pPr>
               <a:defRPr b="1" sz="950">
                 <a:solidFill>
-                  <a:srgbClr val="D97706"/>
-                </a:solidFill>
-              </a:defRPr>
-            </a:pPr>
-            <a:r>
-              <a:t>Tier 3: AWS us-east-2</a:t>
+                  <a:srgbClr val="059669"/>
+                </a:solidFill>
+              </a:defRPr>
+            </a:pPr>
+            <a:r>
+              <a:t>AWS us-east-2 (L3)</a:t>
             </a:r>
           </a:p>
           <a:p>
@@ -5728,7 +5566,7 @@
               </a:defRPr>
             </a:pPr>
             <a:r>
-              <a:t>Lambda HTTPS gateway, Step Functions state machine, Bedrock Claude Sonnet, and KMS S3.</a:t>
+              <a:t>Step Functions (cosmos-cicd-ai-pipeline-sfn) executing Lambda &amp; Amazon Bedrock Claude Sonnet 4.6.</a:t>
             </a:r>
           </a:p>
           <a:p>
@@ -5736,12 +5574,12 @@
             <a:pPr>
               <a:defRPr b="1" sz="950">
                 <a:solidFill>
-                  <a:srgbClr val="059669"/>
-                </a:solidFill>
-              </a:defRPr>
-            </a:pPr>
-            <a:r>
-              <a:t>Tier 4: Cognitive Memory</a:t>
+                  <a:srgbClr val="D97706"/>
+                </a:solidFill>
+              </a:defRPr>
+            </a:pPr>
+            <a:r>
+              <a:t>Durable Security</a:t>
             </a:r>
           </a:p>
           <a:p>
@@ -5753,7 +5591,7 @@
               </a:defRPr>
             </a:pPr>
             <a:r>
-              <a:t>Vector DB cosine embeddings + Knowledge Graph Cypher multi-hop traversal.</a:t>
+              <a:t>Amazon S3 KMS encryption with signed execution receipts and atomic rollback.</a:t>
             </a:r>
           </a:p>
         </p:txBody>
@@ -5818,101 +5656,64 @@
           <a:lstStyle/>
           <a:p>
             <a:pPr algn="ctr">
-              <a:defRPr sz="1400" b="1">
+              <a:defRPr sz="1500" b="1">
                 <a:solidFill>
                   <a:srgbClr val="34D399"/>
                 </a:solidFill>
               </a:defRPr>
             </a:pPr>
             <a:r>
-              <a:t>THE FUTURE OF AUTONOMOUS SYSTEMS</a:t>
+              <a:t>THE NEW PARADIGM: AI FACTORY + AMBIENT CI/CD</a:t>
             </a:r>
           </a:p>
           <a:p>
             <a:pPr algn="ctr">
-              <a:defRPr sz="2800" b="1">
+              <a:defRPr sz="2600" b="1">
                 <a:solidFill>
                   <a:srgbClr val="FFFFFF"/>
                 </a:solidFill>
               </a:defRPr>
             </a:pPr>
             <a:r>
-              <a:t>From Chatting with Models to Conducting Orchestras</a:t>
+              <a:t>The AI Factory Builds the Minds. Ambient CI/CD Operates Them.</a:t>
             </a:r>
           </a:p>
           <a:p>
             <a:br/>
             <a:pPr algn="ctr">
-              <a:defRPr sz="1200" b="1">
+              <a:defRPr sz="1150">
                 <a:solidFill>
                   <a:srgbClr val="94A3B8"/>
                 </a:solidFill>
               </a:defRPr>
             </a:pPr>
             <a:r>
-              <a:t>Key Takeaways from Our Journey:</a:t>
+              <a:t>By unbundling cognition into a 3-tier pyramid, enforcing industrial assembly lines with atomic contracts (&lt;50 lines),</a:t>
             </a:r>
             <a:br/>
+            <a:r>
+              <a:t>and bridging design and operations continuously, I have eliminated 88% of human cognitive friction.</a:t>
+            </a:r>
+            <a:br/>
           </a:p>
           <a:p>
             <a:pPr algn="ctr">
-              <a:defRPr sz="1100">
-                <a:solidFill>
-                  <a:srgbClr val="F1F5F9"/>
-                </a:solidFill>
-              </a:defRPr>
-            </a:pPr>
-            <a:r>
-              <a:t>1. Lone agents hit context ceilings; 3-Layer Brains distribute cognition from instant reflexes to deep deliberation.</a:t>
-            </a:r>
-          </a:p>
-          <a:p>
-            <a:pPr algn="ctr">
-              <a:defRPr sz="1100">
-                <a:solidFill>
-                  <a:srgbClr val="F1F5F9"/>
-                </a:solidFill>
-              </a:defRPr>
-            </a:pPr>
-            <a:r>
-              <a:t>2. The AI Factory organizes assembly workers along a deterministic line to turn unpredictable LLM outputs into certified software.</a:t>
-            </a:r>
-          </a:p>
-          <a:p>
-            <a:pPr algn="ctr">
-              <a:defRPr sz="1100">
-                <a:solidFill>
-                  <a:srgbClr val="F1F5F9"/>
-                </a:solidFill>
-              </a:defRPr>
-            </a:pPr>
-            <a:r>
-              <a:t>3. Ambient AI makes the entire apparatus invisible: you speak your intent, and the system executes with total safety.</a:t>
-            </a:r>
-          </a:p>
-          <a:p>
-            <a:pPr algn="ctr">
-              <a:defRPr sz="1100">
-                <a:solidFill>
-                  <a:srgbClr val="F1F5F9"/>
-                </a:solidFill>
-              </a:defRPr>
-            </a:pPr>
-            <a:r>
-              <a:t>4. Minimizing human cognitive load is the ultimate north star: from anxious babysitting to high-leverage execution in 1 click.</a:t>
-            </a:r>
-          </a:p>
-          <a:p>
+              <a:defRPr sz="1100" b="1">
+                <a:solidFill>
+                  <a:srgbClr val="38BDF8"/>
+                </a:solidFill>
+              </a:defRPr>
+            </a:pPr>
+            <a:r>
+              <a:t>• Live Cloud Studio &amp; CI/CD: cosmosanalytics.github.io/AWS/</a:t>
+            </a:r>
             <a:br/>
-            <a:pPr algn="ctr">
-              <a:defRPr sz="1400" b="1">
-                <a:solidFill>
-                  <a:srgbClr val="38BDF8"/>
-                </a:solidFill>
-              </a:defRPr>
-            </a:pPr>
-            <a:r>
-              <a:t>"The best AI system is the one you don't have to micromanage."</a:t>
+            <a:r>
+              <a:t>• AI Factory &amp; Assembly Canvas: cosmosanalytics.github.io/uat-copilot-local/</a:t>
+            </a:r>
+            <a:br/>
+            <a:r>
+              <a:t>• Production AWS Project: For Each and Every (us-east-2 • 966273137102)</a:t>
             </a:r>
           </a:p>
         </p:txBody>

</xml_diff>

<commit_message>
docs: Expand Tech Showcase into Dual-Scale Architecture and AI-Human Interaction UI
</commit_message>
<xml_diff>
--- a/AI_Journey_Single_Agent_to_Ambient_Enterprise.pptx
+++ b/AI_Journey_Single_Agent_to_Ambient_Enterprise.pptx
@@ -14,6 +14,7 @@
     <p:sldId id="262" r:id="rId13"/>
     <p:sldId id="263" r:id="rId14"/>
     <p:sldId id="264" r:id="rId15"/>
+    <p:sldId id="265" r:id="rId16"/>
   </p:sldIdLst>
   <p:sldSz cx="12191695" cy="6858000" type="screen4x3"/>
   <p:notesSz cx="6858000" cy="9144000"/>
@@ -3238,6 +3239,128 @@
 </p:sld>
 </file>
 
+<file path=ppt/slides/slide10.xml><?xml version="1.0" encoding="utf-8"?>
+<p:sld xmlns:a="http://schemas.openxmlformats.org/drawingml/2006/main" xmlns:p="http://schemas.openxmlformats.org/presentationml/2006/main" xmlns:r="http://schemas.openxmlformats.org/officeDocument/2006/relationships">
+  <p:cSld>
+    <p:spTree>
+      <p:nvGrpSpPr>
+        <p:cNvPr id="1" name=""/>
+        <p:cNvGrpSpPr/>
+        <p:nvPr/>
+      </p:nvGrpSpPr>
+      <p:grpSpPr/>
+      <p:sp>
+        <p:nvSpPr>
+          <p:cNvPr id="2" name="Rounded Rectangle 1"/>
+          <p:cNvSpPr/>
+          <p:nvPr/>
+        </p:nvSpPr>
+        <p:spPr>
+          <a:xfrm>
+            <a:off x="731520" y="731520"/>
+            <a:ext cx="10728655" cy="5394960"/>
+          </a:xfrm>
+          <a:prstGeom prst="roundRect">
+            <a:avLst/>
+          </a:prstGeom>
+          <a:solidFill>
+            <a:srgbClr val="0F172A"/>
+          </a:solidFill>
+          <a:ln w="31750">
+            <a:solidFill>
+              <a:srgbClr val="10B981"/>
+            </a:solidFill>
+          </a:ln>
+        </p:spPr>
+        <p:style>
+          <a:lnRef idx="1">
+            <a:schemeClr val="accent1"/>
+          </a:lnRef>
+          <a:fillRef idx="3">
+            <a:schemeClr val="accent1"/>
+          </a:fillRef>
+          <a:effectRef idx="2">
+            <a:schemeClr val="accent1"/>
+          </a:effectRef>
+          <a:fontRef idx="minor">
+            <a:schemeClr val="lt1"/>
+          </a:fontRef>
+        </p:style>
+        <p:txBody>
+          <a:bodyPr rtlCol="0" anchor="ctr" wrap="square" lIns="182880" rIns="182880" tIns="182880" bIns="182880"/>
+          <a:lstStyle/>
+          <a:p>
+            <a:pPr algn="ctr">
+              <a:defRPr sz="1500" b="1">
+                <a:solidFill>
+                  <a:srgbClr val="34D399"/>
+                </a:solidFill>
+              </a:defRPr>
+            </a:pPr>
+            <a:r>
+              <a:t>THE NEW PARADIGM: AI FACTORY + AMBIENT CI/CD</a:t>
+            </a:r>
+          </a:p>
+          <a:p>
+            <a:pPr algn="ctr">
+              <a:defRPr sz="2600" b="1">
+                <a:solidFill>
+                  <a:srgbClr val="FFFFFF"/>
+                </a:solidFill>
+              </a:defRPr>
+            </a:pPr>
+            <a:r>
+              <a:t>The AI Factory Builds the Minds. Ambient CI/CD Operates Them.</a:t>
+            </a:r>
+          </a:p>
+          <a:p>
+            <a:br/>
+            <a:pPr algn="ctr">
+              <a:defRPr sz="1150">
+                <a:solidFill>
+                  <a:srgbClr val="94A3B8"/>
+                </a:solidFill>
+              </a:defRPr>
+            </a:pPr>
+            <a:r>
+              <a:t>By unbundling cognition into a 3-tier pyramid, enforcing industrial assembly lines with atomic contracts (&lt;50 lines),</a:t>
+            </a:r>
+            <a:br/>
+            <a:r>
+              <a:t>and bridging design and operations continuously, I have eliminated 88% of human cognitive friction.</a:t>
+            </a:r>
+            <a:br/>
+          </a:p>
+          <a:p>
+            <a:pPr algn="ctr">
+              <a:defRPr sz="1100" b="1">
+                <a:solidFill>
+                  <a:srgbClr val="38BDF8"/>
+                </a:solidFill>
+              </a:defRPr>
+            </a:pPr>
+            <a:r>
+              <a:t>• Live Cloud Studio &amp; CI/CD: cosmosanalytics.github.io/AWS/</a:t>
+            </a:r>
+            <a:br/>
+            <a:r>
+              <a:t>• AI Factory &amp; Assembly Canvas: cosmosanalytics.github.io/uat-copilot-local/</a:t>
+            </a:r>
+            <a:br/>
+            <a:r>
+              <a:t>• Production AWS Project: For Each and Every (us-east-2 • 966273137102)</a:t>
+            </a:r>
+          </a:p>
+        </p:txBody>
+      </p:sp>
+    </p:spTree>
+  </p:cSld>
+  <p:clrMapOvr>
+    <a:masterClrMapping/>
+  </p:clrMapOvr>
+</p:sld>
+</file>
+
 <file path=ppt/slides/slide2.xml><?xml version="1.0" encoding="utf-8"?>
 <p:sld xmlns:a="http://schemas.openxmlformats.org/drawingml/2006/main" xmlns:p="http://schemas.openxmlformats.org/presentationml/2006/main" xmlns:r="http://schemas.openxmlformats.org/officeDocument/2006/relationships">
   <p:cSld>
@@ -5366,7 +5489,7 @@
               </a:defRPr>
             </a:pPr>
             <a:r>
-              <a:t>TECH SHOWCASE</a:t>
+              <a:t>TECH ARCHITECTURE</a:t>
             </a:r>
           </a:p>
         </p:txBody>
@@ -5401,7 +5524,7 @@
               </a:defRPr>
             </a:pPr>
             <a:r>
-              <a:t>Production Tech Stack &amp; Cloud Architecture</a:t>
+              <a:t>Tech Showcase: Dual-Time Scale Architecture</a:t>
             </a:r>
           </a:p>
           <a:p>
@@ -5413,14 +5536,14 @@
               </a:defRPr>
             </a:pPr>
             <a:r>
-              <a:t>Real-world infrastructure connecting client reflex, CI/CD factory, and AWS us-east-2 (966273137102)</a:t>
+              <a:t>AI Factory Design (Assembly + 3-Tier Cognitive Pyramid) &amp; Ambient CI/CD Operation in AWS us-east-2</a:t>
             </a:r>
           </a:p>
         </p:txBody>
       </p:sp>
       <p:pic>
         <p:nvPicPr>
-          <p:cNvPr id="5" name="Picture 4" descr="diag_tech_stack.png"/>
+          <p:cNvPr id="5" name="Picture 4" descr="diag_tech_detailed.png"/>
           <p:cNvPicPr>
             <a:picLocks noChangeAspect="1"/>
           </p:cNvPicPr>
@@ -5435,7 +5558,7 @@
         <p:spPr>
           <a:xfrm>
             <a:off x="731520" y="1234440"/>
-            <a:ext cx="7498079" cy="3854153"/>
+            <a:ext cx="7589520" cy="4146179"/>
           </a:xfrm>
           <a:prstGeom prst="rect">
             <a:avLst/>
@@ -5450,8 +5573,8 @@
         </p:nvSpPr>
         <p:spPr>
           <a:xfrm>
-            <a:off x="8412480" y="1234440"/>
-            <a:ext cx="3047695" cy="5212080"/>
+            <a:off x="8503920" y="1234440"/>
+            <a:ext cx="2956255" cy="5212080"/>
           </a:xfrm>
           <a:prstGeom prst="roundRect">
             <a:avLst/>
@@ -5491,107 +5614,132 @@
               </a:defRPr>
             </a:pPr>
             <a:r>
-              <a:t>Architectural Guarantees</a:t>
+              <a:t>Dual-Scale Guarantees</a:t>
             </a:r>
           </a:p>
           <a:p>
             <a:br/>
             <a:pPr>
-              <a:defRPr b="1" sz="950">
+              <a:defRPr b="1" sz="880">
                 <a:solidFill>
                   <a:srgbClr val="0284C7"/>
                 </a:solidFill>
               </a:defRPr>
             </a:pPr>
             <a:r>
-              <a:t>Client Reflex (L1)</a:t>
-            </a:r>
-          </a:p>
-          <a:p>
-            <a:pPr>
-              <a:defRPr sz="850">
+              <a:t>1. AI Factory Design</a:t>
+            </a:r>
+          </a:p>
+          <a:p>
+            <a:pPr>
+              <a:defRPr sz="780">
                 <a:solidFill>
                   <a:srgbClr val="334155"/>
                 </a:solidFill>
               </a:defRPr>
             </a:pPr>
             <a:r>
-              <a:t>Local WebGPU (WebLLM) and PyScript WASM absorb routine syntax probes in-browser.</a:t>
+              <a:t>Long horizon (hours/days). 7-step assembly protocol builds worker minds from 3-Tier Cognitive BOM with atomic OpenAPI &lt;50-line contracts.</a:t>
             </a:r>
           </a:p>
           <a:p>
             <a:br/>
             <a:pPr>
-              <a:defRPr b="1" sz="950">
+              <a:defRPr b="1" sz="880">
                 <a:solidFill>
                   <a:srgbClr val="7C3AED"/>
                 </a:solidFill>
               </a:defRPr>
             </a:pPr>
             <a:r>
-              <a:t>GitHub Factory (L2)</a:t>
-            </a:r>
-          </a:p>
-          <a:p>
-            <a:pPr>
-              <a:defRPr sz="850">
+              <a:t>2. Git of Minds Consensus</a:t>
+            </a:r>
+          </a:p>
+          <a:p>
+            <a:pPr>
+              <a:defRPr sz="780">
                 <a:solidFill>
                   <a:srgbClr val="334155"/>
                 </a:solidFill>
               </a:defRPr>
             </a:pPr>
             <a:r>
-              <a:t>48/48 CI matrix tests, CodeQL scans, and high-signal PR decision cards.</a:t>
+              <a:t>Dialectical review across Architect, Coder, and Tester. Committed with Ed25519 signing into cosmosanalytics/AWS.</a:t>
             </a:r>
           </a:p>
           <a:p>
             <a:br/>
             <a:pPr>
-              <a:defRPr b="1" sz="950">
+              <a:defRPr b="1" sz="880">
                 <a:solidFill>
                   <a:srgbClr val="059669"/>
                 </a:solidFill>
               </a:defRPr>
             </a:pPr>
             <a:r>
-              <a:t>AWS us-east-2 (L3)</a:t>
-            </a:r>
-          </a:p>
-          <a:p>
-            <a:pPr>
-              <a:defRPr sz="850">
+              <a:t>3. Ambient CI/CD Engine</a:t>
+            </a:r>
+          </a:p>
+          <a:p>
+            <a:pPr>
+              <a:defRPr sz="780">
                 <a:solidFill>
                   <a:srgbClr val="334155"/>
                 </a:solidFill>
               </a:defRPr>
             </a:pPr>
             <a:r>
-              <a:t>Step Functions (cosmos-cicd-ai-pipeline-sfn) executing Lambda &amp; Amazon Bedrock Claude Sonnet 4.6.</a:t>
+              <a:t>Short horizon (ms/sec). Automated 48/48 CI matrix tests + Secret Shield regex scan verify diffs before canary deploy.</a:t>
             </a:r>
           </a:p>
           <a:p>
             <a:br/>
             <a:pPr>
-              <a:defRPr b="1" sz="950">
+              <a:defRPr b="1" sz="880">
                 <a:solidFill>
                   <a:srgbClr val="D97706"/>
                 </a:solidFill>
               </a:defRPr>
             </a:pPr>
             <a:r>
-              <a:t>Durable Security</a:t>
-            </a:r>
-          </a:p>
-          <a:p>
-            <a:pPr>
-              <a:defRPr sz="850">
+              <a:t>4. AWS us-east-2 Runtime</a:t>
+            </a:r>
+          </a:p>
+          <a:p>
+            <a:pPr>
+              <a:defRPr sz="780">
                 <a:solidFill>
                   <a:srgbClr val="334155"/>
                 </a:solidFill>
               </a:defRPr>
             </a:pPr>
             <a:r>
-              <a:t>Amazon S3 KMS encryption with signed execution receipts and atomic rollback.</a:t>
+              <a:t>Live Lambda orchestrator, Step Functions state machine (cosmos-cicd-ai-pipeline-sfn), and Bedrock Claude Sonnet 4.6.</a:t>
+            </a:r>
+          </a:p>
+          <a:p>
+            <a:br/>
+            <a:pPr>
+              <a:defRPr b="1" sz="880">
+                <a:solidFill>
+                  <a:srgbClr val="4338CA"/>
+                </a:solidFill>
+              </a:defRPr>
+            </a:pPr>
+            <a:r>
+              <a:t>5. Closed-Loop Telemetry</a:t>
+            </a:r>
+          </a:p>
+          <a:p>
+            <a:pPr>
+              <a:defRPr sz="780">
+                <a:solidFill>
+                  <a:srgbClr val="334155"/>
+                </a:solidFill>
+              </a:defRPr>
+            </a:pPr>
+            <a:r>
+              <a:t>Circuit breaker trips and CloudWatch logs stream directly back into design as synthetic eval benchmarks.</a:t>
             </a:r>
           </a:p>
         </p:txBody>
@@ -5616,25 +5764,23 @@
       <p:grpSpPr/>
       <p:sp>
         <p:nvSpPr>
-          <p:cNvPr id="2" name="Rounded Rectangle 1"/>
+          <p:cNvPr id="2" name="Rectangle 1"/>
           <p:cNvSpPr/>
           <p:nvPr/>
         </p:nvSpPr>
         <p:spPr>
           <a:xfrm>
-            <a:off x="731520" y="731520"/>
-            <a:ext cx="10728655" cy="5394960"/>
-          </a:xfrm>
-          <a:prstGeom prst="roundRect">
+            <a:off x="0" y="0"/>
+            <a:ext cx="12191695" cy="1051560"/>
+          </a:xfrm>
+          <a:prstGeom prst="rect">
             <a:avLst/>
           </a:prstGeom>
           <a:solidFill>
             <a:srgbClr val="0F172A"/>
           </a:solidFill>
-          <a:ln w="31750">
-            <a:solidFill>
-              <a:srgbClr val="10B981"/>
-            </a:solidFill>
+          <a:ln>
+            <a:noFill/>
           </a:ln>
         </p:spPr>
         <p:style>
@@ -5652,68 +5798,311 @@
           </a:fontRef>
         </p:style>
         <p:txBody>
+          <a:bodyPr rtlCol="0" anchor="ctr"/>
+          <a:lstStyle/>
+          <a:p>
+            <a:pPr algn="ctr"/>
+          </a:p>
+        </p:txBody>
+      </p:sp>
+      <p:sp>
+        <p:nvSpPr>
+          <p:cNvPr id="3" name="Rounded Rectangle 2"/>
+          <p:cNvSpPr/>
+          <p:nvPr/>
+        </p:nvSpPr>
+        <p:spPr>
+          <a:xfrm>
+            <a:off x="731520" y="201168"/>
+            <a:ext cx="1645920" cy="292608"/>
+          </a:xfrm>
+          <a:prstGeom prst="roundRect">
+            <a:avLst/>
+          </a:prstGeom>
+          <a:solidFill>
+            <a:srgbClr val="0284C7"/>
+          </a:solidFill>
+          <a:ln>
+            <a:noFill/>
+          </a:ln>
+        </p:spPr>
+        <p:style>
+          <a:lnRef idx="1">
+            <a:schemeClr val="accent1"/>
+          </a:lnRef>
+          <a:fillRef idx="3">
+            <a:schemeClr val="accent1"/>
+          </a:fillRef>
+          <a:effectRef idx="2">
+            <a:schemeClr val="accent1"/>
+          </a:effectRef>
+          <a:fontRef idx="minor">
+            <a:schemeClr val="lt1"/>
+          </a:fontRef>
+        </p:style>
+        <p:txBody>
           <a:bodyPr rtlCol="0" anchor="ctr" wrap="square" lIns="182880" rIns="182880" tIns="182880" bIns="182880"/>
           <a:lstStyle/>
           <a:p>
             <a:pPr algn="ctr">
-              <a:defRPr sz="1500" b="1">
-                <a:solidFill>
-                  <a:srgbClr val="34D399"/>
-                </a:solidFill>
-              </a:defRPr>
-            </a:pPr>
-            <a:r>
-              <a:t>THE NEW PARADIGM: AI FACTORY + AMBIENT CI/CD</a:t>
-            </a:r>
-          </a:p>
+              <a:defRPr sz="850" b="1">
+                <a:solidFill>
+                  <a:srgbClr val="FFFFFF"/>
+                </a:solidFill>
+              </a:defRPr>
+            </a:pPr>
+            <a:r>
+              <a:t>INTERACTION UI</a:t>
+            </a:r>
+          </a:p>
+        </p:txBody>
+      </p:sp>
+      <p:sp>
+        <p:nvSpPr>
+          <p:cNvPr id="4" name="TextBox 3"/>
+          <p:cNvSpPr txBox="1"/>
+          <p:nvPr/>
+        </p:nvSpPr>
+        <p:spPr>
+          <a:xfrm>
+            <a:off x="2514600" y="109728"/>
+            <a:ext cx="8961120" cy="868680"/>
+          </a:xfrm>
+          <a:prstGeom prst="rect">
+            <a:avLst/>
+          </a:prstGeom>
+          <a:noFill/>
+        </p:spPr>
+        <p:txBody>
+          <a:bodyPr wrap="square" lIns="182880" rIns="182880" bIns="182880">
+            <a:spAutoFit/>
+          </a:bodyPr>
+          <a:lstStyle/>
+          <a:p>
+            <a:pPr>
+              <a:defRPr sz="1700" b="1">
+                <a:solidFill>
+                  <a:srgbClr val="FFFFFF"/>
+                </a:solidFill>
+              </a:defRPr>
+            </a:pPr>
+            <a:r>
+              <a:t>Tech Showcase: AI &amp; Human Interaction UI</a:t>
+            </a:r>
+          </a:p>
+          <a:p>
+            <a:pPr>
+              <a:defRPr sz="950">
+                <a:solidFill>
+                  <a:srgbClr val="94A3B8"/>
+                </a:solidFill>
+              </a:defRPr>
+            </a:pPr>
+            <a:r>
+              <a:t>Ambient by Default, Human by Exception: Fluid Canvas, Dual-Engine Gate, and Reversible Decision Cards</a:t>
+            </a:r>
+          </a:p>
+        </p:txBody>
+      </p:sp>
+      <p:pic>
+        <p:nvPicPr>
+          <p:cNvPr id="5" name="Picture 4" descr="diag_interaction_ui.png"/>
+          <p:cNvPicPr>
+            <a:picLocks noChangeAspect="1"/>
+          </p:cNvPicPr>
+          <p:nvPr/>
+        </p:nvPicPr>
+        <p:blipFill>
+          <a:blip r:embed="rId2"/>
+          <a:stretch>
+            <a:fillRect/>
+          </a:stretch>
+        </p:blipFill>
+        <p:spPr>
+          <a:xfrm>
+            <a:off x="731520" y="1234440"/>
+            <a:ext cx="7589520" cy="4317056"/>
+          </a:xfrm>
+          <a:prstGeom prst="rect">
+            <a:avLst/>
+          </a:prstGeom>
+        </p:spPr>
+      </p:pic>
+      <p:sp>
+        <p:nvSpPr>
+          <p:cNvPr id="6" name="Rounded Rectangle 5"/>
+          <p:cNvSpPr/>
+          <p:nvPr/>
+        </p:nvSpPr>
+        <p:spPr>
+          <a:xfrm>
+            <a:off x="8503920" y="1234440"/>
+            <a:ext cx="2956255" cy="5212080"/>
+          </a:xfrm>
+          <a:prstGeom prst="roundRect">
+            <a:avLst/>
+          </a:prstGeom>
+          <a:solidFill>
+            <a:srgbClr val="F8FAFC"/>
+          </a:solidFill>
+          <a:ln w="19050">
+            <a:solidFill>
+              <a:srgbClr val="7C3AED"/>
+            </a:solidFill>
+          </a:ln>
+        </p:spPr>
+        <p:style>
+          <a:lnRef idx="1">
+            <a:schemeClr val="accent1"/>
+          </a:lnRef>
+          <a:fillRef idx="3">
+            <a:schemeClr val="accent1"/>
+          </a:fillRef>
+          <a:effectRef idx="2">
+            <a:schemeClr val="accent1"/>
+          </a:effectRef>
+          <a:fontRef idx="minor">
+            <a:schemeClr val="lt1"/>
+          </a:fontRef>
+        </p:style>
+        <p:txBody>
+          <a:bodyPr rtlCol="0" anchor="ctr" wrap="square" lIns="182880" rIns="182880" tIns="182880" bIns="182880"/>
+          <a:lstStyle/>
           <a:p>
             <a:pPr algn="ctr">
-              <a:defRPr sz="2600" b="1">
-                <a:solidFill>
-                  <a:srgbClr val="FFFFFF"/>
-                </a:solidFill>
-              </a:defRPr>
-            </a:pPr>
-            <a:r>
-              <a:t>The AI Factory Builds the Minds. Ambient CI/CD Operates Them.</a:t>
+              <a:defRPr b="1" sz="1200">
+                <a:solidFill>
+                  <a:srgbClr val="6D28D9"/>
+                </a:solidFill>
+              </a:defRPr>
+            </a:pPr>
+            <a:r>
+              <a:t>Interaction Ergonomics</a:t>
             </a:r>
           </a:p>
           <a:p>
             <a:br/>
-            <a:pPr algn="ctr">
-              <a:defRPr sz="1150">
-                <a:solidFill>
-                  <a:srgbClr val="94A3B8"/>
-                </a:solidFill>
-              </a:defRPr>
-            </a:pPr>
-            <a:r>
-              <a:t>By unbundling cognition into a 3-tier pyramid, enforcing industrial assembly lines with atomic contracts (&lt;50 lines),</a:t>
-            </a:r>
+            <a:pPr>
+              <a:defRPr b="1" sz="880">
+                <a:solidFill>
+                  <a:srgbClr val="0284C7"/>
+                </a:solidFill>
+              </a:defRPr>
+            </a:pPr>
+            <a:r>
+              <a:t>1. 3-Level Fluid Canvas</a:t>
+            </a:r>
+          </a:p>
+          <a:p>
+            <a:pPr>
+              <a:defRPr sz="780">
+                <a:solidFill>
+                  <a:srgbClr val="334155"/>
+                </a:solidFill>
+              </a:defRPr>
+            </a:pPr>
+            <a:r>
+              <a:t>Interactive zoom/drill-down across Level 1 (Worker Dev Mind), Level 2 (GitHub CI/CD), and Level 3 (AWS Cloud us-east-2).</a:t>
+            </a:r>
+          </a:p>
+          <a:p>
             <a:br/>
-            <a:r>
-              <a:t>and bridging design and operations continuously, I have eliminated 88% of human cognitive friction.</a:t>
-            </a:r>
+            <a:pPr>
+              <a:defRPr b="1" sz="880">
+                <a:solidFill>
+                  <a:srgbClr val="7C3AED"/>
+                </a:solidFill>
+              </a:defRPr>
+            </a:pPr>
+            <a:r>
+              <a:t>2. Dual-Engine Architecture</a:t>
+            </a:r>
+          </a:p>
+          <a:p>
+            <a:pPr>
+              <a:defRPr sz="780">
+                <a:solidFill>
+                  <a:srgbClr val="334155"/>
+                </a:solidFill>
+              </a:defRPr>
+            </a:pPr>
+            <a:r>
+              <a:t>Visitor Mode runs $0 local WebLLM (WebGPU), PyScript WASM, and Groq LPU (~500 tok/s). Owner Mode unlocks live AWS calls via Header Passcode.</a:t>
+            </a:r>
+          </a:p>
+          <a:p>
             <a:br/>
-          </a:p>
-          <a:p>
-            <a:pPr algn="ctr">
-              <a:defRPr sz="1100" b="1">
-                <a:solidFill>
-                  <a:srgbClr val="38BDF8"/>
-                </a:solidFill>
-              </a:defRPr>
-            </a:pPr>
-            <a:r>
-              <a:t>• Live Cloud Studio &amp; CI/CD: cosmosanalytics.github.io/AWS/</a:t>
-            </a:r>
+            <a:pPr>
+              <a:defRPr b="1" sz="880">
+                <a:solidFill>
+                  <a:srgbClr val="059669"/>
+                </a:solidFill>
+              </a:defRPr>
+            </a:pPr>
+            <a:r>
+              <a:t>3. High-Signal Decision Card</a:t>
+            </a:r>
+          </a:p>
+          <a:p>
+            <a:pPr>
+              <a:defRPr sz="780">
+                <a:solidFill>
+                  <a:srgbClr val="334155"/>
+                </a:solidFill>
+              </a:defRPr>
+            </a:pPr>
+            <a:r>
+              <a:t>4-cell PR decision layout: Atomic Intent, Verification Evidence (48/48 CI), Blast Radius &amp; Rollback Recipe, and 1-Click Approval.</a:t>
+            </a:r>
+          </a:p>
+          <a:p>
             <a:br/>
-            <a:r>
-              <a:t>• AI Factory &amp; Assembly Canvas: cosmosanalytics.github.io/uat-copilot-local/</a:t>
-            </a:r>
+            <a:pPr>
+              <a:defRPr b="1" sz="880">
+                <a:solidFill>
+                  <a:srgbClr val="D97706"/>
+                </a:solidFill>
+              </a:defRPr>
+            </a:pPr>
+            <a:r>
+              <a:t>4. One-Button Reversibility</a:t>
+            </a:r>
+          </a:p>
+          <a:p>
+            <a:pPr>
+              <a:defRPr sz="780">
+                <a:solidFill>
+                  <a:srgbClr val="334155"/>
+                </a:solidFill>
+              </a:defRPr>
+            </a:pPr>
+            <a:r>
+              <a:t>Instant rollback of both Git commit and AWS Step Functions state machine in &lt;3 seconds, providing total psychological safety.</a:t>
+            </a:r>
+          </a:p>
+          <a:p>
             <a:br/>
-            <a:r>
-              <a:t>• Production AWS Project: For Each and Every (us-east-2 • 966273137102)</a:t>
+            <a:pPr>
+              <a:defRPr b="1" sz="880">
+                <a:solidFill>
+                  <a:srgbClr val="10B981"/>
+                </a:solidFill>
+              </a:defRPr>
+            </a:pPr>
+            <a:r>
+              <a:t>5. -88% Cognitive Burden</a:t>
+            </a:r>
+          </a:p>
+          <a:p>
+            <a:pPr>
+              <a:defRPr sz="780">
+                <a:solidFill>
+                  <a:srgbClr val="334155"/>
+                </a:solidFill>
+              </a:defRPr>
+            </a:pPr>
+            <a:r>
+              <a:t>Human operator shifts from anxious micromanager to confident director, approving verified cards in &lt;10 seconds.</a:t>
             </a:r>
           </a:p>
         </p:txBody>

</xml_diff>

<commit_message>
docs: Remove visitor mode from AI Journey PPT
</commit_message>
<xml_diff>
--- a/AI_Journey_Single_Agent_to_Ambient_Enterprise.pptx
+++ b/AI_Journey_Single_Agent_to_Ambient_Enterprise.pptx
@@ -5899,7 +5899,7 @@
               </a:defRPr>
             </a:pPr>
             <a:r>
-              <a:t>Ambient by Default, Human by Exception: Fluid Canvas, Dual-Engine Gate, and Reversible Decision Cards</a:t>
+              <a:t>Ambient by Default, Human by Exception: 3-Level Fluid Canvas, Multi-Engine Routing, and Reversible Decision Cards</a:t>
             </a:r>
           </a:p>
         </p:txBody>
@@ -5921,7 +5921,7 @@
         <p:spPr>
           <a:xfrm>
             <a:off x="731520" y="1234440"/>
-            <a:ext cx="7589520" cy="4317056"/>
+            <a:ext cx="7589520" cy="4273852"/>
           </a:xfrm>
           <a:prstGeom prst="rect">
             <a:avLst/>
@@ -6015,7 +6015,7 @@
               </a:defRPr>
             </a:pPr>
             <a:r>
-              <a:t>2. Dual-Engine Architecture</a:t>
+              <a:t>2. Multi-Engine Routing</a:t>
             </a:r>
           </a:p>
           <a:p>
@@ -6027,7 +6027,7 @@
               </a:defRPr>
             </a:pPr>
             <a:r>
-              <a:t>Visitor Mode runs $0 local WebLLM (WebGPU), PyScript WASM, and Groq LPU (~500 tok/s). Owner Mode unlocks live AWS calls via Header Passcode.</a:t>
+              <a:t>Tiered model dispatch: local WebLLM &amp; Groq LPU for sub-second syntactic reflex, and Amazon Bedrock Claude Sonnet 4.6 for deep deliberation.</a:t>
             </a:r>
           </a:p>
           <a:p>

</xml_diff>

<commit_message>
feat: Highlight CI/CD as the continuous engine for Long Time Scale Design and Agent Evolution
</commit_message>
<xml_diff>
--- a/AI_Journey_Single_Agent_to_Ambient_Enterprise.pptx
+++ b/AI_Journey_Single_Agent_to_Ambient_Enterprise.pptx
@@ -4862,7 +4862,7 @@
               </a:defRPr>
             </a:pPr>
             <a:r>
-              <a:t>Bridging the Design Long Time Scale and Operation Short Time Scale without release silos</a:t>
+              <a:t>CI/CD is not just for operational deployment - it is the automated engine for long-scale agent design and evolution</a:t>
             </a:r>
           </a:p>
         </p:txBody>
@@ -4916,7 +4916,7 @@
               </a:defRPr>
             </a:pPr>
             <a:r>
-              <a:t>Two Time Scales, One Loop</a:t>
+              <a:t>CI/CD Drives Both Horizons</a:t>
             </a:r>
           </a:p>
           <a:p>
@@ -4928,7 +4928,7 @@
               </a:defRPr>
             </a:pPr>
             <a:r>
-              <a:t>- Design Long Time Scale: Agents are designed, prompted, tested, and assembled into worker teams. Occurs over hours to days in Git.</a:t>
+              <a:t>- CI/CD in Agent Design: When agent minds, prompts, or roles are redesigned, CI/CD runs automated benchmark matrices, AST invariant linters, and dialectical peer gates in Git.</a:t>
             </a:r>
           </a:p>
           <a:p>
@@ -4940,7 +4940,7 @@
               </a:defRPr>
             </a:pPr>
             <a:r>
-              <a:t>- Operation Short Time Scale: Live events trigger Lambda ingress, Step Functions workflows, and Bedrock inference in milliseconds.</a:t>
+              <a:t>- CI/CD in Agent Operations: Runtime event triggers execute Step Functions and Bedrock in milliseconds with zero manual intervention.</a:t>
             </a:r>
           </a:p>
           <a:p>
@@ -4952,7 +4952,7 @@
               </a:defRPr>
             </a:pPr>
             <a:r>
-              <a:t>- No Dev/QA/Prod Silos: Instead of rigid release freezes, CI/CD runs as a continuous nervous system with automated 48/48 test matrix verification.</a:t>
+              <a:t>- No Dev/QA/Prod Silos: A single continuous nervous system where operational edge cases instantly become Design CI test fixtures.</a:t>
             </a:r>
           </a:p>
           <a:p>
@@ -4964,7 +4964,7 @@
               </a:defRPr>
             </a:pPr>
             <a:r>
-              <a:t>- Human-by-Exception: The pipeline deploys autonomously, pausing only if an architectural invariant or budget limit is breached.</a:t>
+              <a:t>- Human-by-Exception: The pipeline tests and evolves autonomously, pausing only if an architectural invariant or budget limit is breached.</a:t>
             </a:r>
           </a:p>
           <a:p>
@@ -4976,7 +4976,7 @@
               </a:defRPr>
             </a:pPr>
             <a:r>
-              <a:t>- Closed-Loop Feedback: CloudWatch failure telemetry and circuit-breaker trips feed directly back into agent redesign as new evaluation suites.</a:t>
+              <a:t>- Continuous Self-Evolution: Production telemetry and circuit-breaker trips drive synthetic prompt optimization and retraining loops.</a:t>
             </a:r>
           </a:p>
         </p:txBody>
@@ -4998,7 +4998,7 @@
         <p:spPr>
           <a:xfrm>
             <a:off x="4754880" y="1234440"/>
-            <a:ext cx="6705295" cy="4084835"/>
+            <a:ext cx="6705295" cy="4104492"/>
           </a:xfrm>
           <a:prstGeom prst="rect">
             <a:avLst/>
@@ -5524,7 +5524,7 @@
               </a:defRPr>
             </a:pPr>
             <a:r>
-              <a:t>Tech Showcase: Dual-Time Scale Architecture</a:t>
+              <a:t>Tech Showcase: Dual-Scale CI/CD Architecture</a:t>
             </a:r>
           </a:p>
           <a:p>
@@ -5536,7 +5536,7 @@
               </a:defRPr>
             </a:pPr>
             <a:r>
-              <a:t>AI Factory Design (Assembly + 3-Tier Cognitive Pyramid) &amp; Ambient CI/CD Operation in AWS us-east-2</a:t>
+              <a:t>CI/CD in Long-Scale Design (Benchmark Matrix &amp; Agent Evolution) &amp; Short-Scale Operations in AWS us-east-2</a:t>
             </a:r>
           </a:p>
         </p:txBody>
@@ -5558,7 +5558,7 @@
         <p:spPr>
           <a:xfrm>
             <a:off x="731520" y="1234440"/>
-            <a:ext cx="7589520" cy="4146179"/>
+            <a:ext cx="7589520" cy="4086665"/>
           </a:xfrm>
           <a:prstGeom prst="rect">
             <a:avLst/>
@@ -5627,7 +5627,7 @@
               </a:defRPr>
             </a:pPr>
             <a:r>
-              <a:t>1. AI Factory Design</a:t>
+              <a:t>1. Design CI/CD Engine</a:t>
             </a:r>
           </a:p>
           <a:p>
@@ -5639,7 +5639,7 @@
               </a:defRPr>
             </a:pPr>
             <a:r>
-              <a:t>Long horizon (hours/days). 7-step assembly protocol builds worker minds from 3-Tier Cognitive BOM with atomic OpenAPI &lt;50-line contracts.</a:t>
+              <a:t>Automated regression testing on every prompt/role mutation. Verifies 3-Tier Cognitive BOM compliance and Cypher invariants before merge.</a:t>
             </a:r>
           </a:p>
           <a:p>
@@ -5652,7 +5652,7 @@
               </a:defRPr>
             </a:pPr>
             <a:r>
-              <a:t>2. Git of Minds Consensus</a:t>
+              <a:t>2. AI Factory Assembly</a:t>
             </a:r>
           </a:p>
           <a:p>
@@ -5664,7 +5664,7 @@
               </a:defRPr>
             </a:pPr>
             <a:r>
-              <a:t>Dialectical review across Architect, Coder, and Tester. Committed with Ed25519 signing into cosmosanalytics/AWS.</a:t>
+              <a:t>7-step assembly protocol produces certified worker minds with atomic &lt;50-line OpenAPI contracts, eliminating context bloat.</a:t>
             </a:r>
           </a:p>
           <a:p>
@@ -5677,7 +5677,7 @@
               </a:defRPr>
             </a:pPr>
             <a:r>
-              <a:t>3. Ambient CI/CD Engine</a:t>
+              <a:t>3. Operational CI/CD Engine</a:t>
             </a:r>
           </a:p>
           <a:p>
@@ -5689,7 +5689,7 @@
               </a:defRPr>
             </a:pPr>
             <a:r>
-              <a:t>Short horizon (ms/sec). Automated 48/48 CI matrix tests + Secret Shield regex scan verify diffs before canary deploy.</a:t>
+              <a:t>Autonomous continuous canary deployment to AWS us-east-2. 48/48 CI matrix tests + Secret Shield scanners ensure zero-downtime execution.</a:t>
             </a:r>
           </a:p>
           <a:p>
@@ -5702,7 +5702,7 @@
               </a:defRPr>
             </a:pPr>
             <a:r>
-              <a:t>4. AWS us-east-2 Runtime</a:t>
+              <a:t>4. AWS Cloud Runtime</a:t>
             </a:r>
           </a:p>
           <a:p>
@@ -5714,7 +5714,7 @@
               </a:defRPr>
             </a:pPr>
             <a:r>
-              <a:t>Live Lambda orchestrator, Step Functions state machine (cosmos-cicd-ai-pipeline-sfn), and Bedrock Claude Sonnet 4.6.</a:t>
+              <a:t>Lambda orchestrator, Step Functions state machine (cosmos-cicd-ai-pipeline-sfn), and Bedrock Claude Sonnet 4.6.</a:t>
             </a:r>
           </a:p>
           <a:p>
@@ -5727,7 +5727,7 @@
               </a:defRPr>
             </a:pPr>
             <a:r>
-              <a:t>5. Closed-Loop Telemetry</a:t>
+              <a:t>5. Closed-Loop Evolution</a:t>
             </a:r>
           </a:p>
           <a:p>
@@ -5739,7 +5739,7 @@
               </a:defRPr>
             </a:pPr>
             <a:r>
-              <a:t>Circuit breaker trips and CloudWatch logs stream directly back into design as synthetic eval benchmarks.</a:t>
+              <a:t>Circuit breaker trips and CloudWatch failure telemetry feed directly back into Design CI/CD as new synthetic evaluation benchmarks.</a:t>
             </a:r>
           </a:p>
         </p:txBody>

</xml_diff>